<commit_message>
Rename Watchlist per dugout type, update pitch deck
Games get "Backlog" and music gets "Listen Later" instead of a
one-size-fits-all "Watchlist" label across the Dugout status pill,
DetailModal, and the artist page.
</commit_message>
<xml_diff>
--- a/docs/TRACKR Pitchdeck.pptx
+++ b/docs/TRACKR Pitchdeck.pptx
@@ -5,15 +5,18 @@
     <p:sldMasterId id="2147483777" r:id="rId1"/>
   </p:sldMasterIdLst>
   <p:notesMasterIdLst>
-    <p:notesMasterId r:id="rId8"/>
+    <p:notesMasterId r:id="rId11"/>
   </p:notesMasterIdLst>
   <p:sldIdLst>
     <p:sldId id="256" r:id="rId2"/>
     <p:sldId id="257" r:id="rId3"/>
     <p:sldId id="259" r:id="rId4"/>
     <p:sldId id="260" r:id="rId5"/>
-    <p:sldId id="261" r:id="rId6"/>
-    <p:sldId id="258" r:id="rId7"/>
+    <p:sldId id="262" r:id="rId6"/>
+    <p:sldId id="261" r:id="rId7"/>
+    <p:sldId id="263" r:id="rId8"/>
+    <p:sldId id="264" r:id="rId9"/>
+    <p:sldId id="258" r:id="rId10"/>
   </p:sldIdLst>
   <p:sldSz cx="12192000" cy="6858000"/>
   <p:notesSz cx="6858000" cy="9144000"/>
@@ -112,6 +115,11 @@
       </a:defRPr>
     </a:lvl9pPr>
   </p:defaultTextStyle>
+  <p:extLst>
+    <p:ext uri="{EFAFB233-063F-42B5-8137-9DF3F51BA10A}">
+      <p15:sldGuideLst xmlns:p15="http://schemas.microsoft.com/office/powerpoint/2012/main"/>
+    </p:ext>
+  </p:extLst>
 </p:presentation>
 </file>
 
@@ -1024,9 +1032,7 @@
           <a:r>
             <a:rPr lang="en-US" dirty="0">
               <a:solidFill>
-                <a:schemeClr val="tx2">
-                  <a:lumMod val="10000"/>
-                </a:schemeClr>
+                <a:schemeClr val="tx1"/>
               </a:solidFill>
             </a:rPr>
             <a:t>FOLLOW ANYTHING: choose your favorite tv shows, movies, video games, and more and keep up to date with all new releases with ease</a:t>
@@ -1071,9 +1077,7 @@
           <a:r>
             <a:rPr lang="en-US" dirty="0">
               <a:solidFill>
-                <a:schemeClr val="tx2">
-                  <a:lumMod val="10000"/>
-                </a:schemeClr>
+                <a:schemeClr val="tx1"/>
               </a:solidFill>
             </a:rPr>
             <a:t>DISCOVER MORE: explore to see what’s new, or something you may have missed from years ago</a:t>
@@ -1118,9 +1122,7 @@
           <a:r>
             <a:rPr lang="en-US" dirty="0">
               <a:solidFill>
-                <a:schemeClr val="tx2">
-                  <a:lumMod val="10000"/>
-                </a:schemeClr>
+                <a:schemeClr val="tx1"/>
               </a:solidFill>
             </a:rPr>
             <a:t>FORM YOUR DUGOUT: add any items to your watchlist and line up what you looking to do next</a:t>
@@ -1165,7 +1167,16 @@
     </dgm:pt>
     <dgm:pt modelId="{1DFEE864-AC7D-4705-8DF6-AF1484DB0183}" type="pres">
       <dgm:prSet presAssocID="{AB7BB1CF-FEE2-41C6-9127-47A6A4D1D60E}" presName="bgRect" presStyleLbl="bgShp" presStyleIdx="0" presStyleCnt="3"/>
-      <dgm:spPr/>
+      <dgm:spPr>
+        <a:solidFill>
+          <a:srgbClr val="0B0C12"/>
+        </a:solidFill>
+        <a:ln>
+          <a:solidFill>
+            <a:schemeClr val="tx1"/>
+          </a:solidFill>
+        </a:ln>
+      </dgm:spPr>
     </dgm:pt>
     <dgm:pt modelId="{8857E13B-3EF9-4757-9B39-A9E803BF8747}" type="pres">
       <dgm:prSet presAssocID="{AB7BB1CF-FEE2-41C6-9127-47A6A4D1D60E}" presName="iconRect" presStyleLbl="node1" presStyleIdx="0" presStyleCnt="3"/>
@@ -1185,6 +1196,11 @@
             <a:fillRect/>
           </a:stretch>
         </a:blipFill>
+        <a:ln>
+          <a:solidFill>
+            <a:schemeClr val="bg2"/>
+          </a:solidFill>
+        </a:ln>
       </dgm:spPr>
       <dgm:extLst>
         <a:ext uri="{E40237B7-FDA0-4F09-8148-C483321AD2D9}">
@@ -1215,7 +1231,16 @@
     </dgm:pt>
     <dgm:pt modelId="{7421D09D-770C-4F22-BF8A-51A856A48E74}" type="pres">
       <dgm:prSet presAssocID="{B21388B4-2BF5-4879-A0A9-1AFAB7F4EBC7}" presName="bgRect" presStyleLbl="bgShp" presStyleIdx="1" presStyleCnt="3"/>
-      <dgm:spPr/>
+      <dgm:spPr>
+        <a:solidFill>
+          <a:srgbClr val="0B0C12"/>
+        </a:solidFill>
+        <a:ln>
+          <a:solidFill>
+            <a:schemeClr val="tx1"/>
+          </a:solidFill>
+        </a:ln>
+      </dgm:spPr>
     </dgm:pt>
     <dgm:pt modelId="{EFBC3D30-98BF-4B05-856D-846391CD9E55}" type="pres">
       <dgm:prSet presAssocID="{B21388B4-2BF5-4879-A0A9-1AFAB7F4EBC7}" presName="iconRect" presStyleLbl="node1" presStyleIdx="1" presStyleCnt="3"/>
@@ -1235,6 +1260,11 @@
             <a:fillRect/>
           </a:stretch>
         </a:blipFill>
+        <a:ln>
+          <a:solidFill>
+            <a:schemeClr val="bg2"/>
+          </a:solidFill>
+        </a:ln>
       </dgm:spPr>
       <dgm:extLst>
         <a:ext uri="{E40237B7-FDA0-4F09-8148-C483321AD2D9}">
@@ -1265,7 +1295,16 @@
     </dgm:pt>
     <dgm:pt modelId="{A77C85DB-FEF4-4D37-9F86-D3495FDE8B14}" type="pres">
       <dgm:prSet presAssocID="{64E1D5B0-B20A-4064-80ED-C1DE53623A6A}" presName="bgRect" presStyleLbl="bgShp" presStyleIdx="2" presStyleCnt="3"/>
-      <dgm:spPr/>
+      <dgm:spPr>
+        <a:solidFill>
+          <a:srgbClr val="0B0C12"/>
+        </a:solidFill>
+        <a:ln>
+          <a:solidFill>
+            <a:schemeClr val="tx1"/>
+          </a:solidFill>
+        </a:ln>
+      </dgm:spPr>
     </dgm:pt>
     <dgm:pt modelId="{B1DD3873-4AFF-4FE9-A49D-4CB18C323261}" type="pres">
       <dgm:prSet presAssocID="{64E1D5B0-B20A-4064-80ED-C1DE53623A6A}" presName="iconRect" presStyleLbl="node1" presStyleIdx="2" presStyleCnt="3"/>
@@ -1285,6 +1324,11 @@
             <a:fillRect/>
           </a:stretch>
         </a:blipFill>
+        <a:ln>
+          <a:solidFill>
+            <a:schemeClr val="bg2"/>
+          </a:solidFill>
+        </a:ln>
       </dgm:spPr>
       <dgm:extLst>
         <a:ext uri="{E40237B7-FDA0-4F09-8148-C483321AD2D9}">
@@ -1366,16 +1410,12 @@
           </a:avLst>
         </a:prstGeom>
         <a:solidFill>
-          <a:schemeClr val="accent1">
-            <a:tint val="40000"/>
-            <a:hueOff val="0"/>
-            <a:satOff val="0"/>
-            <a:lumOff val="0"/>
-            <a:alphaOff val="0"/>
-          </a:schemeClr>
+          <a:srgbClr val="0B0C12"/>
         </a:solidFill>
         <a:ln>
-          <a:noFill/>
+          <a:solidFill>
+            <a:schemeClr val="tx1"/>
+          </a:solidFill>
         </a:ln>
         <a:effectLst/>
       </dsp:spPr>
@@ -1422,12 +1462,7 @@
         </a:blipFill>
         <a:ln w="12700" cap="flat" cmpd="sng" algn="ctr">
           <a:solidFill>
-            <a:schemeClr val="lt1">
-              <a:hueOff val="0"/>
-              <a:satOff val="0"/>
-              <a:lumOff val="0"/>
-              <a:alphaOff val="0"/>
-            </a:schemeClr>
+            <a:schemeClr val="bg2"/>
           </a:solidFill>
           <a:prstDash val="solid"/>
           <a:miter lim="800000"/>
@@ -1501,9 +1536,7 @@
           <a:r>
             <a:rPr lang="en-US" sz="2500" kern="1200" dirty="0">
               <a:solidFill>
-                <a:schemeClr val="tx2">
-                  <a:lumMod val="10000"/>
-                </a:schemeClr>
+                <a:schemeClr val="tx1"/>
               </a:solidFill>
             </a:rPr>
             <a:t>FOLLOW ANYTHING: choose your favorite tv shows, movies, video games, and more and keep up to date with all new releases with ease</a:t>
@@ -1531,16 +1564,12 @@
           </a:avLst>
         </a:prstGeom>
         <a:solidFill>
-          <a:schemeClr val="accent1">
-            <a:tint val="40000"/>
-            <a:hueOff val="0"/>
-            <a:satOff val="0"/>
-            <a:lumOff val="0"/>
-            <a:alphaOff val="0"/>
-          </a:schemeClr>
+          <a:srgbClr val="0B0C12"/>
         </a:solidFill>
         <a:ln>
-          <a:noFill/>
+          <a:solidFill>
+            <a:schemeClr val="tx1"/>
+          </a:solidFill>
         </a:ln>
         <a:effectLst/>
       </dsp:spPr>
@@ -1587,12 +1616,7 @@
         </a:blipFill>
         <a:ln w="12700" cap="flat" cmpd="sng" algn="ctr">
           <a:solidFill>
-            <a:schemeClr val="lt1">
-              <a:hueOff val="0"/>
-              <a:satOff val="0"/>
-              <a:lumOff val="0"/>
-              <a:alphaOff val="0"/>
-            </a:schemeClr>
+            <a:schemeClr val="bg2"/>
           </a:solidFill>
           <a:prstDash val="solid"/>
           <a:miter lim="800000"/>
@@ -1666,9 +1690,7 @@
           <a:r>
             <a:rPr lang="en-US" sz="2500" kern="1200" dirty="0">
               <a:solidFill>
-                <a:schemeClr val="tx2">
-                  <a:lumMod val="10000"/>
-                </a:schemeClr>
+                <a:schemeClr val="tx1"/>
               </a:solidFill>
             </a:rPr>
             <a:t>DISCOVER MORE: explore to see what’s new, or something you may have missed from years ago</a:t>
@@ -1696,16 +1718,12 @@
           </a:avLst>
         </a:prstGeom>
         <a:solidFill>
-          <a:schemeClr val="accent1">
-            <a:tint val="40000"/>
-            <a:hueOff val="0"/>
-            <a:satOff val="0"/>
-            <a:lumOff val="0"/>
-            <a:alphaOff val="0"/>
-          </a:schemeClr>
+          <a:srgbClr val="0B0C12"/>
         </a:solidFill>
         <a:ln>
-          <a:noFill/>
+          <a:solidFill>
+            <a:schemeClr val="tx1"/>
+          </a:solidFill>
         </a:ln>
         <a:effectLst/>
       </dsp:spPr>
@@ -1752,12 +1770,7 @@
         </a:blipFill>
         <a:ln w="12700" cap="flat" cmpd="sng" algn="ctr">
           <a:solidFill>
-            <a:schemeClr val="lt1">
-              <a:hueOff val="0"/>
-              <a:satOff val="0"/>
-              <a:lumOff val="0"/>
-              <a:alphaOff val="0"/>
-            </a:schemeClr>
+            <a:schemeClr val="bg2"/>
           </a:solidFill>
           <a:prstDash val="solid"/>
           <a:miter lim="800000"/>
@@ -1831,9 +1844,7 @@
           <a:r>
             <a:rPr lang="en-US" sz="2500" kern="1200" dirty="0">
               <a:solidFill>
-                <a:schemeClr val="tx2">
-                  <a:lumMod val="10000"/>
-                </a:schemeClr>
+                <a:schemeClr val="tx1"/>
               </a:solidFill>
             </a:rPr>
             <a:t>FORM YOUR DUGOUT: add any items to your watchlist and line up what you looking to do next</a:t>
@@ -3259,7 +3270,7 @@
           <a:p>
             <a:fld id="{0046FE89-E818-47F4-8451-E5577C95B5C1}" type="datetimeFigureOut">
               <a:rPr lang="en-US" smtClean="0"/>
-              <a:t>8/3/2026</a:t>
+              <a:t>8/10/2026</a:t>
             </a:fld>
             <a:endParaRPr lang="en-US"/>
           </a:p>
@@ -3839,7 +3850,7 @@
           <a:p>
             <a:fld id="{7D31F0D8-39C5-4C77-A52E-168D39363794}" type="datetimeFigureOut">
               <a:rPr lang="en-US" smtClean="0"/>
-              <a:t>8/3/2026</a:t>
+              <a:t>8/10/2026</a:t>
             </a:fld>
             <a:endParaRPr lang="en-US"/>
           </a:p>
@@ -4001,7 +4012,7 @@
           <a:p>
             <a:fld id="{7D31F0D8-39C5-4C77-A52E-168D39363794}" type="datetimeFigureOut">
               <a:rPr lang="en-US" smtClean="0"/>
-              <a:t>8/3/2026</a:t>
+              <a:t>8/10/2026</a:t>
             </a:fld>
             <a:endParaRPr lang="en-US"/>
           </a:p>
@@ -4481,7 +4492,7 @@
           <a:p>
             <a:fld id="{7D31F0D8-39C5-4C77-A52E-168D39363794}" type="datetimeFigureOut">
               <a:rPr lang="en-US" smtClean="0"/>
-              <a:t>8/3/2026</a:t>
+              <a:t>8/10/2026</a:t>
             </a:fld>
             <a:endParaRPr lang="en-US"/>
           </a:p>
@@ -4798,7 +4809,7 @@
           <a:p>
             <a:fld id="{7D31F0D8-39C5-4C77-A52E-168D39363794}" type="datetimeFigureOut">
               <a:rPr lang="en-US" smtClean="0"/>
-              <a:t>8/3/2026</a:t>
+              <a:t>8/10/2026</a:t>
             </a:fld>
             <a:endParaRPr lang="en-US"/>
           </a:p>
@@ -5146,7 +5157,7 @@
           <a:p>
             <a:fld id="{7D31F0D8-39C5-4C77-A52E-168D39363794}" type="datetimeFigureOut">
               <a:rPr lang="en-US" smtClean="0"/>
-              <a:t>8/3/2026</a:t>
+              <a:t>8/10/2026</a:t>
             </a:fld>
             <a:endParaRPr lang="en-US"/>
           </a:p>
@@ -5433,7 +5444,7 @@
           <a:p>
             <a:fld id="{7D31F0D8-39C5-4C77-A52E-168D39363794}" type="datetimeFigureOut">
               <a:rPr lang="en-US" smtClean="0"/>
-              <a:t>8/3/2026</a:t>
+              <a:t>8/10/2026</a:t>
             </a:fld>
             <a:endParaRPr lang="en-US"/>
           </a:p>
@@ -5887,7 +5898,7 @@
           <a:p>
             <a:fld id="{7D31F0D8-39C5-4C77-A52E-168D39363794}" type="datetimeFigureOut">
               <a:rPr lang="en-US" smtClean="0"/>
-              <a:t>8/3/2026</a:t>
+              <a:t>8/10/2026</a:t>
             </a:fld>
             <a:endParaRPr lang="en-US"/>
           </a:p>
@@ -6483,7 +6494,7 @@
           <a:p>
             <a:fld id="{7D31F0D8-39C5-4C77-A52E-168D39363794}" type="datetimeFigureOut">
               <a:rPr lang="en-US" smtClean="0"/>
-              <a:t>8/3/2026</a:t>
+              <a:t>8/10/2026</a:t>
             </a:fld>
             <a:endParaRPr lang="en-US"/>
           </a:p>
@@ -6695,7 +6706,7 @@
           <a:p>
             <a:fld id="{7D31F0D8-39C5-4C77-A52E-168D39363794}" type="datetimeFigureOut">
               <a:rPr lang="en-US" smtClean="0"/>
-              <a:t>8/3/2026</a:t>
+              <a:t>8/10/2026</a:t>
             </a:fld>
             <a:endParaRPr lang="en-US"/>
           </a:p>
@@ -7169,7 +7180,7 @@
           <a:p>
             <a:fld id="{7D31F0D8-39C5-4C77-A52E-168D39363794}" type="datetimeFigureOut">
               <a:rPr lang="en-US" smtClean="0"/>
-              <a:t>8/3/2026</a:t>
+              <a:t>8/10/2026</a:t>
             </a:fld>
             <a:endParaRPr lang="en-US"/>
           </a:p>
@@ -7458,7 +7469,7 @@
           <a:p>
             <a:fld id="{7D31F0D8-39C5-4C77-A52E-168D39363794}" type="datetimeFigureOut">
               <a:rPr lang="en-US" smtClean="0"/>
-              <a:t>8/3/2026</a:t>
+              <a:t>8/10/2026</a:t>
             </a:fld>
             <a:endParaRPr lang="en-US"/>
           </a:p>
@@ -7721,7 +7732,7 @@
           <a:p>
             <a:fld id="{7D31F0D8-39C5-4C77-A52E-168D39363794}" type="datetimeFigureOut">
               <a:rPr lang="en-US" smtClean="0"/>
-              <a:t>8/3/2026</a:t>
+              <a:t>8/10/2026</a:t>
             </a:fld>
             <a:endParaRPr lang="en-US"/>
           </a:p>
@@ -8344,7 +8355,7 @@
           <a:p>
             <a:fld id="{7D31F0D8-39C5-4C77-A52E-168D39363794}" type="datetimeFigureOut">
               <a:rPr lang="en-US" smtClean="0"/>
-              <a:t>8/3/2026</a:t>
+              <a:t>8/10/2026</a:t>
             </a:fld>
             <a:endParaRPr lang="en-US"/>
           </a:p>
@@ -8921,7 +8932,7 @@
           <a:p>
             <a:fld id="{7D31F0D8-39C5-4C77-A52E-168D39363794}" type="datetimeFigureOut">
               <a:rPr lang="en-US" smtClean="0"/>
-              <a:t>8/3/2026</a:t>
+              <a:t>8/10/2026</a:t>
             </a:fld>
             <a:endParaRPr lang="en-US"/>
           </a:p>
@@ -9259,7 +9270,7 @@
           <a:p>
             <a:fld id="{7D31F0D8-39C5-4C77-A52E-168D39363794}" type="datetimeFigureOut">
               <a:rPr lang="en-US" smtClean="0"/>
-              <a:t>8/3/2026</a:t>
+              <a:t>8/10/2026</a:t>
             </a:fld>
             <a:endParaRPr lang="en-US"/>
           </a:p>
@@ -9814,7 +9825,7 @@
           <a:p>
             <a:fld id="{7D31F0D8-39C5-4C77-A52E-168D39363794}" type="datetimeFigureOut">
               <a:rPr lang="en-US" smtClean="0"/>
-              <a:t>8/3/2026</a:t>
+              <a:t>8/10/2026</a:t>
             </a:fld>
             <a:endParaRPr lang="en-US"/>
           </a:p>
@@ -10053,7 +10064,7 @@
           <a:p>
             <a:fld id="{7D31F0D8-39C5-4C77-A52E-168D39363794}" type="datetimeFigureOut">
               <a:rPr lang="en-US" smtClean="0"/>
-              <a:t>8/3/2026</a:t>
+              <a:t>8/10/2026</a:t>
             </a:fld>
             <a:endParaRPr lang="en-US"/>
           </a:p>
@@ -10442,7 +10453,7 @@
           <a:p>
             <a:fld id="{7D31F0D8-39C5-4C77-A52E-168D39363794}" type="datetimeFigureOut">
               <a:rPr lang="en-US" smtClean="0"/>
-              <a:t>8/3/2026</a:t>
+              <a:t>8/10/2026</a:t>
             </a:fld>
             <a:endParaRPr lang="en-US"/>
           </a:p>
@@ -10975,7 +10986,7 @@
           <a:p>
             <a:fld id="{7D31F0D8-39C5-4C77-A52E-168D39363794}" type="datetimeFigureOut">
               <a:rPr lang="en-US" smtClean="0"/>
-              <a:t>8/3/2026</a:t>
+              <a:t>8/10/2026</a:t>
             </a:fld>
             <a:endParaRPr lang="en-US"/>
           </a:p>
@@ -11088,7 +11099,7 @@
           <a:p>
             <a:fld id="{7D31F0D8-39C5-4C77-A52E-168D39363794}" type="datetimeFigureOut">
               <a:rPr lang="en-US" smtClean="0"/>
-              <a:t>8/3/2026</a:t>
+              <a:t>8/10/2026</a:t>
             </a:fld>
             <a:endParaRPr lang="en-US"/>
           </a:p>
@@ -11389,7 +11400,7 @@
           <a:p>
             <a:fld id="{7D31F0D8-39C5-4C77-A52E-168D39363794}" type="datetimeFigureOut">
               <a:rPr lang="en-US" smtClean="0"/>
-              <a:t>8/3/2026</a:t>
+              <a:t>8/10/2026</a:t>
             </a:fld>
             <a:endParaRPr lang="en-US"/>
           </a:p>
@@ -11603,7 +11614,7 @@
           <a:p>
             <a:fld id="{7D31F0D8-39C5-4C77-A52E-168D39363794}" type="datetimeFigureOut">
               <a:rPr lang="en-US" smtClean="0"/>
-              <a:t>8/3/2026</a:t>
+              <a:t>8/10/2026</a:t>
             </a:fld>
             <a:endParaRPr lang="en-US"/>
           </a:p>
@@ -12105,7 +12116,7 @@
           <a:p>
             <a:fld id="{7D31F0D8-39C5-4C77-A52E-168D39363794}" type="datetimeFigureOut">
               <a:rPr lang="en-US" smtClean="0"/>
-              <a:t>8/3/2026</a:t>
+              <a:t>8/10/2026</a:t>
             </a:fld>
             <a:endParaRPr lang="en-US"/>
           </a:p>
@@ -12529,7 +12540,7 @@
           <a:p>
             <a:fld id="{7D31F0D8-39C5-4C77-A52E-168D39363794}" type="datetimeFigureOut">
               <a:rPr lang="en-US" smtClean="0"/>
-              <a:t>8/3/2026</a:t>
+              <a:t>8/10/2026</a:t>
             </a:fld>
             <a:endParaRPr lang="en-US"/>
           </a:p>
@@ -13072,7 +13083,7 @@
           <a:p>
             <a:fld id="{7D31F0D8-39C5-4C77-A52E-168D39363794}" type="datetimeFigureOut">
               <a:rPr lang="en-US" smtClean="0"/>
-              <a:t>8/3/2026</a:t>
+              <a:t>8/10/2026</a:t>
             </a:fld>
             <a:endParaRPr lang="en-US"/>
           </a:p>
@@ -13794,7 +13805,7 @@
           <a:p>
             <a:fld id="{7D31F0D8-39C5-4C77-A52E-168D39363794}" type="datetimeFigureOut">
               <a:rPr lang="en-US" smtClean="0"/>
-              <a:t>8/3/2026</a:t>
+              <a:t>8/10/2026</a:t>
             </a:fld>
             <a:endParaRPr lang="en-US"/>
           </a:p>
@@ -14162,7 +14173,7 @@
           <a:p>
             <a:fld id="{7D31F0D8-39C5-4C77-A52E-168D39363794}" type="datetimeFigureOut">
               <a:rPr lang="en-US" smtClean="0"/>
-              <a:t>8/3/2026</a:t>
+              <a:t>8/10/2026</a:t>
             </a:fld>
             <a:endParaRPr lang="en-US"/>
           </a:p>
@@ -14405,7 +14416,7 @@
           <a:p>
             <a:fld id="{7D31F0D8-39C5-4C77-A52E-168D39363794}" type="datetimeFigureOut">
               <a:rPr lang="en-US" smtClean="0"/>
-              <a:t>8/3/2026</a:t>
+              <a:t>8/10/2026</a:t>
             </a:fld>
             <a:endParaRPr lang="en-US"/>
           </a:p>
@@ -15785,6 +15796,261 @@
           <p:cNvPr id="2" name="Title 1">
             <a:extLst>
               <a:ext uri="{FF2B5EF4-FFF2-40B4-BE49-F238E27FC236}">
+                <a16:creationId xmlns:a16="http://schemas.microsoft.com/office/drawing/2014/main" id="{07CBDF1C-6F0C-9506-E8B6-B4C5C2FDF3FF}"/>
+              </a:ext>
+            </a:extLst>
+          </p:cNvPr>
+          <p:cNvSpPr>
+            <a:spLocks noGrp="1"/>
+          </p:cNvSpPr>
+          <p:nvPr>
+            <p:ph type="title"/>
+          </p:nvPr>
+        </p:nvSpPr>
+        <p:spPr/>
+        <p:txBody>
+          <a:bodyPr>
+            <a:normAutofit/>
+          </a:bodyPr>
+          <a:lstStyle/>
+          <a:p>
+            <a:r>
+              <a:rPr lang="en-US" sz="3600" dirty="0"/>
+              <a:t>Compliment, not Competition</a:t>
+            </a:r>
+          </a:p>
+        </p:txBody>
+      </p:sp>
+      <p:sp>
+        <p:nvSpPr>
+          <p:cNvPr id="3" name="Text Placeholder 2">
+            <a:extLst>
+              <a:ext uri="{FF2B5EF4-FFF2-40B4-BE49-F238E27FC236}">
+                <a16:creationId xmlns:a16="http://schemas.microsoft.com/office/drawing/2014/main" id="{796D21AF-CEEF-6F4B-7619-95C09F2FAB86}"/>
+              </a:ext>
+            </a:extLst>
+          </p:cNvPr>
+          <p:cNvSpPr>
+            <a:spLocks noGrp="1"/>
+          </p:cNvSpPr>
+          <p:nvPr>
+            <p:ph type="body" idx="1"/>
+          </p:nvPr>
+        </p:nvSpPr>
+        <p:spPr/>
+        <p:txBody>
+          <a:bodyPr>
+            <a:normAutofit/>
+          </a:bodyPr>
+          <a:lstStyle/>
+          <a:p>
+            <a:r>
+              <a:rPr lang="en-US" sz="2400" dirty="0"/>
+              <a:t>Trackr</a:t>
+            </a:r>
+          </a:p>
+        </p:txBody>
+      </p:sp>
+      <p:sp>
+        <p:nvSpPr>
+          <p:cNvPr id="4" name="Content Placeholder 3">
+            <a:extLst>
+              <a:ext uri="{FF2B5EF4-FFF2-40B4-BE49-F238E27FC236}">
+                <a16:creationId xmlns:a16="http://schemas.microsoft.com/office/drawing/2014/main" id="{681C0A33-C56B-784B-F8F4-8ABACB07474A}"/>
+              </a:ext>
+            </a:extLst>
+          </p:cNvPr>
+          <p:cNvSpPr>
+            <a:spLocks noGrp="1"/>
+          </p:cNvSpPr>
+          <p:nvPr>
+            <p:ph sz="quarter" idx="18"/>
+          </p:nvPr>
+        </p:nvSpPr>
+        <p:spPr/>
+        <p:txBody>
+          <a:bodyPr>
+            <a:normAutofit/>
+          </a:bodyPr>
+          <a:lstStyle/>
+          <a:p>
+            <a:pPr marL="285750" indent="-285750">
+              <a:buFont typeface="Arial" panose="020B0604020202020204" pitchFamily="34" charset="0"/>
+              <a:buChar char="•"/>
+            </a:pPr>
+            <a:r>
+              <a:rPr lang="en-US" sz="2000" dirty="0"/>
+              <a:t>Tracking what you want to watch next</a:t>
+            </a:r>
+          </a:p>
+          <a:p>
+            <a:pPr marL="285750" indent="-285750">
+              <a:buFont typeface="Arial" panose="020B0604020202020204" pitchFamily="34" charset="0"/>
+              <a:buChar char="•"/>
+            </a:pPr>
+            <a:r>
+              <a:rPr lang="en-US" sz="2000" dirty="0"/>
+              <a:t>Multiple media types</a:t>
+            </a:r>
+          </a:p>
+          <a:p>
+            <a:pPr marL="285750" indent="-285750">
+              <a:buFont typeface="Arial" panose="020B0604020202020204" pitchFamily="34" charset="0"/>
+              <a:buChar char="•"/>
+            </a:pPr>
+            <a:r>
+              <a:rPr lang="en-US" sz="2000" dirty="0"/>
+              <a:t>Notifications for new releases</a:t>
+            </a:r>
+          </a:p>
+          <a:p>
+            <a:pPr marL="285750" indent="-285750">
+              <a:buFont typeface="Arial" panose="020B0604020202020204" pitchFamily="34" charset="0"/>
+              <a:buChar char="•"/>
+            </a:pPr>
+            <a:r>
+              <a:rPr lang="en-US" sz="2000" dirty="0"/>
+              <a:t>Can be used alongside other social platforms</a:t>
+            </a:r>
+          </a:p>
+        </p:txBody>
+      </p:sp>
+      <p:sp>
+        <p:nvSpPr>
+          <p:cNvPr id="5" name="Text Placeholder 4">
+            <a:extLst>
+              <a:ext uri="{FF2B5EF4-FFF2-40B4-BE49-F238E27FC236}">
+                <a16:creationId xmlns:a16="http://schemas.microsoft.com/office/drawing/2014/main" id="{8E0D72AB-82DA-C189-C6DC-34D2A11436ED}"/>
+              </a:ext>
+            </a:extLst>
+          </p:cNvPr>
+          <p:cNvSpPr>
+            <a:spLocks noGrp="1"/>
+          </p:cNvSpPr>
+          <p:nvPr>
+            <p:ph type="body" sz="quarter" idx="3"/>
+          </p:nvPr>
+        </p:nvSpPr>
+        <p:spPr/>
+        <p:txBody>
+          <a:bodyPr>
+            <a:normAutofit/>
+          </a:bodyPr>
+          <a:lstStyle/>
+          <a:p>
+            <a:r>
+              <a:rPr lang="en-US" sz="2400" dirty="0"/>
+              <a:t>Letterboxd and Others</a:t>
+            </a:r>
+          </a:p>
+        </p:txBody>
+      </p:sp>
+      <p:sp>
+        <p:nvSpPr>
+          <p:cNvPr id="6" name="Content Placeholder 5">
+            <a:extLst>
+              <a:ext uri="{FF2B5EF4-FFF2-40B4-BE49-F238E27FC236}">
+                <a16:creationId xmlns:a16="http://schemas.microsoft.com/office/drawing/2014/main" id="{C4CD8094-A248-C70D-66FF-90A926945558}"/>
+              </a:ext>
+            </a:extLst>
+          </p:cNvPr>
+          <p:cNvSpPr>
+            <a:spLocks noGrp="1"/>
+          </p:cNvSpPr>
+          <p:nvPr>
+            <p:ph sz="quarter" idx="19"/>
+          </p:nvPr>
+        </p:nvSpPr>
+        <p:spPr/>
+        <p:txBody>
+          <a:bodyPr>
+            <a:normAutofit/>
+          </a:bodyPr>
+          <a:lstStyle/>
+          <a:p>
+            <a:pPr marL="285750" indent="-285750">
+              <a:buFont typeface="Arial" panose="020B0604020202020204" pitchFamily="34" charset="0"/>
+              <a:buChar char="•"/>
+            </a:pPr>
+            <a:r>
+              <a:rPr lang="en-US" sz="2000" dirty="0"/>
+              <a:t>Tracking what you’ve already watched</a:t>
+            </a:r>
+          </a:p>
+          <a:p>
+            <a:pPr marL="285750" indent="-285750">
+              <a:buFont typeface="Arial" panose="020B0604020202020204" pitchFamily="34" charset="0"/>
+              <a:buChar char="•"/>
+            </a:pPr>
+            <a:r>
+              <a:rPr lang="en-US" sz="2000" dirty="0"/>
+              <a:t>Focus on one media type</a:t>
+            </a:r>
+          </a:p>
+          <a:p>
+            <a:pPr marL="285750" indent="-285750">
+              <a:buFont typeface="Arial" panose="020B0604020202020204" pitchFamily="34" charset="0"/>
+              <a:buChar char="•"/>
+            </a:pPr>
+            <a:r>
+              <a:rPr lang="en-US" sz="2000" dirty="0"/>
+              <a:t>No way to track new releases</a:t>
+            </a:r>
+          </a:p>
+          <a:p>
+            <a:pPr marL="285750" indent="-285750">
+              <a:buFont typeface="Arial" panose="020B0604020202020204" pitchFamily="34" charset="0"/>
+              <a:buChar char="•"/>
+            </a:pPr>
+            <a:r>
+              <a:rPr lang="en-US" sz="2000" dirty="0"/>
+              <a:t>Media tracking as a social media</a:t>
+            </a:r>
+          </a:p>
+          <a:p>
+            <a:pPr marL="285750" indent="-285750">
+              <a:buFont typeface="Arial" panose="020B0604020202020204" pitchFamily="34" charset="0"/>
+              <a:buChar char="•"/>
+            </a:pPr>
+            <a:endParaRPr lang="en-US" sz="2000" dirty="0"/>
+          </a:p>
+        </p:txBody>
+      </p:sp>
+    </p:spTree>
+    <p:extLst>
+      <p:ext uri="{BB962C8B-B14F-4D97-AF65-F5344CB8AC3E}">
+        <p14:creationId xmlns:p14="http://schemas.microsoft.com/office/powerpoint/2010/main" val="2107956701"/>
+      </p:ext>
+    </p:extLst>
+  </p:cSld>
+  <p:clrMapOvr>
+    <a:masterClrMapping/>
+  </p:clrMapOvr>
+</p:sld>
+</file>
+
+<file path=ppt/slides/slide6.xml><?xml version="1.0" encoding="utf-8"?>
+<p:sld xmlns:a="http://schemas.openxmlformats.org/drawingml/2006/main" xmlns:r="http://schemas.openxmlformats.org/officeDocument/2006/relationships" xmlns:p="http://schemas.openxmlformats.org/presentationml/2006/main">
+  <p:cSld>
+    <p:spTree>
+      <p:nvGrpSpPr>
+        <p:cNvPr id="1" name=""/>
+        <p:cNvGrpSpPr/>
+        <p:nvPr/>
+      </p:nvGrpSpPr>
+      <p:grpSpPr>
+        <a:xfrm>
+          <a:off x="0" y="0"/>
+          <a:ext cx="0" cy="0"/>
+          <a:chOff x="0" y="0"/>
+          <a:chExt cx="0" cy="0"/>
+        </a:xfrm>
+      </p:grpSpPr>
+      <p:sp>
+        <p:nvSpPr>
+          <p:cNvPr id="2" name="Title 1">
+            <a:extLst>
+              <a:ext uri="{FF2B5EF4-FFF2-40B4-BE49-F238E27FC236}">
                 <a16:creationId xmlns:a16="http://schemas.microsoft.com/office/drawing/2014/main" id="{55B010EC-0823-638A-A54B-085573D0CAFC}"/>
               </a:ext>
             </a:extLst>
@@ -15809,7 +16075,7 @@
           <a:lstStyle/>
           <a:p>
             <a:r>
-              <a:rPr lang="en-US"/>
+              <a:rPr lang="en-US" sz="4000" dirty="0"/>
               <a:t>Primary Features</a:t>
             </a:r>
           </a:p>
@@ -15831,7 +16097,7 @@
             <p:ph sz="quarter" idx="13"/>
             <p:extLst>
               <p:ext uri="{D42A27DB-BD31-4B8C-83A1-F6EECF244321}">
-                <p14:modId xmlns:p14="http://schemas.microsoft.com/office/powerpoint/2010/main" val="1009906997"/>
+                <p14:modId xmlns:p14="http://schemas.microsoft.com/office/powerpoint/2010/main" val="1066573651"/>
               </p:ext>
             </p:extLst>
           </p:nvPr>
@@ -15859,7 +16125,841 @@
 </p:sld>
 </file>
 
-<file path=ppt/slides/slide6.xml><?xml version="1.0" encoding="utf-8"?>
+<file path=ppt/slides/slide7.xml><?xml version="1.0" encoding="utf-8"?>
+<p:sld xmlns:a="http://schemas.openxmlformats.org/drawingml/2006/main" xmlns:r="http://schemas.openxmlformats.org/officeDocument/2006/relationships" xmlns:p="http://schemas.openxmlformats.org/presentationml/2006/main">
+  <p:cSld>
+    <p:spTree>
+      <p:nvGrpSpPr>
+        <p:cNvPr id="1" name=""/>
+        <p:cNvGrpSpPr/>
+        <p:nvPr/>
+      </p:nvGrpSpPr>
+      <p:grpSpPr>
+        <a:xfrm>
+          <a:off x="0" y="0"/>
+          <a:ext cx="0" cy="0"/>
+          <a:chOff x="0" y="0"/>
+          <a:chExt cx="0" cy="0"/>
+        </a:xfrm>
+      </p:grpSpPr>
+      <p:sp>
+        <p:nvSpPr>
+          <p:cNvPr id="2" name="Title 1">
+            <a:extLst>
+              <a:ext uri="{FF2B5EF4-FFF2-40B4-BE49-F238E27FC236}">
+                <a16:creationId xmlns:a16="http://schemas.microsoft.com/office/drawing/2014/main" id="{250FBDB4-FBB3-5E4E-871F-18ADDC9305DF}"/>
+              </a:ext>
+            </a:extLst>
+          </p:cNvPr>
+          <p:cNvSpPr>
+            <a:spLocks noGrp="1"/>
+          </p:cNvSpPr>
+          <p:nvPr>
+            <p:ph type="title"/>
+          </p:nvPr>
+        </p:nvSpPr>
+        <p:spPr/>
+        <p:txBody>
+          <a:bodyPr>
+            <a:normAutofit/>
+          </a:bodyPr>
+          <a:lstStyle/>
+          <a:p>
+            <a:r>
+              <a:rPr lang="en-US" sz="4400" dirty="0"/>
+              <a:t>Business Model</a:t>
+            </a:r>
+          </a:p>
+        </p:txBody>
+      </p:sp>
+      <p:sp>
+        <p:nvSpPr>
+          <p:cNvPr id="11" name="Text Placeholder 10">
+            <a:extLst>
+              <a:ext uri="{FF2B5EF4-FFF2-40B4-BE49-F238E27FC236}">
+                <a16:creationId xmlns:a16="http://schemas.microsoft.com/office/drawing/2014/main" id="{A866AA53-AF0F-D8E5-1920-897F46931FBE}"/>
+              </a:ext>
+            </a:extLst>
+          </p:cNvPr>
+          <p:cNvSpPr>
+            <a:spLocks noGrp="1"/>
+          </p:cNvSpPr>
+          <p:nvPr>
+            <p:ph type="body" idx="1"/>
+          </p:nvPr>
+        </p:nvSpPr>
+        <p:spPr/>
+        <p:txBody>
+          <a:bodyPr>
+            <a:normAutofit/>
+          </a:bodyPr>
+          <a:lstStyle/>
+          <a:p>
+            <a:r>
+              <a:rPr lang="en-US" sz="2800" dirty="0"/>
+              <a:t>Free Tier</a:t>
+            </a:r>
+          </a:p>
+        </p:txBody>
+      </p:sp>
+      <p:sp>
+        <p:nvSpPr>
+          <p:cNvPr id="13" name="Content Placeholder 12">
+            <a:extLst>
+              <a:ext uri="{FF2B5EF4-FFF2-40B4-BE49-F238E27FC236}">
+                <a16:creationId xmlns:a16="http://schemas.microsoft.com/office/drawing/2014/main" id="{EF4948EB-F8E8-F5D1-7C93-1CF2B021E895}"/>
+              </a:ext>
+            </a:extLst>
+          </p:cNvPr>
+          <p:cNvSpPr>
+            <a:spLocks noGrp="1"/>
+          </p:cNvSpPr>
+          <p:nvPr>
+            <p:ph sz="quarter" idx="18"/>
+          </p:nvPr>
+        </p:nvSpPr>
+        <p:spPr>
+          <a:xfrm>
+            <a:off x="301625" y="2587753"/>
+            <a:ext cx="5165725" cy="3805110"/>
+          </a:xfrm>
+        </p:spPr>
+        <p:txBody>
+          <a:bodyPr>
+            <a:normAutofit/>
+          </a:bodyPr>
+          <a:lstStyle/>
+          <a:p>
+            <a:pPr marL="285750" indent="-285750">
+              <a:buFont typeface="Arial" panose="020B0604020202020204" pitchFamily="34" charset="0"/>
+              <a:buChar char="•"/>
+            </a:pPr>
+            <a:r>
+              <a:rPr lang="en-US" sz="1800" dirty="0"/>
+              <a:t>Access to basic tracking features</a:t>
+            </a:r>
+          </a:p>
+          <a:p>
+            <a:pPr marL="285750" indent="-285750">
+              <a:buFont typeface="Arial" panose="020B0604020202020204" pitchFamily="34" charset="0"/>
+              <a:buChar char="•"/>
+            </a:pPr>
+            <a:r>
+              <a:rPr lang="en-US" sz="1800" dirty="0"/>
+              <a:t>Full discover page access to track any media items</a:t>
+            </a:r>
+          </a:p>
+          <a:p>
+            <a:pPr marL="285750" indent="-285750">
+              <a:buFont typeface="Arial" panose="020B0604020202020204" pitchFamily="34" charset="0"/>
+              <a:buChar char="•"/>
+            </a:pPr>
+            <a:r>
+              <a:rPr lang="en-US" sz="1800" dirty="0"/>
+              <a:t>Ability to view calendar page on site</a:t>
+            </a:r>
+          </a:p>
+        </p:txBody>
+      </p:sp>
+      <p:sp>
+        <p:nvSpPr>
+          <p:cNvPr id="12" name="Text Placeholder 11">
+            <a:extLst>
+              <a:ext uri="{FF2B5EF4-FFF2-40B4-BE49-F238E27FC236}">
+                <a16:creationId xmlns:a16="http://schemas.microsoft.com/office/drawing/2014/main" id="{19473856-1FC8-4BD6-73EB-6F08A1A9D4E1}"/>
+              </a:ext>
+            </a:extLst>
+          </p:cNvPr>
+          <p:cNvSpPr>
+            <a:spLocks noGrp="1"/>
+          </p:cNvSpPr>
+          <p:nvPr>
+            <p:ph type="body" sz="quarter" idx="3"/>
+          </p:nvPr>
+        </p:nvSpPr>
+        <p:spPr/>
+        <p:txBody>
+          <a:bodyPr>
+            <a:normAutofit/>
+          </a:bodyPr>
+          <a:lstStyle/>
+          <a:p>
+            <a:r>
+              <a:rPr lang="en-US" sz="2800" dirty="0"/>
+              <a:t>Paid Tier</a:t>
+            </a:r>
+          </a:p>
+        </p:txBody>
+      </p:sp>
+      <p:sp>
+        <p:nvSpPr>
+          <p:cNvPr id="14" name="Content Placeholder 13">
+            <a:extLst>
+              <a:ext uri="{FF2B5EF4-FFF2-40B4-BE49-F238E27FC236}">
+                <a16:creationId xmlns:a16="http://schemas.microsoft.com/office/drawing/2014/main" id="{05ACCA10-3A2B-F833-4ADC-9FD5871BB41B}"/>
+              </a:ext>
+            </a:extLst>
+          </p:cNvPr>
+          <p:cNvSpPr>
+            <a:spLocks noGrp="1"/>
+          </p:cNvSpPr>
+          <p:nvPr>
+            <p:ph sz="quarter" idx="19"/>
+          </p:nvPr>
+        </p:nvSpPr>
+        <p:spPr>
+          <a:xfrm>
+            <a:off x="6723890" y="2587753"/>
+            <a:ext cx="5181907" cy="3805110"/>
+          </a:xfrm>
+        </p:spPr>
+        <p:txBody>
+          <a:bodyPr>
+            <a:normAutofit/>
+          </a:bodyPr>
+          <a:lstStyle/>
+          <a:p>
+            <a:pPr marL="285750" indent="-285750">
+              <a:buFont typeface="Arial" panose="020B0604020202020204" pitchFamily="34" charset="0"/>
+              <a:buChar char="•"/>
+            </a:pPr>
+            <a:r>
+              <a:rPr lang="en-US" sz="1800" dirty="0"/>
+              <a:t>Access to all features</a:t>
+            </a:r>
+          </a:p>
+          <a:p>
+            <a:pPr marL="285750" indent="-285750">
+              <a:buFont typeface="Arial" panose="020B0604020202020204" pitchFamily="34" charset="0"/>
+              <a:buChar char="•"/>
+            </a:pPr>
+            <a:r>
+              <a:rPr lang="en-US" sz="1800" dirty="0"/>
+              <a:t>Customizable notifications for any media items</a:t>
+            </a:r>
+          </a:p>
+          <a:p>
+            <a:pPr marL="285750" indent="-285750">
+              <a:buFont typeface="Arial" panose="020B0604020202020204" pitchFamily="34" charset="0"/>
+              <a:buChar char="•"/>
+            </a:pPr>
+            <a:r>
+              <a:rPr lang="en-US" sz="1800" dirty="0"/>
+              <a:t>Ability to sync calendar with other apps like Apple, Google, Outlook, etc.</a:t>
+            </a:r>
+          </a:p>
+          <a:p>
+            <a:pPr marL="285750" indent="-285750">
+              <a:buFont typeface="Arial" panose="020B0604020202020204" pitchFamily="34" charset="0"/>
+              <a:buChar char="•"/>
+            </a:pPr>
+            <a:r>
+              <a:rPr lang="en-US" sz="1800" dirty="0"/>
+              <a:t>Access to the “Dugout” page</a:t>
+            </a:r>
+          </a:p>
+          <a:p>
+            <a:pPr marL="285750" indent="-285750">
+              <a:buFont typeface="Arial" panose="020B0604020202020204" pitchFamily="34" charset="0"/>
+              <a:buChar char="•"/>
+            </a:pPr>
+            <a:r>
+              <a:rPr lang="en-US" sz="1800" dirty="0"/>
+              <a:t>Profile customization</a:t>
+            </a:r>
+          </a:p>
+        </p:txBody>
+      </p:sp>
+      <p:sp>
+        <p:nvSpPr>
+          <p:cNvPr id="15" name="TextBox 14">
+            <a:extLst>
+              <a:ext uri="{FF2B5EF4-FFF2-40B4-BE49-F238E27FC236}">
+                <a16:creationId xmlns:a16="http://schemas.microsoft.com/office/drawing/2014/main" id="{59A8EB60-0D3B-F948-7917-2751D9B736FD}"/>
+              </a:ext>
+            </a:extLst>
+          </p:cNvPr>
+          <p:cNvSpPr txBox="1"/>
+          <p:nvPr/>
+        </p:nvSpPr>
+        <p:spPr>
+          <a:xfrm>
+            <a:off x="4142232" y="1864984"/>
+            <a:ext cx="2487168" cy="461665"/>
+          </a:xfrm>
+          <a:prstGeom prst="rect">
+            <a:avLst/>
+          </a:prstGeom>
+          <a:noFill/>
+        </p:spPr>
+        <p:txBody>
+          <a:bodyPr wrap="square" rtlCol="0">
+            <a:spAutoFit/>
+          </a:bodyPr>
+          <a:lstStyle/>
+          <a:p>
+            <a:r>
+              <a:rPr lang="en-US" sz="2400" dirty="0"/>
+              <a:t>$0/year</a:t>
+            </a:r>
+          </a:p>
+        </p:txBody>
+      </p:sp>
+      <p:sp>
+        <p:nvSpPr>
+          <p:cNvPr id="17" name="TextBox 16">
+            <a:extLst>
+              <a:ext uri="{FF2B5EF4-FFF2-40B4-BE49-F238E27FC236}">
+                <a16:creationId xmlns:a16="http://schemas.microsoft.com/office/drawing/2014/main" id="{3B6950EF-C8AA-BF60-72E3-39E7A7C70C0A}"/>
+              </a:ext>
+            </a:extLst>
+          </p:cNvPr>
+          <p:cNvSpPr txBox="1"/>
+          <p:nvPr/>
+        </p:nvSpPr>
+        <p:spPr>
+          <a:xfrm>
+            <a:off x="10469880" y="1836348"/>
+            <a:ext cx="2487168" cy="461665"/>
+          </a:xfrm>
+          <a:prstGeom prst="rect">
+            <a:avLst/>
+          </a:prstGeom>
+          <a:noFill/>
+        </p:spPr>
+        <p:txBody>
+          <a:bodyPr wrap="square" rtlCol="0">
+            <a:spAutoFit/>
+          </a:bodyPr>
+          <a:lstStyle/>
+          <a:p>
+            <a:r>
+              <a:rPr lang="en-US" sz="2400" dirty="0"/>
+              <a:t>$10/year</a:t>
+            </a:r>
+          </a:p>
+        </p:txBody>
+      </p:sp>
+    </p:spTree>
+    <p:extLst>
+      <p:ext uri="{BB962C8B-B14F-4D97-AF65-F5344CB8AC3E}">
+        <p14:creationId xmlns:p14="http://schemas.microsoft.com/office/powerpoint/2010/main" val="2513515690"/>
+      </p:ext>
+    </p:extLst>
+  </p:cSld>
+  <p:clrMapOvr>
+    <a:masterClrMapping/>
+  </p:clrMapOvr>
+</p:sld>
+</file>
+
+<file path=ppt/slides/slide8.xml><?xml version="1.0" encoding="utf-8"?>
+<p:sld xmlns:a="http://schemas.openxmlformats.org/drawingml/2006/main" xmlns:r="http://schemas.openxmlformats.org/officeDocument/2006/relationships" xmlns:p="http://schemas.openxmlformats.org/presentationml/2006/main">
+  <p:cSld>
+    <p:spTree>
+      <p:nvGrpSpPr>
+        <p:cNvPr id="1" name=""/>
+        <p:cNvGrpSpPr/>
+        <p:nvPr/>
+      </p:nvGrpSpPr>
+      <p:grpSpPr>
+        <a:xfrm>
+          <a:off x="0" y="0"/>
+          <a:ext cx="0" cy="0"/>
+          <a:chOff x="0" y="0"/>
+          <a:chExt cx="0" cy="0"/>
+        </a:xfrm>
+      </p:grpSpPr>
+      <p:sp>
+        <p:nvSpPr>
+          <p:cNvPr id="2" name="Title 1">
+            <a:extLst>
+              <a:ext uri="{FF2B5EF4-FFF2-40B4-BE49-F238E27FC236}">
+                <a16:creationId xmlns:a16="http://schemas.microsoft.com/office/drawing/2014/main" id="{352DF2B7-2ACF-AE2F-49BB-9F647CDFA66F}"/>
+              </a:ext>
+            </a:extLst>
+          </p:cNvPr>
+          <p:cNvSpPr>
+            <a:spLocks noGrp="1"/>
+          </p:cNvSpPr>
+          <p:nvPr>
+            <p:ph type="title"/>
+          </p:nvPr>
+        </p:nvSpPr>
+        <p:spPr>
+          <a:xfrm>
+            <a:off x="429767" y="1578102"/>
+            <a:ext cx="7498080" cy="1106424"/>
+          </a:xfrm>
+        </p:spPr>
+        <p:txBody>
+          <a:bodyPr/>
+          <a:lstStyle/>
+          <a:p>
+            <a:r>
+              <a:rPr lang="en-US" dirty="0"/>
+              <a:t>Roadmap</a:t>
+            </a:r>
+          </a:p>
+        </p:txBody>
+      </p:sp>
+      <p:sp>
+        <p:nvSpPr>
+          <p:cNvPr id="7" name="Rectangle 6">
+            <a:extLst>
+              <a:ext uri="{FF2B5EF4-FFF2-40B4-BE49-F238E27FC236}">
+                <a16:creationId xmlns:a16="http://schemas.microsoft.com/office/drawing/2014/main" id="{B5FB133F-2387-42F7-48F8-0ED78ED45F46}"/>
+              </a:ext>
+            </a:extLst>
+          </p:cNvPr>
+          <p:cNvSpPr/>
+          <p:nvPr/>
+        </p:nvSpPr>
+        <p:spPr>
+          <a:xfrm>
+            <a:off x="5772912" y="530352"/>
+            <a:ext cx="5736336" cy="1389888"/>
+          </a:xfrm>
+          <a:prstGeom prst="rect">
+            <a:avLst/>
+          </a:prstGeom>
+          <a:noFill/>
+          <a:ln>
+            <a:solidFill>
+              <a:schemeClr val="tx1"/>
+            </a:solidFill>
+          </a:ln>
+        </p:spPr>
+        <p:style>
+          <a:lnRef idx="2">
+            <a:schemeClr val="accent1">
+              <a:shade val="15000"/>
+            </a:schemeClr>
+          </a:lnRef>
+          <a:fillRef idx="1">
+            <a:schemeClr val="accent1"/>
+          </a:fillRef>
+          <a:effectRef idx="0">
+            <a:schemeClr val="accent1"/>
+          </a:effectRef>
+          <a:fontRef idx="minor">
+            <a:schemeClr val="lt1"/>
+          </a:fontRef>
+        </p:style>
+        <p:txBody>
+          <a:bodyPr rtlCol="0" anchor="ctr"/>
+          <a:lstStyle/>
+          <a:p>
+            <a:pPr marL="342900" indent="-342900">
+              <a:buFont typeface="Arial" panose="020B0604020202020204" pitchFamily="34" charset="0"/>
+              <a:buChar char="•"/>
+            </a:pPr>
+            <a:r>
+              <a:rPr lang="en-US" sz="2000" dirty="0"/>
+              <a:t>Finalize release date pipeline</a:t>
+            </a:r>
+          </a:p>
+          <a:p>
+            <a:pPr marL="342900" indent="-342900">
+              <a:buFont typeface="Arial" panose="020B0604020202020204" pitchFamily="34" charset="0"/>
+              <a:buChar char="•"/>
+            </a:pPr>
+            <a:r>
+              <a:rPr lang="en-US" sz="2000" dirty="0"/>
+              <a:t>App Store launch</a:t>
+            </a:r>
+          </a:p>
+          <a:p>
+            <a:pPr marL="342900" indent="-342900">
+              <a:buFont typeface="Arial" panose="020B0604020202020204" pitchFamily="34" charset="0"/>
+              <a:buChar char="•"/>
+            </a:pPr>
+            <a:r>
+              <a:rPr lang="en-US" sz="2000" dirty="0"/>
+              <a:t>Initial paid tier at $5/lifetime for early users</a:t>
+            </a:r>
+          </a:p>
+        </p:txBody>
+      </p:sp>
+      <p:sp>
+        <p:nvSpPr>
+          <p:cNvPr id="13" name="Rectangle 12">
+            <a:extLst>
+              <a:ext uri="{FF2B5EF4-FFF2-40B4-BE49-F238E27FC236}">
+                <a16:creationId xmlns:a16="http://schemas.microsoft.com/office/drawing/2014/main" id="{AD0E9EED-EB3F-446D-9BA6-D9B59BFD0B63}"/>
+              </a:ext>
+            </a:extLst>
+          </p:cNvPr>
+          <p:cNvSpPr/>
+          <p:nvPr/>
+        </p:nvSpPr>
+        <p:spPr>
+          <a:xfrm>
+            <a:off x="5772912" y="2484120"/>
+            <a:ext cx="5736336" cy="1106424"/>
+          </a:xfrm>
+          <a:prstGeom prst="rect">
+            <a:avLst/>
+          </a:prstGeom>
+          <a:noFill/>
+          <a:ln>
+            <a:solidFill>
+              <a:schemeClr val="tx1"/>
+            </a:solidFill>
+          </a:ln>
+        </p:spPr>
+        <p:style>
+          <a:lnRef idx="2">
+            <a:schemeClr val="accent1">
+              <a:shade val="15000"/>
+            </a:schemeClr>
+          </a:lnRef>
+          <a:fillRef idx="1">
+            <a:schemeClr val="accent1"/>
+          </a:fillRef>
+          <a:effectRef idx="0">
+            <a:schemeClr val="accent1"/>
+          </a:effectRef>
+          <a:fontRef idx="minor">
+            <a:schemeClr val="lt1"/>
+          </a:fontRef>
+        </p:style>
+        <p:txBody>
+          <a:bodyPr rtlCol="0" anchor="ctr"/>
+          <a:lstStyle/>
+          <a:p>
+            <a:pPr marL="342900" indent="-342900">
+              <a:buFont typeface="Arial" panose="020B0604020202020204" pitchFamily="34" charset="0"/>
+              <a:buChar char="•"/>
+            </a:pPr>
+            <a:r>
+              <a:rPr lang="en-US" sz="2000" dirty="0"/>
+              <a:t>Implement personalized recommendations</a:t>
+            </a:r>
+          </a:p>
+          <a:p>
+            <a:pPr marL="342900" indent="-342900">
+              <a:buFont typeface="Arial" panose="020B0604020202020204" pitchFamily="34" charset="0"/>
+              <a:buChar char="•"/>
+            </a:pPr>
+            <a:r>
+              <a:rPr lang="en-US" sz="2000" dirty="0"/>
+              <a:t>Expand media types (books, live events, etc.)</a:t>
+            </a:r>
+          </a:p>
+          <a:p>
+            <a:pPr marL="342900" indent="-342900">
+              <a:buFont typeface="Arial" panose="020B0604020202020204" pitchFamily="34" charset="0"/>
+              <a:buChar char="•"/>
+            </a:pPr>
+            <a:r>
+              <a:rPr lang="en-US" sz="2000" dirty="0"/>
+              <a:t>Strengthen infrastructure for larger userbase</a:t>
+            </a:r>
+          </a:p>
+        </p:txBody>
+      </p:sp>
+      <p:sp>
+        <p:nvSpPr>
+          <p:cNvPr id="15" name="Rectangle 14">
+            <a:extLst>
+              <a:ext uri="{FF2B5EF4-FFF2-40B4-BE49-F238E27FC236}">
+                <a16:creationId xmlns:a16="http://schemas.microsoft.com/office/drawing/2014/main" id="{996D8C91-388D-951A-647D-6A5FADBDA29F}"/>
+              </a:ext>
+            </a:extLst>
+          </p:cNvPr>
+          <p:cNvSpPr/>
+          <p:nvPr/>
+        </p:nvSpPr>
+        <p:spPr>
+          <a:xfrm>
+            <a:off x="5772912" y="4154424"/>
+            <a:ext cx="5736336" cy="1389888"/>
+          </a:xfrm>
+          <a:prstGeom prst="rect">
+            <a:avLst/>
+          </a:prstGeom>
+          <a:noFill/>
+          <a:ln>
+            <a:solidFill>
+              <a:schemeClr val="tx1"/>
+            </a:solidFill>
+          </a:ln>
+        </p:spPr>
+        <p:style>
+          <a:lnRef idx="2">
+            <a:schemeClr val="accent1">
+              <a:shade val="15000"/>
+            </a:schemeClr>
+          </a:lnRef>
+          <a:fillRef idx="1">
+            <a:schemeClr val="accent1"/>
+          </a:fillRef>
+          <a:effectRef idx="0">
+            <a:schemeClr val="accent1"/>
+          </a:effectRef>
+          <a:fontRef idx="minor">
+            <a:schemeClr val="lt1"/>
+          </a:fontRef>
+        </p:style>
+        <p:txBody>
+          <a:bodyPr rtlCol="0" anchor="ctr"/>
+          <a:lstStyle/>
+          <a:p>
+            <a:pPr marL="342900" indent="-342900">
+              <a:buFont typeface="Arial" panose="020B0604020202020204" pitchFamily="34" charset="0"/>
+              <a:buChar char="•"/>
+            </a:pPr>
+            <a:r>
+              <a:rPr lang="en-US" sz="2000" dirty="0"/>
+              <a:t>Seek out direct data partnerships</a:t>
+            </a:r>
+          </a:p>
+          <a:p>
+            <a:pPr marL="342900" indent="-342900">
+              <a:buFont typeface="Arial" panose="020B0604020202020204" pitchFamily="34" charset="0"/>
+              <a:buChar char="•"/>
+            </a:pPr>
+            <a:r>
+              <a:rPr lang="en-US" sz="2000" dirty="0"/>
+              <a:t>Embeddable release-calendar widget</a:t>
+            </a:r>
+          </a:p>
+          <a:p>
+            <a:pPr marL="342900" indent="-342900">
+              <a:buFont typeface="Arial" panose="020B0604020202020204" pitchFamily="34" charset="0"/>
+              <a:buChar char="•"/>
+            </a:pPr>
+            <a:r>
+              <a:rPr lang="en-US" sz="2000" dirty="0"/>
+              <a:t>Explore affiliate revenue for storefront links</a:t>
+            </a:r>
+          </a:p>
+        </p:txBody>
+      </p:sp>
+      <p:sp>
+        <p:nvSpPr>
+          <p:cNvPr id="16" name="TextBox 15">
+            <a:extLst>
+              <a:ext uri="{FF2B5EF4-FFF2-40B4-BE49-F238E27FC236}">
+                <a16:creationId xmlns:a16="http://schemas.microsoft.com/office/drawing/2014/main" id="{40C505AC-0223-C127-BF84-5DF94E10BB1A}"/>
+              </a:ext>
+            </a:extLst>
+          </p:cNvPr>
+          <p:cNvSpPr txBox="1"/>
+          <p:nvPr/>
+        </p:nvSpPr>
+        <p:spPr>
+          <a:xfrm>
+            <a:off x="4050791" y="976175"/>
+            <a:ext cx="2029968" cy="461665"/>
+          </a:xfrm>
+          <a:prstGeom prst="rect">
+            <a:avLst/>
+          </a:prstGeom>
+          <a:noFill/>
+        </p:spPr>
+        <p:txBody>
+          <a:bodyPr wrap="square" rtlCol="0">
+            <a:spAutoFit/>
+          </a:bodyPr>
+          <a:lstStyle/>
+          <a:p>
+            <a:r>
+              <a:rPr lang="en-US" sz="2400" dirty="0"/>
+              <a:t>Short-term</a:t>
+            </a:r>
+          </a:p>
+        </p:txBody>
+      </p:sp>
+      <p:sp>
+        <p:nvSpPr>
+          <p:cNvPr id="18" name="TextBox 17">
+            <a:extLst>
+              <a:ext uri="{FF2B5EF4-FFF2-40B4-BE49-F238E27FC236}">
+                <a16:creationId xmlns:a16="http://schemas.microsoft.com/office/drawing/2014/main" id="{1422B8CB-8630-6AC1-CFD5-CE5360763C35}"/>
+              </a:ext>
+            </a:extLst>
+          </p:cNvPr>
+          <p:cNvSpPr txBox="1"/>
+          <p:nvPr/>
+        </p:nvSpPr>
+        <p:spPr>
+          <a:xfrm>
+            <a:off x="4066032" y="2806499"/>
+            <a:ext cx="2029968" cy="461665"/>
+          </a:xfrm>
+          <a:prstGeom prst="rect">
+            <a:avLst/>
+          </a:prstGeom>
+          <a:noFill/>
+        </p:spPr>
+        <p:txBody>
+          <a:bodyPr wrap="square" rtlCol="0">
+            <a:spAutoFit/>
+          </a:bodyPr>
+          <a:lstStyle/>
+          <a:p>
+            <a:r>
+              <a:rPr lang="en-US" sz="2400" dirty="0"/>
+              <a:t>Mid-term</a:t>
+            </a:r>
+          </a:p>
+        </p:txBody>
+      </p:sp>
+      <p:sp>
+        <p:nvSpPr>
+          <p:cNvPr id="20" name="TextBox 19">
+            <a:extLst>
+              <a:ext uri="{FF2B5EF4-FFF2-40B4-BE49-F238E27FC236}">
+                <a16:creationId xmlns:a16="http://schemas.microsoft.com/office/drawing/2014/main" id="{4BE092C5-BB83-FB52-C83B-8B06D8DCB1E0}"/>
+              </a:ext>
+            </a:extLst>
+          </p:cNvPr>
+          <p:cNvSpPr txBox="1"/>
+          <p:nvPr/>
+        </p:nvSpPr>
+        <p:spPr>
+          <a:xfrm>
+            <a:off x="4066032" y="4618535"/>
+            <a:ext cx="2029968" cy="461665"/>
+          </a:xfrm>
+          <a:prstGeom prst="rect">
+            <a:avLst/>
+          </a:prstGeom>
+          <a:noFill/>
+        </p:spPr>
+        <p:txBody>
+          <a:bodyPr wrap="square" rtlCol="0">
+            <a:spAutoFit/>
+          </a:bodyPr>
+          <a:lstStyle/>
+          <a:p>
+            <a:r>
+              <a:rPr lang="en-US" sz="2400" dirty="0"/>
+              <a:t>Long-term</a:t>
+            </a:r>
+          </a:p>
+        </p:txBody>
+      </p:sp>
+      <p:sp>
+        <p:nvSpPr>
+          <p:cNvPr id="21" name="Arrow: Down 20">
+            <a:extLst>
+              <a:ext uri="{FF2B5EF4-FFF2-40B4-BE49-F238E27FC236}">
+                <a16:creationId xmlns:a16="http://schemas.microsoft.com/office/drawing/2014/main" id="{C8D94CF0-3024-70EB-0D2D-B61400EF13E3}"/>
+              </a:ext>
+            </a:extLst>
+          </p:cNvPr>
+          <p:cNvSpPr/>
+          <p:nvPr/>
+        </p:nvSpPr>
+        <p:spPr>
+          <a:xfrm>
+            <a:off x="8471916" y="2069592"/>
+            <a:ext cx="338328" cy="265176"/>
+          </a:xfrm>
+          <a:prstGeom prst="downArrow">
+            <a:avLst/>
+          </a:prstGeom>
+          <a:noFill/>
+          <a:ln>
+            <a:solidFill>
+              <a:schemeClr val="tx1"/>
+            </a:solidFill>
+          </a:ln>
+        </p:spPr>
+        <p:style>
+          <a:lnRef idx="2">
+            <a:schemeClr val="accent1">
+              <a:shade val="15000"/>
+            </a:schemeClr>
+          </a:lnRef>
+          <a:fillRef idx="1">
+            <a:schemeClr val="accent1"/>
+          </a:fillRef>
+          <a:effectRef idx="0">
+            <a:schemeClr val="accent1"/>
+          </a:effectRef>
+          <a:fontRef idx="minor">
+            <a:schemeClr val="lt1"/>
+          </a:fontRef>
+        </p:style>
+        <p:txBody>
+          <a:bodyPr rtlCol="0" anchor="ctr"/>
+          <a:lstStyle/>
+          <a:p>
+            <a:pPr algn="ctr"/>
+            <a:endParaRPr lang="en-US"/>
+          </a:p>
+        </p:txBody>
+      </p:sp>
+      <p:sp>
+        <p:nvSpPr>
+          <p:cNvPr id="23" name="Arrow: Down 22">
+            <a:extLst>
+              <a:ext uri="{FF2B5EF4-FFF2-40B4-BE49-F238E27FC236}">
+                <a16:creationId xmlns:a16="http://schemas.microsoft.com/office/drawing/2014/main" id="{6A00D220-69CD-BD2F-6C91-EB666C98C0AE}"/>
+              </a:ext>
+            </a:extLst>
+          </p:cNvPr>
+          <p:cNvSpPr/>
+          <p:nvPr/>
+        </p:nvSpPr>
+        <p:spPr>
+          <a:xfrm>
+            <a:off x="8471916" y="3742944"/>
+            <a:ext cx="338328" cy="265176"/>
+          </a:xfrm>
+          <a:prstGeom prst="downArrow">
+            <a:avLst/>
+          </a:prstGeom>
+          <a:noFill/>
+          <a:ln>
+            <a:solidFill>
+              <a:schemeClr val="tx1"/>
+            </a:solidFill>
+          </a:ln>
+        </p:spPr>
+        <p:style>
+          <a:lnRef idx="2">
+            <a:schemeClr val="accent1">
+              <a:shade val="15000"/>
+            </a:schemeClr>
+          </a:lnRef>
+          <a:fillRef idx="1">
+            <a:schemeClr val="accent1"/>
+          </a:fillRef>
+          <a:effectRef idx="0">
+            <a:schemeClr val="accent1"/>
+          </a:effectRef>
+          <a:fontRef idx="minor">
+            <a:schemeClr val="lt1"/>
+          </a:fontRef>
+        </p:style>
+        <p:txBody>
+          <a:bodyPr rtlCol="0" anchor="ctr"/>
+          <a:lstStyle/>
+          <a:p>
+            <a:pPr algn="ctr"/>
+            <a:endParaRPr lang="en-US"/>
+          </a:p>
+        </p:txBody>
+      </p:sp>
+    </p:spTree>
+    <p:extLst>
+      <p:ext uri="{BB962C8B-B14F-4D97-AF65-F5344CB8AC3E}">
+        <p14:creationId xmlns:p14="http://schemas.microsoft.com/office/powerpoint/2010/main" val="3472879271"/>
+      </p:ext>
+    </p:extLst>
+  </p:cSld>
+  <p:clrMapOvr>
+    <a:masterClrMapping/>
+  </p:clrMapOvr>
+</p:sld>
+</file>
+
+<file path=ppt/slides/slide9.xml><?xml version="1.0" encoding="utf-8"?>
 <p:sld xmlns:a="http://schemas.openxmlformats.org/drawingml/2006/main" xmlns:r="http://schemas.openxmlformats.org/officeDocument/2006/relationships" xmlns:p="http://schemas.openxmlformats.org/presentationml/2006/main">
   <p:cSld>
     <p:spTree>

</xml_diff>

<commit_message>
Fix broken image reference in pitch deck; skip dugout fetch when signed out
Slide 3's image had a corrupted filename/relationship (image7.666666666667,100)
that would render as a broken image in PowerPoint. Home page also fired an
authenticated-only /api/dugout request on every load even when signed out,
producing a console 401 for anonymous visitors.
</commit_message>
<xml_diff>
--- a/docs/TRACKR Pitchdeck.pptx
+++ b/docs/TRACKR Pitchdeck.pptx
@@ -5,18 +5,20 @@
     <p:sldMasterId id="2147483777" r:id="rId1"/>
   </p:sldMasterIdLst>
   <p:notesMasterIdLst>
-    <p:notesMasterId r:id="rId11"/>
+    <p:notesMasterId r:id="rId13"/>
   </p:notesMasterIdLst>
   <p:sldIdLst>
     <p:sldId id="256" r:id="rId2"/>
-    <p:sldId id="257" r:id="rId3"/>
+    <p:sldId id="266" r:id="rId3"/>
     <p:sldId id="259" r:id="rId4"/>
     <p:sldId id="260" r:id="rId5"/>
-    <p:sldId id="262" r:id="rId6"/>
-    <p:sldId id="261" r:id="rId7"/>
-    <p:sldId id="263" r:id="rId8"/>
-    <p:sldId id="264" r:id="rId9"/>
-    <p:sldId id="258" r:id="rId10"/>
+    <p:sldId id="267" r:id="rId6"/>
+    <p:sldId id="262" r:id="rId7"/>
+    <p:sldId id="261" r:id="rId8"/>
+    <p:sldId id="263" r:id="rId9"/>
+    <p:sldId id="265" r:id="rId10"/>
+    <p:sldId id="264" r:id="rId11"/>
+    <p:sldId id="258" r:id="rId12"/>
   </p:sldIdLst>
   <p:sldSz cx="12192000" cy="6858000"/>
   <p:notesSz cx="6858000" cy="9144000"/>
@@ -1173,7 +1175,10 @@
         </a:solidFill>
         <a:ln>
           <a:solidFill>
-            <a:schemeClr val="tx1"/>
+            <a:schemeClr val="bg1">
+              <a:lumMod val="65000"/>
+              <a:lumOff val="35000"/>
+            </a:schemeClr>
           </a:solidFill>
         </a:ln>
       </dgm:spPr>
@@ -1237,7 +1242,10 @@
         </a:solidFill>
         <a:ln>
           <a:solidFill>
-            <a:schemeClr val="tx1"/>
+            <a:schemeClr val="bg1">
+              <a:lumMod val="65000"/>
+              <a:lumOff val="35000"/>
+            </a:schemeClr>
           </a:solidFill>
         </a:ln>
       </dgm:spPr>
@@ -1301,7 +1309,10 @@
         </a:solidFill>
         <a:ln>
           <a:solidFill>
-            <a:schemeClr val="tx1"/>
+            <a:schemeClr val="bg1">
+              <a:lumMod val="65000"/>
+              <a:lumOff val="35000"/>
+            </a:schemeClr>
           </a:solidFill>
         </a:ln>
       </dgm:spPr>
@@ -1414,7 +1425,10 @@
         </a:solidFill>
         <a:ln>
           <a:solidFill>
-            <a:schemeClr val="tx1"/>
+            <a:schemeClr val="bg1">
+              <a:lumMod val="65000"/>
+              <a:lumOff val="35000"/>
+            </a:schemeClr>
           </a:solidFill>
         </a:ln>
         <a:effectLst/>
@@ -1568,7 +1582,10 @@
         </a:solidFill>
         <a:ln>
           <a:solidFill>
-            <a:schemeClr val="tx1"/>
+            <a:schemeClr val="bg1">
+              <a:lumMod val="65000"/>
+              <a:lumOff val="35000"/>
+            </a:schemeClr>
           </a:solidFill>
         </a:ln>
         <a:effectLst/>
@@ -1722,7 +1739,10 @@
         </a:solidFill>
         <a:ln>
           <a:solidFill>
-            <a:schemeClr val="tx1"/>
+            <a:schemeClr val="bg1">
+              <a:lumMod val="65000"/>
+              <a:lumOff val="35000"/>
+            </a:schemeClr>
           </a:solidFill>
         </a:ln>
         <a:effectLst/>
@@ -3270,7 +3290,7 @@
           <a:p>
             <a:fld id="{0046FE89-E818-47F4-8451-E5577C95B5C1}" type="datetimeFigureOut">
               <a:rPr lang="en-US" smtClean="0"/>
-              <a:t>8/10/2026</a:t>
+              <a:t>8/13/2026</a:t>
             </a:fld>
             <a:endParaRPr lang="en-US"/>
           </a:p>
@@ -3624,6 +3644,90 @@
 </p:notes>
 </file>
 
+<file path=ppt/notesSlides/notesSlide2.xml><?xml version="1.0" encoding="utf-8"?>
+<p:notes xmlns:a="http://schemas.openxmlformats.org/drawingml/2006/main" xmlns:r="http://schemas.openxmlformats.org/officeDocument/2006/relationships" xmlns:p="http://schemas.openxmlformats.org/presentationml/2006/main">
+  <p:cSld>
+    <p:spTree>
+      <p:nvGrpSpPr>
+        <p:cNvPr id="1" name=""/>
+        <p:cNvGrpSpPr/>
+        <p:nvPr/>
+      </p:nvGrpSpPr>
+      <p:grpSpPr>
+        <a:xfrm>
+          <a:off x="0" y="0"/>
+          <a:ext cx="0" cy="0"/>
+          <a:chOff x="0" y="0"/>
+          <a:chExt cx="0" cy="0"/>
+        </a:xfrm>
+      </p:grpSpPr>
+      <p:sp>
+        <p:nvSpPr>
+          <p:cNvPr id="2" name="Slide Image Placeholder 1"/>
+          <p:cNvSpPr>
+            <a:spLocks noGrp="1" noRot="1" noChangeAspect="1"/>
+          </p:cNvSpPr>
+          <p:nvPr>
+            <p:ph type="sldImg"/>
+          </p:nvPr>
+        </p:nvSpPr>
+        <p:spPr/>
+      </p:sp>
+      <p:sp>
+        <p:nvSpPr>
+          <p:cNvPr id="3" name="Notes Placeholder 2"/>
+          <p:cNvSpPr>
+            <a:spLocks noGrp="1"/>
+          </p:cNvSpPr>
+          <p:nvPr>
+            <p:ph type="body" idx="1"/>
+          </p:nvPr>
+        </p:nvSpPr>
+        <p:spPr/>
+        <p:txBody>
+          <a:bodyPr/>
+          <a:lstStyle/>
+          <a:p>
+            <a:endParaRPr lang="en-US" dirty="0"/>
+          </a:p>
+        </p:txBody>
+      </p:sp>
+      <p:sp>
+        <p:nvSpPr>
+          <p:cNvPr id="4" name="Slide Number Placeholder 3"/>
+          <p:cNvSpPr>
+            <a:spLocks noGrp="1"/>
+          </p:cNvSpPr>
+          <p:nvPr>
+            <p:ph type="sldNum" sz="quarter" idx="5"/>
+          </p:nvPr>
+        </p:nvSpPr>
+        <p:spPr/>
+        <p:txBody>
+          <a:bodyPr/>
+          <a:lstStyle/>
+          <a:p>
+            <a:fld id="{F231CC50-A15D-4751-811F-4D8ADDBE4302}" type="slidenum">
+              <a:rPr lang="en-US" smtClean="0"/>
+              <a:t>9</a:t>
+            </a:fld>
+            <a:endParaRPr lang="en-US"/>
+          </a:p>
+        </p:txBody>
+      </p:sp>
+    </p:spTree>
+    <p:extLst>
+      <p:ext uri="{BB962C8B-B14F-4D97-AF65-F5344CB8AC3E}">
+        <p14:creationId xmlns:p14="http://schemas.microsoft.com/office/powerpoint/2010/main" val="3660729910"/>
+      </p:ext>
+    </p:extLst>
+  </p:cSld>
+  <p:clrMapOvr>
+    <a:masterClrMapping/>
+  </p:clrMapOvr>
+</p:notes>
+</file>
+
 <file path=ppt/slideLayouts/slideLayout1.xml><?xml version="1.0" encoding="utf-8"?>
 <p:sldLayout xmlns:a="http://schemas.openxmlformats.org/drawingml/2006/main" xmlns:r="http://schemas.openxmlformats.org/officeDocument/2006/relationships" xmlns:p="http://schemas.openxmlformats.org/presentationml/2006/main" showMasterSp="0" preserve="1">
   <p:cSld name="Title with Picture">
@@ -3850,7 +3954,7 @@
           <a:p>
             <a:fld id="{7D31F0D8-39C5-4C77-A52E-168D39363794}" type="datetimeFigureOut">
               <a:rPr lang="en-US" smtClean="0"/>
-              <a:t>8/10/2026</a:t>
+              <a:t>8/13/2026</a:t>
             </a:fld>
             <a:endParaRPr lang="en-US"/>
           </a:p>
@@ -4012,7 +4116,7 @@
           <a:p>
             <a:fld id="{7D31F0D8-39C5-4C77-A52E-168D39363794}" type="datetimeFigureOut">
               <a:rPr lang="en-US" smtClean="0"/>
-              <a:t>8/10/2026</a:t>
+              <a:t>8/13/2026</a:t>
             </a:fld>
             <a:endParaRPr lang="en-US"/>
           </a:p>
@@ -4492,7 +4596,7 @@
           <a:p>
             <a:fld id="{7D31F0D8-39C5-4C77-A52E-168D39363794}" type="datetimeFigureOut">
               <a:rPr lang="en-US" smtClean="0"/>
-              <a:t>8/10/2026</a:t>
+              <a:t>8/13/2026</a:t>
             </a:fld>
             <a:endParaRPr lang="en-US"/>
           </a:p>
@@ -4809,7 +4913,7 @@
           <a:p>
             <a:fld id="{7D31F0D8-39C5-4C77-A52E-168D39363794}" type="datetimeFigureOut">
               <a:rPr lang="en-US" smtClean="0"/>
-              <a:t>8/10/2026</a:t>
+              <a:t>8/13/2026</a:t>
             </a:fld>
             <a:endParaRPr lang="en-US"/>
           </a:p>
@@ -5157,7 +5261,7 @@
           <a:p>
             <a:fld id="{7D31F0D8-39C5-4C77-A52E-168D39363794}" type="datetimeFigureOut">
               <a:rPr lang="en-US" smtClean="0"/>
-              <a:t>8/10/2026</a:t>
+              <a:t>8/13/2026</a:t>
             </a:fld>
             <a:endParaRPr lang="en-US"/>
           </a:p>
@@ -5444,7 +5548,7 @@
           <a:p>
             <a:fld id="{7D31F0D8-39C5-4C77-A52E-168D39363794}" type="datetimeFigureOut">
               <a:rPr lang="en-US" smtClean="0"/>
-              <a:t>8/10/2026</a:t>
+              <a:t>8/13/2026</a:t>
             </a:fld>
             <a:endParaRPr lang="en-US"/>
           </a:p>
@@ -5898,7 +6002,7 @@
           <a:p>
             <a:fld id="{7D31F0D8-39C5-4C77-A52E-168D39363794}" type="datetimeFigureOut">
               <a:rPr lang="en-US" smtClean="0"/>
-              <a:t>8/10/2026</a:t>
+              <a:t>8/13/2026</a:t>
             </a:fld>
             <a:endParaRPr lang="en-US"/>
           </a:p>
@@ -6494,7 +6598,7 @@
           <a:p>
             <a:fld id="{7D31F0D8-39C5-4C77-A52E-168D39363794}" type="datetimeFigureOut">
               <a:rPr lang="en-US" smtClean="0"/>
-              <a:t>8/10/2026</a:t>
+              <a:t>8/13/2026</a:t>
             </a:fld>
             <a:endParaRPr lang="en-US"/>
           </a:p>
@@ -6706,7 +6810,7 @@
           <a:p>
             <a:fld id="{7D31F0D8-39C5-4C77-A52E-168D39363794}" type="datetimeFigureOut">
               <a:rPr lang="en-US" smtClean="0"/>
-              <a:t>8/10/2026</a:t>
+              <a:t>8/13/2026</a:t>
             </a:fld>
             <a:endParaRPr lang="en-US"/>
           </a:p>
@@ -7180,7 +7284,7 @@
           <a:p>
             <a:fld id="{7D31F0D8-39C5-4C77-A52E-168D39363794}" type="datetimeFigureOut">
               <a:rPr lang="en-US" smtClean="0"/>
-              <a:t>8/10/2026</a:t>
+              <a:t>8/13/2026</a:t>
             </a:fld>
             <a:endParaRPr lang="en-US"/>
           </a:p>
@@ -7469,7 +7573,7 @@
           <a:p>
             <a:fld id="{7D31F0D8-39C5-4C77-A52E-168D39363794}" type="datetimeFigureOut">
               <a:rPr lang="en-US" smtClean="0"/>
-              <a:t>8/10/2026</a:t>
+              <a:t>8/13/2026</a:t>
             </a:fld>
             <a:endParaRPr lang="en-US"/>
           </a:p>
@@ -7732,7 +7836,7 @@
           <a:p>
             <a:fld id="{7D31F0D8-39C5-4C77-A52E-168D39363794}" type="datetimeFigureOut">
               <a:rPr lang="en-US" smtClean="0"/>
-              <a:t>8/10/2026</a:t>
+              <a:t>8/13/2026</a:t>
             </a:fld>
             <a:endParaRPr lang="en-US"/>
           </a:p>
@@ -8355,7 +8459,7 @@
           <a:p>
             <a:fld id="{7D31F0D8-39C5-4C77-A52E-168D39363794}" type="datetimeFigureOut">
               <a:rPr lang="en-US" smtClean="0"/>
-              <a:t>8/10/2026</a:t>
+              <a:t>8/13/2026</a:t>
             </a:fld>
             <a:endParaRPr lang="en-US"/>
           </a:p>
@@ -8932,7 +9036,7 @@
           <a:p>
             <a:fld id="{7D31F0D8-39C5-4C77-A52E-168D39363794}" type="datetimeFigureOut">
               <a:rPr lang="en-US" smtClean="0"/>
-              <a:t>8/10/2026</a:t>
+              <a:t>8/13/2026</a:t>
             </a:fld>
             <a:endParaRPr lang="en-US"/>
           </a:p>
@@ -9270,7 +9374,7 @@
           <a:p>
             <a:fld id="{7D31F0D8-39C5-4C77-A52E-168D39363794}" type="datetimeFigureOut">
               <a:rPr lang="en-US" smtClean="0"/>
-              <a:t>8/10/2026</a:t>
+              <a:t>8/13/2026</a:t>
             </a:fld>
             <a:endParaRPr lang="en-US"/>
           </a:p>
@@ -9825,7 +9929,7 @@
           <a:p>
             <a:fld id="{7D31F0D8-39C5-4C77-A52E-168D39363794}" type="datetimeFigureOut">
               <a:rPr lang="en-US" smtClean="0"/>
-              <a:t>8/10/2026</a:t>
+              <a:t>8/13/2026</a:t>
             </a:fld>
             <a:endParaRPr lang="en-US"/>
           </a:p>
@@ -10064,7 +10168,7 @@
           <a:p>
             <a:fld id="{7D31F0D8-39C5-4C77-A52E-168D39363794}" type="datetimeFigureOut">
               <a:rPr lang="en-US" smtClean="0"/>
-              <a:t>8/10/2026</a:t>
+              <a:t>8/13/2026</a:t>
             </a:fld>
             <a:endParaRPr lang="en-US"/>
           </a:p>
@@ -10453,7 +10557,7 @@
           <a:p>
             <a:fld id="{7D31F0D8-39C5-4C77-A52E-168D39363794}" type="datetimeFigureOut">
               <a:rPr lang="en-US" smtClean="0"/>
-              <a:t>8/10/2026</a:t>
+              <a:t>8/13/2026</a:t>
             </a:fld>
             <a:endParaRPr lang="en-US"/>
           </a:p>
@@ -10986,7 +11090,7 @@
           <a:p>
             <a:fld id="{7D31F0D8-39C5-4C77-A52E-168D39363794}" type="datetimeFigureOut">
               <a:rPr lang="en-US" smtClean="0"/>
-              <a:t>8/10/2026</a:t>
+              <a:t>8/13/2026</a:t>
             </a:fld>
             <a:endParaRPr lang="en-US"/>
           </a:p>
@@ -11099,7 +11203,7 @@
           <a:p>
             <a:fld id="{7D31F0D8-39C5-4C77-A52E-168D39363794}" type="datetimeFigureOut">
               <a:rPr lang="en-US" smtClean="0"/>
-              <a:t>8/10/2026</a:t>
+              <a:t>8/13/2026</a:t>
             </a:fld>
             <a:endParaRPr lang="en-US"/>
           </a:p>
@@ -11400,7 +11504,7 @@
           <a:p>
             <a:fld id="{7D31F0D8-39C5-4C77-A52E-168D39363794}" type="datetimeFigureOut">
               <a:rPr lang="en-US" smtClean="0"/>
-              <a:t>8/10/2026</a:t>
+              <a:t>8/13/2026</a:t>
             </a:fld>
             <a:endParaRPr lang="en-US"/>
           </a:p>
@@ -11614,7 +11718,7 @@
           <a:p>
             <a:fld id="{7D31F0D8-39C5-4C77-A52E-168D39363794}" type="datetimeFigureOut">
               <a:rPr lang="en-US" smtClean="0"/>
-              <a:t>8/10/2026</a:t>
+              <a:t>8/13/2026</a:t>
             </a:fld>
             <a:endParaRPr lang="en-US"/>
           </a:p>
@@ -12116,7 +12220,7 @@
           <a:p>
             <a:fld id="{7D31F0D8-39C5-4C77-A52E-168D39363794}" type="datetimeFigureOut">
               <a:rPr lang="en-US" smtClean="0"/>
-              <a:t>8/10/2026</a:t>
+              <a:t>8/13/2026</a:t>
             </a:fld>
             <a:endParaRPr lang="en-US"/>
           </a:p>
@@ -12540,7 +12644,7 @@
           <a:p>
             <a:fld id="{7D31F0D8-39C5-4C77-A52E-168D39363794}" type="datetimeFigureOut">
               <a:rPr lang="en-US" smtClean="0"/>
-              <a:t>8/10/2026</a:t>
+              <a:t>8/13/2026</a:t>
             </a:fld>
             <a:endParaRPr lang="en-US"/>
           </a:p>
@@ -13083,7 +13187,7 @@
           <a:p>
             <a:fld id="{7D31F0D8-39C5-4C77-A52E-168D39363794}" type="datetimeFigureOut">
               <a:rPr lang="en-US" smtClean="0"/>
-              <a:t>8/10/2026</a:t>
+              <a:t>8/13/2026</a:t>
             </a:fld>
             <a:endParaRPr lang="en-US"/>
           </a:p>
@@ -13805,7 +13909,7 @@
           <a:p>
             <a:fld id="{7D31F0D8-39C5-4C77-A52E-168D39363794}" type="datetimeFigureOut">
               <a:rPr lang="en-US" smtClean="0"/>
-              <a:t>8/10/2026</a:t>
+              <a:t>8/13/2026</a:t>
             </a:fld>
             <a:endParaRPr lang="en-US"/>
           </a:p>
@@ -14173,7 +14277,7 @@
           <a:p>
             <a:fld id="{7D31F0D8-39C5-4C77-A52E-168D39363794}" type="datetimeFigureOut">
               <a:rPr lang="en-US" smtClean="0"/>
-              <a:t>8/10/2026</a:t>
+              <a:t>8/13/2026</a:t>
             </a:fld>
             <a:endParaRPr lang="en-US"/>
           </a:p>
@@ -14416,7 +14520,7 @@
           <a:p>
             <a:fld id="{7D31F0D8-39C5-4C77-A52E-168D39363794}" type="datetimeFigureOut">
               <a:rPr lang="en-US" smtClean="0"/>
-              <a:t>8/10/2026</a:t>
+              <a:t>8/13/2026</a:t>
             </a:fld>
             <a:endParaRPr lang="en-US"/>
           </a:p>
@@ -15228,7 +15332,7 @@
 </p:sld>
 </file>
 
-<file path=ppt/slides/slide2.xml><?xml version="1.0" encoding="utf-8"?>
+<file path=ppt/slides/slide10.xml><?xml version="1.0" encoding="utf-8"?>
 <p:sld xmlns:a="http://schemas.openxmlformats.org/drawingml/2006/main" xmlns:r="http://schemas.openxmlformats.org/officeDocument/2006/relationships" xmlns:p="http://schemas.openxmlformats.org/presentationml/2006/main">
   <p:cSld>
     <p:spTree>
@@ -15247,10 +15351,10 @@
       </p:grpSpPr>
       <p:sp>
         <p:nvSpPr>
-          <p:cNvPr id="4" name="Title 3">
-            <a:extLst>
-              <a:ext uri="{FF2B5EF4-FFF2-40B4-BE49-F238E27FC236}">
-                <a16:creationId xmlns:a16="http://schemas.microsoft.com/office/drawing/2014/main" id="{1CA00E00-C367-ADDB-F470-130EDE3D0EE3}"/>
+          <p:cNvPr id="2" name="Title 1">
+            <a:extLst>
+              <a:ext uri="{FF2B5EF4-FFF2-40B4-BE49-F238E27FC236}">
+                <a16:creationId xmlns:a16="http://schemas.microsoft.com/office/drawing/2014/main" id="{352DF2B7-2ACF-AE2F-49BB-9F647CDFA66F}"/>
               </a:ext>
             </a:extLst>
           </p:cNvPr>
@@ -15263,29 +15367,500 @@
         </p:nvSpPr>
         <p:spPr>
           <a:xfrm>
-            <a:off x="301752" y="952499"/>
-            <a:ext cx="6751127" cy="1250871"/>
-          </a:xfrm>
-        </p:spPr>
-        <p:txBody>
-          <a:bodyPr anchor="b">
-            <a:normAutofit/>
+            <a:off x="429767" y="1578102"/>
+            <a:ext cx="7498080" cy="1106424"/>
+          </a:xfrm>
+        </p:spPr>
+        <p:txBody>
+          <a:bodyPr/>
+          <a:lstStyle/>
+          <a:p>
+            <a:r>
+              <a:rPr lang="en-US" dirty="0"/>
+              <a:t>Roadmap</a:t>
+            </a:r>
+          </a:p>
+        </p:txBody>
+      </p:sp>
+      <p:sp>
+        <p:nvSpPr>
+          <p:cNvPr id="7" name="Rectangle 6">
+            <a:extLst>
+              <a:ext uri="{FF2B5EF4-FFF2-40B4-BE49-F238E27FC236}">
+                <a16:creationId xmlns:a16="http://schemas.microsoft.com/office/drawing/2014/main" id="{B5FB133F-2387-42F7-48F8-0ED78ED45F46}"/>
+              </a:ext>
+            </a:extLst>
+          </p:cNvPr>
+          <p:cNvSpPr/>
+          <p:nvPr/>
+        </p:nvSpPr>
+        <p:spPr>
+          <a:xfrm>
+            <a:off x="5772912" y="530352"/>
+            <a:ext cx="5736336" cy="1389888"/>
+          </a:xfrm>
+          <a:prstGeom prst="rect">
+            <a:avLst/>
+          </a:prstGeom>
+          <a:noFill/>
+          <a:ln>
+            <a:solidFill>
+              <a:schemeClr val="tx1"/>
+            </a:solidFill>
+          </a:ln>
+        </p:spPr>
+        <p:style>
+          <a:lnRef idx="2">
+            <a:schemeClr val="accent1">
+              <a:shade val="15000"/>
+            </a:schemeClr>
+          </a:lnRef>
+          <a:fillRef idx="1">
+            <a:schemeClr val="accent1"/>
+          </a:fillRef>
+          <a:effectRef idx="0">
+            <a:schemeClr val="accent1"/>
+          </a:effectRef>
+          <a:fontRef idx="minor">
+            <a:schemeClr val="lt1"/>
+          </a:fontRef>
+        </p:style>
+        <p:txBody>
+          <a:bodyPr rtlCol="0" anchor="ctr"/>
+          <a:lstStyle/>
+          <a:p>
+            <a:pPr marL="342900" indent="-342900">
+              <a:buFont typeface="Arial" panose="020B0604020202020204" pitchFamily="34" charset="0"/>
+              <a:buChar char="•"/>
+            </a:pPr>
+            <a:r>
+              <a:rPr lang="en-US" sz="2000" dirty="0"/>
+              <a:t>Finalize release date pipeline</a:t>
+            </a:r>
+          </a:p>
+          <a:p>
+            <a:pPr marL="342900" indent="-342900">
+              <a:buFont typeface="Arial" panose="020B0604020202020204" pitchFamily="34" charset="0"/>
+              <a:buChar char="•"/>
+            </a:pPr>
+            <a:r>
+              <a:rPr lang="en-US" sz="2000" dirty="0"/>
+              <a:t>App Store launch</a:t>
+            </a:r>
+          </a:p>
+          <a:p>
+            <a:pPr marL="342900" indent="-342900">
+              <a:buFont typeface="Arial" panose="020B0604020202020204" pitchFamily="34" charset="0"/>
+              <a:buChar char="•"/>
+            </a:pPr>
+            <a:r>
+              <a:rPr lang="en-US" sz="2000" dirty="0"/>
+              <a:t>Initial paid tier at $5/lifetime for early users</a:t>
+            </a:r>
+          </a:p>
+        </p:txBody>
+      </p:sp>
+      <p:sp>
+        <p:nvSpPr>
+          <p:cNvPr id="13" name="Rectangle 12">
+            <a:extLst>
+              <a:ext uri="{FF2B5EF4-FFF2-40B4-BE49-F238E27FC236}">
+                <a16:creationId xmlns:a16="http://schemas.microsoft.com/office/drawing/2014/main" id="{AD0E9EED-EB3F-446D-9BA6-D9B59BFD0B63}"/>
+              </a:ext>
+            </a:extLst>
+          </p:cNvPr>
+          <p:cNvSpPr/>
+          <p:nvPr/>
+        </p:nvSpPr>
+        <p:spPr>
+          <a:xfrm>
+            <a:off x="5772912" y="2484120"/>
+            <a:ext cx="5736336" cy="1106424"/>
+          </a:xfrm>
+          <a:prstGeom prst="rect">
+            <a:avLst/>
+          </a:prstGeom>
+          <a:noFill/>
+          <a:ln>
+            <a:solidFill>
+              <a:schemeClr val="tx1"/>
+            </a:solidFill>
+          </a:ln>
+        </p:spPr>
+        <p:style>
+          <a:lnRef idx="2">
+            <a:schemeClr val="accent1">
+              <a:shade val="15000"/>
+            </a:schemeClr>
+          </a:lnRef>
+          <a:fillRef idx="1">
+            <a:schemeClr val="accent1"/>
+          </a:fillRef>
+          <a:effectRef idx="0">
+            <a:schemeClr val="accent1"/>
+          </a:effectRef>
+          <a:fontRef idx="minor">
+            <a:schemeClr val="lt1"/>
+          </a:fontRef>
+        </p:style>
+        <p:txBody>
+          <a:bodyPr rtlCol="0" anchor="ctr"/>
+          <a:lstStyle/>
+          <a:p>
+            <a:pPr marL="342900" indent="-342900">
+              <a:buFont typeface="Arial" panose="020B0604020202020204" pitchFamily="34" charset="0"/>
+              <a:buChar char="•"/>
+            </a:pPr>
+            <a:r>
+              <a:rPr lang="en-US" sz="2000" dirty="0"/>
+              <a:t>Implement personalized recommendations</a:t>
+            </a:r>
+          </a:p>
+          <a:p>
+            <a:pPr marL="342900" indent="-342900">
+              <a:buFont typeface="Arial" panose="020B0604020202020204" pitchFamily="34" charset="0"/>
+              <a:buChar char="•"/>
+            </a:pPr>
+            <a:r>
+              <a:rPr lang="en-US" sz="2000" dirty="0"/>
+              <a:t>Expand media types (books, live events, etc.)</a:t>
+            </a:r>
+          </a:p>
+          <a:p>
+            <a:pPr marL="342900" indent="-342900">
+              <a:buFont typeface="Arial" panose="020B0604020202020204" pitchFamily="34" charset="0"/>
+              <a:buChar char="•"/>
+            </a:pPr>
+            <a:r>
+              <a:rPr lang="en-US" sz="2000" dirty="0"/>
+              <a:t>Strengthen infrastructure for larger userbase</a:t>
+            </a:r>
+          </a:p>
+        </p:txBody>
+      </p:sp>
+      <p:sp>
+        <p:nvSpPr>
+          <p:cNvPr id="15" name="Rectangle 14">
+            <a:extLst>
+              <a:ext uri="{FF2B5EF4-FFF2-40B4-BE49-F238E27FC236}">
+                <a16:creationId xmlns:a16="http://schemas.microsoft.com/office/drawing/2014/main" id="{996D8C91-388D-951A-647D-6A5FADBDA29F}"/>
+              </a:ext>
+            </a:extLst>
+          </p:cNvPr>
+          <p:cNvSpPr/>
+          <p:nvPr/>
+        </p:nvSpPr>
+        <p:spPr>
+          <a:xfrm>
+            <a:off x="5772912" y="4154424"/>
+            <a:ext cx="5736336" cy="1389888"/>
+          </a:xfrm>
+          <a:prstGeom prst="rect">
+            <a:avLst/>
+          </a:prstGeom>
+          <a:noFill/>
+          <a:ln>
+            <a:solidFill>
+              <a:schemeClr val="tx1"/>
+            </a:solidFill>
+          </a:ln>
+        </p:spPr>
+        <p:style>
+          <a:lnRef idx="2">
+            <a:schemeClr val="accent1">
+              <a:shade val="15000"/>
+            </a:schemeClr>
+          </a:lnRef>
+          <a:fillRef idx="1">
+            <a:schemeClr val="accent1"/>
+          </a:fillRef>
+          <a:effectRef idx="0">
+            <a:schemeClr val="accent1"/>
+          </a:effectRef>
+          <a:fontRef idx="minor">
+            <a:schemeClr val="lt1"/>
+          </a:fontRef>
+        </p:style>
+        <p:txBody>
+          <a:bodyPr rtlCol="0" anchor="ctr"/>
+          <a:lstStyle/>
+          <a:p>
+            <a:pPr marL="342900" indent="-342900">
+              <a:buFont typeface="Arial" panose="020B0604020202020204" pitchFamily="34" charset="0"/>
+              <a:buChar char="•"/>
+            </a:pPr>
+            <a:r>
+              <a:rPr lang="en-US" sz="2000" dirty="0"/>
+              <a:t>Seek out direct data partnerships</a:t>
+            </a:r>
+          </a:p>
+          <a:p>
+            <a:pPr marL="342900" indent="-342900">
+              <a:buFont typeface="Arial" panose="020B0604020202020204" pitchFamily="34" charset="0"/>
+              <a:buChar char="•"/>
+            </a:pPr>
+            <a:r>
+              <a:rPr lang="en-US" sz="2000" dirty="0"/>
+              <a:t>Embeddable release-calendar widget</a:t>
+            </a:r>
+          </a:p>
+          <a:p>
+            <a:pPr marL="342900" indent="-342900">
+              <a:buFont typeface="Arial" panose="020B0604020202020204" pitchFamily="34" charset="0"/>
+              <a:buChar char="•"/>
+            </a:pPr>
+            <a:r>
+              <a:rPr lang="en-US" sz="2000" dirty="0"/>
+              <a:t>Explore affiliate revenue for storefront links</a:t>
+            </a:r>
+          </a:p>
+        </p:txBody>
+      </p:sp>
+      <p:sp>
+        <p:nvSpPr>
+          <p:cNvPr id="16" name="TextBox 15">
+            <a:extLst>
+              <a:ext uri="{FF2B5EF4-FFF2-40B4-BE49-F238E27FC236}">
+                <a16:creationId xmlns:a16="http://schemas.microsoft.com/office/drawing/2014/main" id="{40C505AC-0223-C127-BF84-5DF94E10BB1A}"/>
+              </a:ext>
+            </a:extLst>
+          </p:cNvPr>
+          <p:cNvSpPr txBox="1"/>
+          <p:nvPr/>
+        </p:nvSpPr>
+        <p:spPr>
+          <a:xfrm>
+            <a:off x="4050791" y="976175"/>
+            <a:ext cx="2029968" cy="461665"/>
+          </a:xfrm>
+          <a:prstGeom prst="rect">
+            <a:avLst/>
+          </a:prstGeom>
+          <a:noFill/>
+        </p:spPr>
+        <p:txBody>
+          <a:bodyPr wrap="square" rtlCol="0">
+            <a:spAutoFit/>
           </a:bodyPr>
           <a:lstStyle/>
           <a:p>
             <a:r>
-              <a:rPr lang="en-US" sz="3600" dirty="0"/>
-              <a:t>Streaming Fatigue</a:t>
-            </a:r>
-          </a:p>
-        </p:txBody>
-      </p:sp>
-      <p:sp>
-        <p:nvSpPr>
-          <p:cNvPr id="5" name="Content Placeholder 4">
-            <a:extLst>
-              <a:ext uri="{FF2B5EF4-FFF2-40B4-BE49-F238E27FC236}">
-                <a16:creationId xmlns:a16="http://schemas.microsoft.com/office/drawing/2014/main" id="{50F6C4D4-3A44-E6A1-150C-320DC78E78FA}"/>
+              <a:rPr lang="en-US" sz="2400" dirty="0"/>
+              <a:t>Short-term</a:t>
+            </a:r>
+          </a:p>
+        </p:txBody>
+      </p:sp>
+      <p:sp>
+        <p:nvSpPr>
+          <p:cNvPr id="18" name="TextBox 17">
+            <a:extLst>
+              <a:ext uri="{FF2B5EF4-FFF2-40B4-BE49-F238E27FC236}">
+                <a16:creationId xmlns:a16="http://schemas.microsoft.com/office/drawing/2014/main" id="{1422B8CB-8630-6AC1-CFD5-CE5360763C35}"/>
+              </a:ext>
+            </a:extLst>
+          </p:cNvPr>
+          <p:cNvSpPr txBox="1"/>
+          <p:nvPr/>
+        </p:nvSpPr>
+        <p:spPr>
+          <a:xfrm>
+            <a:off x="4066032" y="2806499"/>
+            <a:ext cx="2029968" cy="461665"/>
+          </a:xfrm>
+          <a:prstGeom prst="rect">
+            <a:avLst/>
+          </a:prstGeom>
+          <a:noFill/>
+        </p:spPr>
+        <p:txBody>
+          <a:bodyPr wrap="square" rtlCol="0">
+            <a:spAutoFit/>
+          </a:bodyPr>
+          <a:lstStyle/>
+          <a:p>
+            <a:r>
+              <a:rPr lang="en-US" sz="2400" dirty="0"/>
+              <a:t>Mid-term</a:t>
+            </a:r>
+          </a:p>
+        </p:txBody>
+      </p:sp>
+      <p:sp>
+        <p:nvSpPr>
+          <p:cNvPr id="20" name="TextBox 19">
+            <a:extLst>
+              <a:ext uri="{FF2B5EF4-FFF2-40B4-BE49-F238E27FC236}">
+                <a16:creationId xmlns:a16="http://schemas.microsoft.com/office/drawing/2014/main" id="{4BE092C5-BB83-FB52-C83B-8B06D8DCB1E0}"/>
+              </a:ext>
+            </a:extLst>
+          </p:cNvPr>
+          <p:cNvSpPr txBox="1"/>
+          <p:nvPr/>
+        </p:nvSpPr>
+        <p:spPr>
+          <a:xfrm>
+            <a:off x="4066032" y="4618535"/>
+            <a:ext cx="2029968" cy="461665"/>
+          </a:xfrm>
+          <a:prstGeom prst="rect">
+            <a:avLst/>
+          </a:prstGeom>
+          <a:noFill/>
+        </p:spPr>
+        <p:txBody>
+          <a:bodyPr wrap="square" rtlCol="0">
+            <a:spAutoFit/>
+          </a:bodyPr>
+          <a:lstStyle/>
+          <a:p>
+            <a:r>
+              <a:rPr lang="en-US" sz="2400" dirty="0"/>
+              <a:t>Long-term</a:t>
+            </a:r>
+          </a:p>
+        </p:txBody>
+      </p:sp>
+      <p:sp>
+        <p:nvSpPr>
+          <p:cNvPr id="21" name="Arrow: Down 20">
+            <a:extLst>
+              <a:ext uri="{FF2B5EF4-FFF2-40B4-BE49-F238E27FC236}">
+                <a16:creationId xmlns:a16="http://schemas.microsoft.com/office/drawing/2014/main" id="{C8D94CF0-3024-70EB-0D2D-B61400EF13E3}"/>
+              </a:ext>
+            </a:extLst>
+          </p:cNvPr>
+          <p:cNvSpPr/>
+          <p:nvPr/>
+        </p:nvSpPr>
+        <p:spPr>
+          <a:xfrm>
+            <a:off x="8471916" y="2069592"/>
+            <a:ext cx="338328" cy="265176"/>
+          </a:xfrm>
+          <a:prstGeom prst="downArrow">
+            <a:avLst/>
+          </a:prstGeom>
+          <a:noFill/>
+          <a:ln>
+            <a:solidFill>
+              <a:schemeClr val="tx1"/>
+            </a:solidFill>
+          </a:ln>
+        </p:spPr>
+        <p:style>
+          <a:lnRef idx="2">
+            <a:schemeClr val="accent1">
+              <a:shade val="15000"/>
+            </a:schemeClr>
+          </a:lnRef>
+          <a:fillRef idx="1">
+            <a:schemeClr val="accent1"/>
+          </a:fillRef>
+          <a:effectRef idx="0">
+            <a:schemeClr val="accent1"/>
+          </a:effectRef>
+          <a:fontRef idx="minor">
+            <a:schemeClr val="lt1"/>
+          </a:fontRef>
+        </p:style>
+        <p:txBody>
+          <a:bodyPr rtlCol="0" anchor="ctr"/>
+          <a:lstStyle/>
+          <a:p>
+            <a:pPr algn="ctr"/>
+            <a:endParaRPr lang="en-US"/>
+          </a:p>
+        </p:txBody>
+      </p:sp>
+      <p:sp>
+        <p:nvSpPr>
+          <p:cNvPr id="23" name="Arrow: Down 22">
+            <a:extLst>
+              <a:ext uri="{FF2B5EF4-FFF2-40B4-BE49-F238E27FC236}">
+                <a16:creationId xmlns:a16="http://schemas.microsoft.com/office/drawing/2014/main" id="{6A00D220-69CD-BD2F-6C91-EB666C98C0AE}"/>
+              </a:ext>
+            </a:extLst>
+          </p:cNvPr>
+          <p:cNvSpPr/>
+          <p:nvPr/>
+        </p:nvSpPr>
+        <p:spPr>
+          <a:xfrm>
+            <a:off x="8471916" y="3742944"/>
+            <a:ext cx="338328" cy="265176"/>
+          </a:xfrm>
+          <a:prstGeom prst="downArrow">
+            <a:avLst/>
+          </a:prstGeom>
+          <a:noFill/>
+          <a:ln>
+            <a:solidFill>
+              <a:schemeClr val="tx1"/>
+            </a:solidFill>
+          </a:ln>
+        </p:spPr>
+        <p:style>
+          <a:lnRef idx="2">
+            <a:schemeClr val="accent1">
+              <a:shade val="15000"/>
+            </a:schemeClr>
+          </a:lnRef>
+          <a:fillRef idx="1">
+            <a:schemeClr val="accent1"/>
+          </a:fillRef>
+          <a:effectRef idx="0">
+            <a:schemeClr val="accent1"/>
+          </a:effectRef>
+          <a:fontRef idx="minor">
+            <a:schemeClr val="lt1"/>
+          </a:fontRef>
+        </p:style>
+        <p:txBody>
+          <a:bodyPr rtlCol="0" anchor="ctr"/>
+          <a:lstStyle/>
+          <a:p>
+            <a:pPr algn="ctr"/>
+            <a:endParaRPr lang="en-US"/>
+          </a:p>
+        </p:txBody>
+      </p:sp>
+    </p:spTree>
+    <p:extLst>
+      <p:ext uri="{BB962C8B-B14F-4D97-AF65-F5344CB8AC3E}">
+        <p14:creationId xmlns:p14="http://schemas.microsoft.com/office/powerpoint/2010/main" val="3472879271"/>
+      </p:ext>
+    </p:extLst>
+  </p:cSld>
+  <p:clrMapOvr>
+    <a:masterClrMapping/>
+  </p:clrMapOvr>
+</p:sld>
+</file>
+
+<file path=ppt/slides/slide11.xml><?xml version="1.0" encoding="utf-8"?>
+<p:sld xmlns:a="http://schemas.openxmlformats.org/drawingml/2006/main" xmlns:r="http://schemas.openxmlformats.org/officeDocument/2006/relationships" xmlns:p="http://schemas.openxmlformats.org/presentationml/2006/main">
+  <p:cSld>
+    <p:spTree>
+      <p:nvGrpSpPr>
+        <p:cNvPr id="1" name=""/>
+        <p:cNvGrpSpPr/>
+        <p:nvPr/>
+      </p:nvGrpSpPr>
+      <p:grpSpPr>
+        <a:xfrm>
+          <a:off x="0" y="0"/>
+          <a:ext cx="0" cy="0"/>
+          <a:chOff x="0" y="0"/>
+          <a:chExt cx="0" cy="0"/>
+        </a:xfrm>
+      </p:grpSpPr>
+      <p:sp>
+        <p:nvSpPr>
+          <p:cNvPr id="2" name="Title 1">
+            <a:extLst>
+              <a:ext uri="{FF2B5EF4-FFF2-40B4-BE49-F238E27FC236}">
+                <a16:creationId xmlns:a16="http://schemas.microsoft.com/office/drawing/2014/main" id="{82B3AAF7-AA83-C46C-5B40-3C886D2C17FC}"/>
               </a:ext>
             </a:extLst>
           </p:cNvPr>
@@ -15293,19 +15868,40 @@
             <a:spLocks noGrp="1"/>
           </p:cNvSpPr>
           <p:nvPr>
-            <p:ph sz="quarter" idx="14"/>
-          </p:nvPr>
-        </p:nvSpPr>
-        <p:spPr>
-          <a:xfrm>
-            <a:off x="301752" y="2410518"/>
-            <a:ext cx="6755514" cy="3807402"/>
-          </a:xfrm>
-        </p:spPr>
-        <p:txBody>
-          <a:bodyPr>
-            <a:normAutofit/>
-          </a:bodyPr>
+            <p:ph type="title"/>
+          </p:nvPr>
+        </p:nvSpPr>
+        <p:spPr/>
+        <p:txBody>
+          <a:bodyPr/>
+          <a:lstStyle/>
+          <a:p>
+            <a:r>
+              <a:rPr lang="en-US" dirty="0"/>
+              <a:t>Sources</a:t>
+            </a:r>
+          </a:p>
+        </p:txBody>
+      </p:sp>
+      <p:sp>
+        <p:nvSpPr>
+          <p:cNvPr id="3" name="Content Placeholder 2">
+            <a:extLst>
+              <a:ext uri="{FF2B5EF4-FFF2-40B4-BE49-F238E27FC236}">
+                <a16:creationId xmlns:a16="http://schemas.microsoft.com/office/drawing/2014/main" id="{8CB2B0BC-F208-466E-ED95-76A6A98D0312}"/>
+              </a:ext>
+            </a:extLst>
+          </p:cNvPr>
+          <p:cNvSpPr>
+            <a:spLocks noGrp="1"/>
+          </p:cNvSpPr>
+          <p:nvPr>
+            <p:ph sz="quarter" idx="13"/>
+          </p:nvPr>
+        </p:nvSpPr>
+        <p:spPr/>
+        <p:txBody>
+          <a:bodyPr/>
           <a:lstStyle/>
           <a:p>
             <a:pPr marL="285750" indent="-285750">
@@ -15313,9 +15909,12 @@
               <a:buChar char="•"/>
             </a:pPr>
             <a:r>
-              <a:rPr lang="en-US" dirty="0"/>
-              <a:t>43% of Americans plan to cancel a streaming service in the next 3 months</a:t>
-            </a:r>
+              <a:rPr lang="en-US" dirty="0">
+                <a:hlinkClick r:id="rId2"/>
+              </a:rPr>
+              <a:t>Streaming Media Survey: Viewers Can't Find What To Watch</a:t>
+            </a:r>
+            <a:endParaRPr lang="en-US" dirty="0"/>
           </a:p>
           <a:p>
             <a:pPr marL="285750" indent="-285750">
@@ -15323,9 +15922,12 @@
               <a:buChar char="•"/>
             </a:pPr>
             <a:r>
-              <a:rPr lang="en-US" dirty="0"/>
-              <a:t>The average American spends 110 hours per year scrolling streaming services deciding what to watch</a:t>
-            </a:r>
+              <a:rPr lang="en-US" dirty="0">
+                <a:hlinkClick r:id="rId3"/>
+              </a:rPr>
+              <a:t>Streaming Fatigue Report 2026: How Price Hikes Are Changing the Way Americans Watch TV | Reviews.org</a:t>
+            </a:r>
+            <a:endParaRPr lang="en-US" dirty="0"/>
           </a:p>
           <a:p>
             <a:pPr marL="285750" indent="-285750">
@@ -15333,39 +15935,12 @@
               <a:buChar char="•"/>
             </a:pPr>
             <a:r>
-              <a:rPr lang="en-US" dirty="0"/>
-              <a:t>Daily media releases are growing exponentially:</a:t>
-            </a:r>
-          </a:p>
-          <a:p>
-            <a:pPr marL="514350" lvl="1" indent="-285750">
-              <a:buFont typeface="Arial" panose="020B0604020202020204" pitchFamily="34" charset="0"/>
-              <a:buChar char="•"/>
-            </a:pPr>
-            <a:r>
-              <a:rPr lang="en-US" dirty="0"/>
-              <a:t>~26 new films released every day</a:t>
-            </a:r>
-          </a:p>
-          <a:p>
-            <a:pPr marL="514350" lvl="1" indent="-285750">
-              <a:buFont typeface="Arial" panose="020B0604020202020204" pitchFamily="34" charset="0"/>
-              <a:buChar char="•"/>
-            </a:pPr>
-            <a:r>
-              <a:rPr lang="en-US" dirty="0"/>
-              <a:t>~14 episodes of television released every day</a:t>
-            </a:r>
-          </a:p>
-          <a:p>
-            <a:pPr marL="514350" lvl="1" indent="-285750">
-              <a:buFont typeface="Arial" panose="020B0604020202020204" pitchFamily="34" charset="0"/>
-              <a:buChar char="•"/>
-            </a:pPr>
-            <a:r>
-              <a:rPr lang="en-US" dirty="0"/>
-              <a:t>~38 video game releases every day</a:t>
-            </a:r>
+              <a:rPr lang="en-US" dirty="0">
+                <a:hlinkClick r:id="rId4"/>
+              </a:rPr>
+              <a:t>Lights, Camera, Action— How Many Movies Are Released Daily Around the World? - System Ent Corp</a:t>
+            </a:r>
+            <a:endParaRPr lang="en-US" dirty="0"/>
           </a:p>
           <a:p>
             <a:pPr marL="285750" indent="-285750">
@@ -15373,8 +15948,114 @@
               <a:buChar char="•"/>
             </a:pPr>
             <a:r>
-              <a:rPr lang="en-US" dirty="0"/>
-              <a:t>As of 2026 there are over 80 streaming services operating in the US</a:t>
+              <a:rPr lang="en-US" dirty="0">
+                <a:hlinkClick r:id="rId5"/>
+              </a:rPr>
+              <a:t>How Many Video Games Exist in Total? – </a:t>
+            </a:r>
+            <a:r>
+              <a:rPr lang="en-US" dirty="0" err="1">
+                <a:hlinkClick r:id="rId5"/>
+              </a:rPr>
+              <a:t>WorthyGamer</a:t>
+            </a:r>
+            <a:endParaRPr lang="en-US" dirty="0"/>
+          </a:p>
+          <a:p>
+            <a:pPr marL="285750" indent="-285750">
+              <a:buFont typeface="Arial" panose="020B0604020202020204" pitchFamily="34" charset="0"/>
+              <a:buChar char="•"/>
+            </a:pPr>
+            <a:r>
+              <a:rPr lang="en-US" dirty="0">
+                <a:hlinkClick r:id="rId6"/>
+              </a:rPr>
+              <a:t>Media Entertainment Industry Statistics 2026</a:t>
+            </a:r>
+            <a:endParaRPr lang="en-US" dirty="0"/>
+          </a:p>
+          <a:p>
+            <a:pPr marL="285750" indent="-285750">
+              <a:buFont typeface="Arial" panose="020B0604020202020204" pitchFamily="34" charset="0"/>
+              <a:buChar char="•"/>
+            </a:pPr>
+            <a:r>
+              <a:rPr lang="en-US" dirty="0">
+                <a:hlinkClick r:id="rId7"/>
+              </a:rPr>
+              <a:t>How Many Streaming Services Are There? Here's a List | Streaming Better</a:t>
+            </a:r>
+            <a:endParaRPr lang="en-US" dirty="0"/>
+          </a:p>
+        </p:txBody>
+      </p:sp>
+    </p:spTree>
+    <p:extLst>
+      <p:ext uri="{BB962C8B-B14F-4D97-AF65-F5344CB8AC3E}">
+        <p14:creationId xmlns:p14="http://schemas.microsoft.com/office/powerpoint/2010/main" val="2992196600"/>
+      </p:ext>
+    </p:extLst>
+  </p:cSld>
+  <p:clrMapOvr>
+    <a:masterClrMapping/>
+  </p:clrMapOvr>
+</p:sld>
+</file>
+
+<file path=ppt/slides/slide2.xml><?xml version="1.0" encoding="utf-8"?>
+<p:sld xmlns:a="http://schemas.openxmlformats.org/drawingml/2006/main" xmlns:r="http://schemas.openxmlformats.org/officeDocument/2006/relationships" xmlns:p="http://schemas.openxmlformats.org/presentationml/2006/main">
+  <p:cSld>
+    <p:spTree>
+      <p:nvGrpSpPr>
+        <p:cNvPr id="1" name="">
+          <a:extLst>
+            <a:ext uri="{FF2B5EF4-FFF2-40B4-BE49-F238E27FC236}">
+              <a16:creationId xmlns:a16="http://schemas.microsoft.com/office/drawing/2014/main" id="{B80B4276-F1BB-14AA-F748-1E2E14D8666B}"/>
+            </a:ext>
+          </a:extLst>
+        </p:cNvPr>
+        <p:cNvGrpSpPr/>
+        <p:nvPr/>
+      </p:nvGrpSpPr>
+      <p:grpSpPr>
+        <a:xfrm>
+          <a:off x="0" y="0"/>
+          <a:ext cx="0" cy="0"/>
+          <a:chOff x="0" y="0"/>
+          <a:chExt cx="0" cy="0"/>
+        </a:xfrm>
+      </p:grpSpPr>
+      <p:sp>
+        <p:nvSpPr>
+          <p:cNvPr id="4" name="Title 3">
+            <a:extLst>
+              <a:ext uri="{FF2B5EF4-FFF2-40B4-BE49-F238E27FC236}">
+                <a16:creationId xmlns:a16="http://schemas.microsoft.com/office/drawing/2014/main" id="{C5CDAD99-6B68-7A71-39B3-03A36B3C67DB}"/>
+              </a:ext>
+            </a:extLst>
+          </p:cNvPr>
+          <p:cNvSpPr>
+            <a:spLocks noGrp="1"/>
+          </p:cNvSpPr>
+          <p:nvPr>
+            <p:ph type="title"/>
+          </p:nvPr>
+        </p:nvSpPr>
+        <p:spPr>
+          <a:xfrm>
+            <a:off x="301752" y="979931"/>
+            <a:ext cx="6751127" cy="718582"/>
+          </a:xfrm>
+        </p:spPr>
+        <p:txBody>
+          <a:bodyPr anchor="b">
+            <a:noAutofit/>
+          </a:bodyPr>
+          <a:lstStyle/>
+          <a:p>
+            <a:r>
+              <a:rPr lang="en-US" sz="4000" dirty="0"/>
+              <a:t>Streaming Fatigue</a:t>
             </a:r>
           </a:p>
         </p:txBody>
@@ -15384,7 +16065,7 @@
           <p:cNvPr id="6" name="Picture 5" descr="Stream Fatigue? Americans Spent 23% Less on Streaming Services in 2024,  Study Finds : r/cordcutters">
             <a:extLst>
               <a:ext uri="{FF2B5EF4-FFF2-40B4-BE49-F238E27FC236}">
-                <a16:creationId xmlns:a16="http://schemas.microsoft.com/office/drawing/2014/main" id="{6100079C-ABDB-3CBE-68A6-9B63E259A7CD}"/>
+                <a16:creationId xmlns:a16="http://schemas.microsoft.com/office/drawing/2014/main" id="{6DF0A147-2C28-088D-433C-12AFB4169A54}"/>
               </a:ext>
             </a:extLst>
           </p:cNvPr>
@@ -15411,10 +16092,223 @@
           <a:noFill/>
         </p:spPr>
       </p:pic>
+      <p:sp>
+        <p:nvSpPr>
+          <p:cNvPr id="7" name="TextBox 6">
+            <a:extLst>
+              <a:ext uri="{FF2B5EF4-FFF2-40B4-BE49-F238E27FC236}">
+                <a16:creationId xmlns:a16="http://schemas.microsoft.com/office/drawing/2014/main" id="{55ED0D43-4DB8-8105-7E73-D747EC76D61D}"/>
+              </a:ext>
+            </a:extLst>
+          </p:cNvPr>
+          <p:cNvSpPr txBox="1"/>
+          <p:nvPr/>
+        </p:nvSpPr>
+        <p:spPr>
+          <a:xfrm>
+            <a:off x="762229" y="1960546"/>
+            <a:ext cx="4868640" cy="738664"/>
+          </a:xfrm>
+          <a:prstGeom prst="rect">
+            <a:avLst/>
+          </a:prstGeom>
+          <a:noFill/>
+        </p:spPr>
+        <p:txBody>
+          <a:bodyPr wrap="none" rtlCol="0">
+            <a:spAutoFit/>
+          </a:bodyPr>
+          <a:lstStyle/>
+          <a:p>
+            <a:r>
+              <a:rPr lang="en-US" sz="3200" b="1" dirty="0"/>
+              <a:t>110</a:t>
+            </a:r>
+            <a:r>
+              <a:rPr lang="en-US" sz="3200" dirty="0"/>
+              <a:t> Hours</a:t>
+            </a:r>
+          </a:p>
+          <a:p>
+            <a:r>
+              <a:rPr lang="en-US" sz="1000" dirty="0"/>
+              <a:t> average time spent annually scrolling through streaming sites deciding what to watch</a:t>
+            </a:r>
+          </a:p>
+        </p:txBody>
+      </p:sp>
+      <p:sp>
+        <p:nvSpPr>
+          <p:cNvPr id="9" name="TextBox 8">
+            <a:extLst>
+              <a:ext uri="{FF2B5EF4-FFF2-40B4-BE49-F238E27FC236}">
+                <a16:creationId xmlns:a16="http://schemas.microsoft.com/office/drawing/2014/main" id="{51E8967A-5CF2-538A-FD0E-B022C75D679F}"/>
+              </a:ext>
+            </a:extLst>
+          </p:cNvPr>
+          <p:cNvSpPr txBox="1"/>
+          <p:nvPr/>
+        </p:nvSpPr>
+        <p:spPr>
+          <a:xfrm>
+            <a:off x="780517" y="2896648"/>
+            <a:ext cx="2954655" cy="738664"/>
+          </a:xfrm>
+          <a:prstGeom prst="rect">
+            <a:avLst/>
+          </a:prstGeom>
+          <a:noFill/>
+        </p:spPr>
+        <p:txBody>
+          <a:bodyPr wrap="none" rtlCol="0">
+            <a:spAutoFit/>
+          </a:bodyPr>
+          <a:lstStyle/>
+          <a:p>
+            <a:r>
+              <a:rPr lang="en-US" sz="3200" b="1" dirty="0"/>
+              <a:t>80</a:t>
+            </a:r>
+            <a:r>
+              <a:rPr lang="en-US" sz="3200" dirty="0"/>
+              <a:t> Platforms</a:t>
+            </a:r>
+          </a:p>
+          <a:p>
+            <a:r>
+              <a:rPr lang="en-US" sz="1000" dirty="0"/>
+              <a:t> streaming services operating in the US as of 2026</a:t>
+            </a:r>
+          </a:p>
+        </p:txBody>
+      </p:sp>
+      <p:sp>
+        <p:nvSpPr>
+          <p:cNvPr id="11" name="TextBox 10">
+            <a:extLst>
+              <a:ext uri="{FF2B5EF4-FFF2-40B4-BE49-F238E27FC236}">
+                <a16:creationId xmlns:a16="http://schemas.microsoft.com/office/drawing/2014/main" id="{45440075-5454-15FC-6576-F998D1D9B1BE}"/>
+              </a:ext>
+            </a:extLst>
+          </p:cNvPr>
+          <p:cNvSpPr txBox="1"/>
+          <p:nvPr/>
+        </p:nvSpPr>
+        <p:spPr>
+          <a:xfrm>
+            <a:off x="780517" y="3897345"/>
+            <a:ext cx="2533835" cy="584775"/>
+          </a:xfrm>
+          <a:prstGeom prst="rect">
+            <a:avLst/>
+          </a:prstGeom>
+          <a:noFill/>
+        </p:spPr>
+        <p:txBody>
+          <a:bodyPr wrap="none" rtlCol="0">
+            <a:spAutoFit/>
+          </a:bodyPr>
+          <a:lstStyle/>
+          <a:p>
+            <a:r>
+              <a:rPr lang="en-US" sz="3200" b="1" dirty="0"/>
+              <a:t>26</a:t>
+            </a:r>
+            <a:r>
+              <a:rPr lang="en-US" sz="3200" dirty="0"/>
+              <a:t> New Films</a:t>
+            </a:r>
+          </a:p>
+        </p:txBody>
+      </p:sp>
+      <p:sp>
+        <p:nvSpPr>
+          <p:cNvPr id="13" name="TextBox 12">
+            <a:extLst>
+              <a:ext uri="{FF2B5EF4-FFF2-40B4-BE49-F238E27FC236}">
+                <a16:creationId xmlns:a16="http://schemas.microsoft.com/office/drawing/2014/main" id="{876E9A3A-55D4-12B2-F67C-7E2F06B66EDA}"/>
+              </a:ext>
+            </a:extLst>
+          </p:cNvPr>
+          <p:cNvSpPr txBox="1"/>
+          <p:nvPr/>
+        </p:nvSpPr>
+        <p:spPr>
+          <a:xfrm>
+            <a:off x="753085" y="4404567"/>
+            <a:ext cx="2941831" cy="584775"/>
+          </a:xfrm>
+          <a:prstGeom prst="rect">
+            <a:avLst/>
+          </a:prstGeom>
+          <a:noFill/>
+        </p:spPr>
+        <p:txBody>
+          <a:bodyPr wrap="none" rtlCol="0">
+            <a:spAutoFit/>
+          </a:bodyPr>
+          <a:lstStyle/>
+          <a:p>
+            <a:r>
+              <a:rPr lang="en-US" sz="3200" b="1" dirty="0"/>
+              <a:t>14</a:t>
+            </a:r>
+            <a:r>
+              <a:rPr lang="en-US" sz="3200" dirty="0"/>
+              <a:t> TV Episodes</a:t>
+            </a:r>
+          </a:p>
+        </p:txBody>
+      </p:sp>
+      <p:sp>
+        <p:nvSpPr>
+          <p:cNvPr id="15" name="TextBox 14">
+            <a:extLst>
+              <a:ext uri="{FF2B5EF4-FFF2-40B4-BE49-F238E27FC236}">
+                <a16:creationId xmlns:a16="http://schemas.microsoft.com/office/drawing/2014/main" id="{45047EF6-83A2-29D6-4BCC-483E15F67538}"/>
+              </a:ext>
+            </a:extLst>
+          </p:cNvPr>
+          <p:cNvSpPr txBox="1"/>
+          <p:nvPr/>
+        </p:nvSpPr>
+        <p:spPr>
+          <a:xfrm>
+            <a:off x="780517" y="4911788"/>
+            <a:ext cx="3106748" cy="738664"/>
+          </a:xfrm>
+          <a:prstGeom prst="rect">
+            <a:avLst/>
+          </a:prstGeom>
+          <a:noFill/>
+        </p:spPr>
+        <p:txBody>
+          <a:bodyPr wrap="none" rtlCol="0">
+            <a:spAutoFit/>
+          </a:bodyPr>
+          <a:lstStyle/>
+          <a:p>
+            <a:r>
+              <a:rPr lang="en-US" sz="3200" b="1" dirty="0"/>
+              <a:t>38</a:t>
+            </a:r>
+            <a:r>
+              <a:rPr lang="en-US" sz="3200" dirty="0"/>
+              <a:t> Video Games</a:t>
+            </a:r>
+          </a:p>
+          <a:p>
+            <a:r>
+              <a:rPr lang="en-US" sz="1000" dirty="0"/>
+              <a:t> average releases per day</a:t>
+            </a:r>
+          </a:p>
+        </p:txBody>
+      </p:sp>
     </p:spTree>
     <p:extLst>
       <p:ext uri="{BB962C8B-B14F-4D97-AF65-F5344CB8AC3E}">
-        <p14:creationId xmlns:p14="http://schemas.microsoft.com/office/powerpoint/2010/main" val="1093483687"/>
+        <p14:creationId xmlns:p14="http://schemas.microsoft.com/office/powerpoint/2010/main" val="3298946407"/>
       </p:ext>
     </p:extLst>
   </p:cSld>
@@ -15791,241 +16685,104 @@
           <a:chExt cx="0" cy="0"/>
         </a:xfrm>
       </p:grpSpPr>
-      <p:sp>
-        <p:nvSpPr>
-          <p:cNvPr id="2" name="Title 1">
-            <a:extLst>
-              <a:ext uri="{FF2B5EF4-FFF2-40B4-BE49-F238E27FC236}">
-                <a16:creationId xmlns:a16="http://schemas.microsoft.com/office/drawing/2014/main" id="{07CBDF1C-6F0C-9506-E8B6-B4C5C2FDF3FF}"/>
-              </a:ext>
-            </a:extLst>
-          </p:cNvPr>
-          <p:cNvSpPr>
-            <a:spLocks noGrp="1"/>
-          </p:cNvSpPr>
-          <p:nvPr>
-            <p:ph type="title"/>
-          </p:nvPr>
-        </p:nvSpPr>
-        <p:spPr/>
-        <p:txBody>
-          <a:bodyPr>
-            <a:normAutofit/>
-          </a:bodyPr>
-          <a:lstStyle/>
-          <a:p>
-            <a:r>
-              <a:rPr lang="en-US" sz="3600" dirty="0"/>
-              <a:t>Compliment, not Competition</a:t>
-            </a:r>
-          </a:p>
-        </p:txBody>
-      </p:sp>
-      <p:sp>
-        <p:nvSpPr>
-          <p:cNvPr id="3" name="Text Placeholder 2">
-            <a:extLst>
-              <a:ext uri="{FF2B5EF4-FFF2-40B4-BE49-F238E27FC236}">
-                <a16:creationId xmlns:a16="http://schemas.microsoft.com/office/drawing/2014/main" id="{796D21AF-CEEF-6F4B-7619-95C09F2FAB86}"/>
-              </a:ext>
-            </a:extLst>
-          </p:cNvPr>
-          <p:cNvSpPr>
-            <a:spLocks noGrp="1"/>
-          </p:cNvSpPr>
-          <p:nvPr>
-            <p:ph type="body" idx="1"/>
-          </p:nvPr>
-        </p:nvSpPr>
-        <p:spPr/>
-        <p:txBody>
-          <a:bodyPr>
-            <a:normAutofit/>
-          </a:bodyPr>
-          <a:lstStyle/>
-          <a:p>
-            <a:r>
-              <a:rPr lang="en-US" sz="2400" dirty="0"/>
-              <a:t>Trackr</a:t>
-            </a:r>
-          </a:p>
-        </p:txBody>
-      </p:sp>
-      <p:sp>
-        <p:nvSpPr>
-          <p:cNvPr id="4" name="Content Placeholder 3">
-            <a:extLst>
-              <a:ext uri="{FF2B5EF4-FFF2-40B4-BE49-F238E27FC236}">
-                <a16:creationId xmlns:a16="http://schemas.microsoft.com/office/drawing/2014/main" id="{681C0A33-C56B-784B-F8F4-8ABACB07474A}"/>
-              </a:ext>
-            </a:extLst>
-          </p:cNvPr>
-          <p:cNvSpPr>
-            <a:spLocks noGrp="1"/>
-          </p:cNvSpPr>
-          <p:nvPr>
-            <p:ph sz="quarter" idx="18"/>
-          </p:nvPr>
-        </p:nvSpPr>
-        <p:spPr/>
-        <p:txBody>
-          <a:bodyPr>
-            <a:normAutofit/>
-          </a:bodyPr>
-          <a:lstStyle/>
-          <a:p>
-            <a:pPr marL="285750" indent="-285750">
-              <a:buFont typeface="Arial" panose="020B0604020202020204" pitchFamily="34" charset="0"/>
-              <a:buChar char="•"/>
-            </a:pPr>
-            <a:r>
-              <a:rPr lang="en-US" sz="2000" dirty="0"/>
-              <a:t>Tracking what you want to watch next</a:t>
-            </a:r>
-          </a:p>
-          <a:p>
-            <a:pPr marL="285750" indent="-285750">
-              <a:buFont typeface="Arial" panose="020B0604020202020204" pitchFamily="34" charset="0"/>
-              <a:buChar char="•"/>
-            </a:pPr>
-            <a:r>
-              <a:rPr lang="en-US" sz="2000" dirty="0"/>
-              <a:t>Multiple media types</a:t>
-            </a:r>
-          </a:p>
-          <a:p>
-            <a:pPr marL="285750" indent="-285750">
-              <a:buFont typeface="Arial" panose="020B0604020202020204" pitchFamily="34" charset="0"/>
-              <a:buChar char="•"/>
-            </a:pPr>
-            <a:r>
-              <a:rPr lang="en-US" sz="2000" dirty="0"/>
-              <a:t>Notifications for new releases</a:t>
-            </a:r>
-          </a:p>
-          <a:p>
-            <a:pPr marL="285750" indent="-285750">
-              <a:buFont typeface="Arial" panose="020B0604020202020204" pitchFamily="34" charset="0"/>
-              <a:buChar char="•"/>
-            </a:pPr>
-            <a:r>
-              <a:rPr lang="en-US" sz="2000" dirty="0"/>
-              <a:t>Can be used alongside other social platforms</a:t>
-            </a:r>
-          </a:p>
-        </p:txBody>
-      </p:sp>
-      <p:sp>
-        <p:nvSpPr>
-          <p:cNvPr id="5" name="Text Placeholder 4">
-            <a:extLst>
-              <a:ext uri="{FF2B5EF4-FFF2-40B4-BE49-F238E27FC236}">
-                <a16:creationId xmlns:a16="http://schemas.microsoft.com/office/drawing/2014/main" id="{8E0D72AB-82DA-C189-C6DC-34D2A11436ED}"/>
-              </a:ext>
-            </a:extLst>
-          </p:cNvPr>
-          <p:cNvSpPr>
-            <a:spLocks noGrp="1"/>
-          </p:cNvSpPr>
-          <p:nvPr>
-            <p:ph type="body" sz="quarter" idx="3"/>
-          </p:nvPr>
-        </p:nvSpPr>
-        <p:spPr/>
-        <p:txBody>
-          <a:bodyPr>
-            <a:normAutofit/>
-          </a:bodyPr>
-          <a:lstStyle/>
-          <a:p>
-            <a:r>
-              <a:rPr lang="en-US" sz="2400" dirty="0"/>
-              <a:t>Letterboxd and Others</a:t>
-            </a:r>
-          </a:p>
-        </p:txBody>
-      </p:sp>
-      <p:sp>
-        <p:nvSpPr>
-          <p:cNvPr id="6" name="Content Placeholder 5">
-            <a:extLst>
-              <a:ext uri="{FF2B5EF4-FFF2-40B4-BE49-F238E27FC236}">
-                <a16:creationId xmlns:a16="http://schemas.microsoft.com/office/drawing/2014/main" id="{C4CD8094-A248-C70D-66FF-90A926945558}"/>
-              </a:ext>
-            </a:extLst>
-          </p:cNvPr>
-          <p:cNvSpPr>
-            <a:spLocks noGrp="1"/>
-          </p:cNvSpPr>
-          <p:nvPr>
-            <p:ph sz="quarter" idx="19"/>
-          </p:nvPr>
-        </p:nvSpPr>
-        <p:spPr/>
-        <p:txBody>
-          <a:bodyPr>
-            <a:normAutofit/>
-          </a:bodyPr>
-          <a:lstStyle/>
-          <a:p>
-            <a:pPr marL="285750" indent="-285750">
-              <a:buFont typeface="Arial" panose="020B0604020202020204" pitchFamily="34" charset="0"/>
-              <a:buChar char="•"/>
-            </a:pPr>
-            <a:r>
-              <a:rPr lang="en-US" sz="2000" dirty="0"/>
-              <a:t>Tracking what you’ve already watched</a:t>
-            </a:r>
-          </a:p>
-          <a:p>
-            <a:pPr marL="285750" indent="-285750">
-              <a:buFont typeface="Arial" panose="020B0604020202020204" pitchFamily="34" charset="0"/>
-              <a:buChar char="•"/>
-            </a:pPr>
-            <a:r>
-              <a:rPr lang="en-US" sz="2000" dirty="0"/>
-              <a:t>Focus on one media type</a:t>
-            </a:r>
-          </a:p>
-          <a:p>
-            <a:pPr marL="285750" indent="-285750">
-              <a:buFont typeface="Arial" panose="020B0604020202020204" pitchFamily="34" charset="0"/>
-              <a:buChar char="•"/>
-            </a:pPr>
-            <a:r>
-              <a:rPr lang="en-US" sz="2000" dirty="0"/>
-              <a:t>No way to track new releases</a:t>
-            </a:r>
-          </a:p>
-          <a:p>
-            <a:pPr marL="285750" indent="-285750">
-              <a:buFont typeface="Arial" panose="020B0604020202020204" pitchFamily="34" charset="0"/>
-              <a:buChar char="•"/>
-            </a:pPr>
-            <a:r>
-              <a:rPr lang="en-US" sz="2000" dirty="0"/>
-              <a:t>Media tracking as a social media</a:t>
-            </a:r>
-          </a:p>
-          <a:p>
-            <a:pPr marL="285750" indent="-285750">
-              <a:buFont typeface="Arial" panose="020B0604020202020204" pitchFamily="34" charset="0"/>
-              <a:buChar char="•"/>
-            </a:pPr>
-            <a:endParaRPr lang="en-US" sz="2000" dirty="0"/>
-          </a:p>
-        </p:txBody>
-      </p:sp>
+      <p:pic>
+        <p:nvPicPr>
+          <p:cNvPr id="5" name="Picture 4">
+            <a:extLst>
+              <a:ext uri="{FF2B5EF4-FFF2-40B4-BE49-F238E27FC236}">
+                <a16:creationId xmlns:a16="http://schemas.microsoft.com/office/drawing/2014/main" id="{E2048217-DF25-0733-0CDD-384AAB3CA2F1}"/>
+              </a:ext>
+            </a:extLst>
+          </p:cNvPr>
+          <p:cNvPicPr>
+            <a:picLocks noChangeAspect="1"/>
+          </p:cNvPicPr>
+          <p:nvPr/>
+        </p:nvPicPr>
+        <p:blipFill>
+          <a:blip r:embed="rId2"/>
+          <a:stretch>
+            <a:fillRect/>
+          </a:stretch>
+        </p:blipFill>
+        <p:spPr>
+          <a:xfrm>
+            <a:off x="538733" y="1068529"/>
+            <a:ext cx="7325107" cy="5195110"/>
+          </a:xfrm>
+          <a:prstGeom prst="rect">
+            <a:avLst/>
+          </a:prstGeom>
+          <a:ln>
+            <a:solidFill>
+              <a:schemeClr val="bg1">
+                <a:lumMod val="85000"/>
+                <a:lumOff val="15000"/>
+              </a:schemeClr>
+            </a:solidFill>
+          </a:ln>
+        </p:spPr>
+      </p:pic>
+      <p:pic>
+        <p:nvPicPr>
+          <p:cNvPr id="7" name="Picture 6">
+            <a:extLst>
+              <a:ext uri="{FF2B5EF4-FFF2-40B4-BE49-F238E27FC236}">
+                <a16:creationId xmlns:a16="http://schemas.microsoft.com/office/drawing/2014/main" id="{11D0E8E4-B940-7B81-DC39-1E2D527EA780}"/>
+              </a:ext>
+            </a:extLst>
+          </p:cNvPr>
+          <p:cNvPicPr>
+            <a:picLocks noChangeAspect="1"/>
+          </p:cNvPicPr>
+          <p:nvPr/>
+        </p:nvPicPr>
+        <p:blipFill>
+          <a:blip r:embed="rId3"/>
+          <a:stretch>
+            <a:fillRect/>
+          </a:stretch>
+        </p:blipFill>
+        <p:spPr>
+          <a:xfrm>
+            <a:off x="8230136" y="1691640"/>
+            <a:ext cx="3529038" cy="3855488"/>
+          </a:xfrm>
+          <a:prstGeom prst="rect">
+            <a:avLst/>
+          </a:prstGeom>
+          <a:ln>
+            <a:solidFill>
+              <a:schemeClr val="bg1">
+                <a:lumMod val="85000"/>
+                <a:lumOff val="15000"/>
+              </a:schemeClr>
+            </a:solidFill>
+          </a:ln>
+        </p:spPr>
+      </p:pic>
     </p:spTree>
     <p:extLst>
       <p:ext uri="{BB962C8B-B14F-4D97-AF65-F5344CB8AC3E}">
-        <p14:creationId xmlns:p14="http://schemas.microsoft.com/office/powerpoint/2010/main" val="2107956701"/>
+        <p14:creationId xmlns:p14="http://schemas.microsoft.com/office/powerpoint/2010/main" val="3943467562"/>
       </p:ext>
     </p:extLst>
   </p:cSld>
   <p:clrMapOvr>
     <a:masterClrMapping/>
   </p:clrMapOvr>
+  <mc:AlternateContent xmlns:mc="http://schemas.openxmlformats.org/markup-compatibility/2006">
+    <mc:Choice xmlns:p14="http://schemas.microsoft.com/office/powerpoint/2010/main" Requires="p14">
+      <p:transition spd="med" p14:dur="700">
+        <p:fade/>
+      </p:transition>
+    </mc:Choice>
+    <mc:Fallback>
+      <p:transition spd="med">
+        <p:fade/>
+      </p:transition>
+    </mc:Fallback>
+  </mc:AlternateContent>
 </p:sld>
 </file>
 
@@ -16051,7 +16808,7 @@
           <p:cNvPr id="2" name="Title 1">
             <a:extLst>
               <a:ext uri="{FF2B5EF4-FFF2-40B4-BE49-F238E27FC236}">
-                <a16:creationId xmlns:a16="http://schemas.microsoft.com/office/drawing/2014/main" id="{55B010EC-0823-638A-A54B-085573D0CAFC}"/>
+                <a16:creationId xmlns:a16="http://schemas.microsoft.com/office/drawing/2014/main" id="{07CBDF1C-6F0C-9506-E8B6-B4C5C2FDF3FF}"/>
               </a:ext>
             </a:extLst>
           </p:cNvPr>
@@ -16062,60 +16819,219 @@
             <p:ph type="title"/>
           </p:nvPr>
         </p:nvSpPr>
-        <p:spPr>
-          <a:xfrm>
-            <a:off x="301752" y="722282"/>
-            <a:ext cx="9830017" cy="731520"/>
-          </a:xfrm>
-        </p:spPr>
-        <p:txBody>
-          <a:bodyPr anchor="b">
+        <p:spPr/>
+        <p:txBody>
+          <a:bodyPr>
             <a:normAutofit/>
           </a:bodyPr>
           <a:lstStyle/>
           <a:p>
             <a:r>
-              <a:rPr lang="en-US" sz="4000" dirty="0"/>
-              <a:t>Primary Features</a:t>
-            </a:r>
-          </a:p>
-        </p:txBody>
-      </p:sp>
-      <p:graphicFrame>
-        <p:nvGraphicFramePr>
-          <p:cNvPr id="5" name="Content Placeholder 2">
-            <a:extLst>
-              <a:ext uri="{FF2B5EF4-FFF2-40B4-BE49-F238E27FC236}">
-                <a16:creationId xmlns:a16="http://schemas.microsoft.com/office/drawing/2014/main" id="{3F1F8C0C-DC36-12BC-CB0E-02376481E29A}"/>
-              </a:ext>
-            </a:extLst>
-          </p:cNvPr>
-          <p:cNvGraphicFramePr>
-            <a:graphicFrameLocks noGrp="1"/>
-          </p:cNvGraphicFramePr>
-          <p:nvPr>
-            <p:ph sz="quarter" idx="13"/>
-            <p:extLst>
-              <p:ext uri="{D42A27DB-BD31-4B8C-83A1-F6EECF244321}">
-                <p14:modId xmlns:p14="http://schemas.microsoft.com/office/powerpoint/2010/main" val="1066573651"/>
-              </p:ext>
-            </p:extLst>
-          </p:nvPr>
-        </p:nvGraphicFramePr>
-        <p:xfrm>
-          <a:off x="301752" y="2011680"/>
-          <a:ext cx="11402568" cy="4389120"/>
-        </p:xfrm>
-        <a:graphic>
-          <a:graphicData uri="http://schemas.openxmlformats.org/drawingml/2006/diagram">
-            <dgm:relIds xmlns:dgm="http://schemas.openxmlformats.org/drawingml/2006/diagram" xmlns:r="http://schemas.openxmlformats.org/officeDocument/2006/relationships" r:dm="rId2" r:lo="rId3" r:qs="rId4" r:cs="rId5"/>
-          </a:graphicData>
-        </a:graphic>
-      </p:graphicFrame>
+              <a:rPr lang="en-US" sz="3600" dirty="0"/>
+              <a:t>Compliment, not Competition</a:t>
+            </a:r>
+          </a:p>
+        </p:txBody>
+      </p:sp>
+      <p:sp>
+        <p:nvSpPr>
+          <p:cNvPr id="3" name="Text Placeholder 2">
+            <a:extLst>
+              <a:ext uri="{FF2B5EF4-FFF2-40B4-BE49-F238E27FC236}">
+                <a16:creationId xmlns:a16="http://schemas.microsoft.com/office/drawing/2014/main" id="{796D21AF-CEEF-6F4B-7619-95C09F2FAB86}"/>
+              </a:ext>
+            </a:extLst>
+          </p:cNvPr>
+          <p:cNvSpPr>
+            <a:spLocks noGrp="1"/>
+          </p:cNvSpPr>
+          <p:nvPr>
+            <p:ph type="body" idx="1"/>
+          </p:nvPr>
+        </p:nvSpPr>
+        <p:spPr/>
+        <p:txBody>
+          <a:bodyPr>
+            <a:normAutofit/>
+          </a:bodyPr>
+          <a:lstStyle/>
+          <a:p>
+            <a:r>
+              <a:rPr lang="en-US" sz="2400" dirty="0"/>
+              <a:t>Trackr</a:t>
+            </a:r>
+          </a:p>
+        </p:txBody>
+      </p:sp>
+      <p:sp>
+        <p:nvSpPr>
+          <p:cNvPr id="4" name="Content Placeholder 3">
+            <a:extLst>
+              <a:ext uri="{FF2B5EF4-FFF2-40B4-BE49-F238E27FC236}">
+                <a16:creationId xmlns:a16="http://schemas.microsoft.com/office/drawing/2014/main" id="{681C0A33-C56B-784B-F8F4-8ABACB07474A}"/>
+              </a:ext>
+            </a:extLst>
+          </p:cNvPr>
+          <p:cNvSpPr>
+            <a:spLocks noGrp="1"/>
+          </p:cNvSpPr>
+          <p:nvPr>
+            <p:ph sz="quarter" idx="18"/>
+          </p:nvPr>
+        </p:nvSpPr>
+        <p:spPr/>
+        <p:txBody>
+          <a:bodyPr>
+            <a:normAutofit/>
+          </a:bodyPr>
+          <a:lstStyle/>
+          <a:p>
+            <a:pPr marL="285750" indent="-285750">
+              <a:buFont typeface="Arial" panose="020B0604020202020204" pitchFamily="34" charset="0"/>
+              <a:buChar char="•"/>
+            </a:pPr>
+            <a:r>
+              <a:rPr lang="en-US" sz="2000" dirty="0"/>
+              <a:t>Tracking what you want to watch next</a:t>
+            </a:r>
+          </a:p>
+          <a:p>
+            <a:pPr marL="285750" indent="-285750">
+              <a:buFont typeface="Arial" panose="020B0604020202020204" pitchFamily="34" charset="0"/>
+              <a:buChar char="•"/>
+            </a:pPr>
+            <a:r>
+              <a:rPr lang="en-US" sz="2000" dirty="0"/>
+              <a:t>Multiple media types</a:t>
+            </a:r>
+          </a:p>
+          <a:p>
+            <a:pPr marL="285750" indent="-285750">
+              <a:buFont typeface="Arial" panose="020B0604020202020204" pitchFamily="34" charset="0"/>
+              <a:buChar char="•"/>
+            </a:pPr>
+            <a:r>
+              <a:rPr lang="en-US" sz="2000" dirty="0"/>
+              <a:t>Notifications for new releases</a:t>
+            </a:r>
+          </a:p>
+          <a:p>
+            <a:pPr marL="285750" indent="-285750">
+              <a:buFont typeface="Arial" panose="020B0604020202020204" pitchFamily="34" charset="0"/>
+              <a:buChar char="•"/>
+            </a:pPr>
+            <a:r>
+              <a:rPr lang="en-US" sz="2000" dirty="0"/>
+              <a:t>Can be used alongside other social platforms</a:t>
+            </a:r>
+          </a:p>
+        </p:txBody>
+      </p:sp>
+      <p:sp>
+        <p:nvSpPr>
+          <p:cNvPr id="5" name="Text Placeholder 4">
+            <a:extLst>
+              <a:ext uri="{FF2B5EF4-FFF2-40B4-BE49-F238E27FC236}">
+                <a16:creationId xmlns:a16="http://schemas.microsoft.com/office/drawing/2014/main" id="{8E0D72AB-82DA-C189-C6DC-34D2A11436ED}"/>
+              </a:ext>
+            </a:extLst>
+          </p:cNvPr>
+          <p:cNvSpPr>
+            <a:spLocks noGrp="1"/>
+          </p:cNvSpPr>
+          <p:nvPr>
+            <p:ph type="body" sz="quarter" idx="3"/>
+          </p:nvPr>
+        </p:nvSpPr>
+        <p:spPr/>
+        <p:txBody>
+          <a:bodyPr>
+            <a:normAutofit/>
+          </a:bodyPr>
+          <a:lstStyle/>
+          <a:p>
+            <a:r>
+              <a:rPr lang="en-US" sz="2400" dirty="0"/>
+              <a:t>Letterboxd and Others</a:t>
+            </a:r>
+          </a:p>
+        </p:txBody>
+      </p:sp>
+      <p:sp>
+        <p:nvSpPr>
+          <p:cNvPr id="6" name="Content Placeholder 5">
+            <a:extLst>
+              <a:ext uri="{FF2B5EF4-FFF2-40B4-BE49-F238E27FC236}">
+                <a16:creationId xmlns:a16="http://schemas.microsoft.com/office/drawing/2014/main" id="{C4CD8094-A248-C70D-66FF-90A926945558}"/>
+              </a:ext>
+            </a:extLst>
+          </p:cNvPr>
+          <p:cNvSpPr>
+            <a:spLocks noGrp="1"/>
+          </p:cNvSpPr>
+          <p:nvPr>
+            <p:ph sz="quarter" idx="19"/>
+          </p:nvPr>
+        </p:nvSpPr>
+        <p:spPr/>
+        <p:txBody>
+          <a:bodyPr>
+            <a:normAutofit/>
+          </a:bodyPr>
+          <a:lstStyle/>
+          <a:p>
+            <a:pPr marL="285750" indent="-285750">
+              <a:buFont typeface="Arial" panose="020B0604020202020204" pitchFamily="34" charset="0"/>
+              <a:buChar char="•"/>
+            </a:pPr>
+            <a:r>
+              <a:rPr lang="en-US" sz="2000" dirty="0"/>
+              <a:t>Tracking what you’ve already watched</a:t>
+            </a:r>
+          </a:p>
+          <a:p>
+            <a:pPr marL="285750" indent="-285750">
+              <a:buFont typeface="Arial" panose="020B0604020202020204" pitchFamily="34" charset="0"/>
+              <a:buChar char="•"/>
+            </a:pPr>
+            <a:r>
+              <a:rPr lang="en-US" sz="2000" dirty="0"/>
+              <a:t>Focus on one media type</a:t>
+            </a:r>
+          </a:p>
+          <a:p>
+            <a:pPr marL="285750" indent="-285750">
+              <a:buFont typeface="Arial" panose="020B0604020202020204" pitchFamily="34" charset="0"/>
+              <a:buChar char="•"/>
+            </a:pPr>
+            <a:r>
+              <a:rPr lang="en-US" sz="2000" dirty="0"/>
+              <a:t>No way to track new releases</a:t>
+            </a:r>
+          </a:p>
+          <a:p>
+            <a:pPr marL="285750" indent="-285750">
+              <a:buFont typeface="Arial" panose="020B0604020202020204" pitchFamily="34" charset="0"/>
+              <a:buChar char="•"/>
+            </a:pPr>
+            <a:r>
+              <a:rPr lang="en-US" sz="2000" dirty="0"/>
+              <a:t>Media tracking as a social media</a:t>
+            </a:r>
+          </a:p>
+          <a:p>
+            <a:pPr marL="285750" indent="-285750">
+              <a:buFont typeface="Arial" panose="020B0604020202020204" pitchFamily="34" charset="0"/>
+              <a:buChar char="•"/>
+            </a:pPr>
+            <a:endParaRPr lang="en-US" sz="2000" dirty="0"/>
+          </a:p>
+        </p:txBody>
+      </p:sp>
     </p:spTree>
     <p:extLst>
       <p:ext uri="{BB962C8B-B14F-4D97-AF65-F5344CB8AC3E}">
-        <p14:creationId xmlns:p14="http://schemas.microsoft.com/office/powerpoint/2010/main" val="1433559613"/>
+        <p14:creationId xmlns:p14="http://schemas.microsoft.com/office/powerpoint/2010/main" val="2107956701"/>
       </p:ext>
     </p:extLst>
   </p:cSld>
@@ -16147,7 +17063,7 @@
           <p:cNvPr id="2" name="Title 1">
             <a:extLst>
               <a:ext uri="{FF2B5EF4-FFF2-40B4-BE49-F238E27FC236}">
-                <a16:creationId xmlns:a16="http://schemas.microsoft.com/office/drawing/2014/main" id="{250FBDB4-FBB3-5E4E-871F-18ADDC9305DF}"/>
+                <a16:creationId xmlns:a16="http://schemas.microsoft.com/office/drawing/2014/main" id="{55B010EC-0823-638A-A54B-085573D0CAFC}"/>
               </a:ext>
             </a:extLst>
           </p:cNvPr>
@@ -16158,292 +17074,60 @@
             <p:ph type="title"/>
           </p:nvPr>
         </p:nvSpPr>
-        <p:spPr/>
-        <p:txBody>
-          <a:bodyPr>
+        <p:spPr>
+          <a:xfrm>
+            <a:off x="301752" y="722282"/>
+            <a:ext cx="9830017" cy="731520"/>
+          </a:xfrm>
+        </p:spPr>
+        <p:txBody>
+          <a:bodyPr anchor="b">
             <a:normAutofit/>
           </a:bodyPr>
           <a:lstStyle/>
           <a:p>
             <a:r>
-              <a:rPr lang="en-US" sz="4400" dirty="0"/>
-              <a:t>Business Model</a:t>
-            </a:r>
-          </a:p>
-        </p:txBody>
-      </p:sp>
-      <p:sp>
-        <p:nvSpPr>
-          <p:cNvPr id="11" name="Text Placeholder 10">
-            <a:extLst>
-              <a:ext uri="{FF2B5EF4-FFF2-40B4-BE49-F238E27FC236}">
-                <a16:creationId xmlns:a16="http://schemas.microsoft.com/office/drawing/2014/main" id="{A866AA53-AF0F-D8E5-1920-897F46931FBE}"/>
-              </a:ext>
-            </a:extLst>
-          </p:cNvPr>
-          <p:cNvSpPr>
-            <a:spLocks noGrp="1"/>
-          </p:cNvSpPr>
-          <p:nvPr>
-            <p:ph type="body" idx="1"/>
-          </p:nvPr>
-        </p:nvSpPr>
-        <p:spPr/>
-        <p:txBody>
-          <a:bodyPr>
-            <a:normAutofit/>
-          </a:bodyPr>
-          <a:lstStyle/>
-          <a:p>
-            <a:r>
-              <a:rPr lang="en-US" sz="2800" dirty="0"/>
-              <a:t>Free Tier</a:t>
-            </a:r>
-          </a:p>
-        </p:txBody>
-      </p:sp>
-      <p:sp>
-        <p:nvSpPr>
-          <p:cNvPr id="13" name="Content Placeholder 12">
-            <a:extLst>
-              <a:ext uri="{FF2B5EF4-FFF2-40B4-BE49-F238E27FC236}">
-                <a16:creationId xmlns:a16="http://schemas.microsoft.com/office/drawing/2014/main" id="{EF4948EB-F8E8-F5D1-7C93-1CF2B021E895}"/>
-              </a:ext>
-            </a:extLst>
-          </p:cNvPr>
-          <p:cNvSpPr>
-            <a:spLocks noGrp="1"/>
-          </p:cNvSpPr>
-          <p:nvPr>
-            <p:ph sz="quarter" idx="18"/>
-          </p:nvPr>
-        </p:nvSpPr>
-        <p:spPr>
-          <a:xfrm>
-            <a:off x="301625" y="2587753"/>
-            <a:ext cx="5165725" cy="3805110"/>
-          </a:xfrm>
-        </p:spPr>
-        <p:txBody>
-          <a:bodyPr>
-            <a:normAutofit/>
-          </a:bodyPr>
-          <a:lstStyle/>
-          <a:p>
-            <a:pPr marL="285750" indent="-285750">
-              <a:buFont typeface="Arial" panose="020B0604020202020204" pitchFamily="34" charset="0"/>
-              <a:buChar char="•"/>
-            </a:pPr>
-            <a:r>
-              <a:rPr lang="en-US" sz="1800" dirty="0"/>
-              <a:t>Access to basic tracking features</a:t>
-            </a:r>
-          </a:p>
-          <a:p>
-            <a:pPr marL="285750" indent="-285750">
-              <a:buFont typeface="Arial" panose="020B0604020202020204" pitchFamily="34" charset="0"/>
-              <a:buChar char="•"/>
-            </a:pPr>
-            <a:r>
-              <a:rPr lang="en-US" sz="1800" dirty="0"/>
-              <a:t>Full discover page access to track any media items</a:t>
-            </a:r>
-          </a:p>
-          <a:p>
-            <a:pPr marL="285750" indent="-285750">
-              <a:buFont typeface="Arial" panose="020B0604020202020204" pitchFamily="34" charset="0"/>
-              <a:buChar char="•"/>
-            </a:pPr>
-            <a:r>
-              <a:rPr lang="en-US" sz="1800" dirty="0"/>
-              <a:t>Ability to view calendar page on site</a:t>
-            </a:r>
-          </a:p>
-        </p:txBody>
-      </p:sp>
-      <p:sp>
-        <p:nvSpPr>
-          <p:cNvPr id="12" name="Text Placeholder 11">
-            <a:extLst>
-              <a:ext uri="{FF2B5EF4-FFF2-40B4-BE49-F238E27FC236}">
-                <a16:creationId xmlns:a16="http://schemas.microsoft.com/office/drawing/2014/main" id="{19473856-1FC8-4BD6-73EB-6F08A1A9D4E1}"/>
-              </a:ext>
-            </a:extLst>
-          </p:cNvPr>
-          <p:cNvSpPr>
-            <a:spLocks noGrp="1"/>
-          </p:cNvSpPr>
-          <p:nvPr>
-            <p:ph type="body" sz="quarter" idx="3"/>
-          </p:nvPr>
-        </p:nvSpPr>
-        <p:spPr/>
-        <p:txBody>
-          <a:bodyPr>
-            <a:normAutofit/>
-          </a:bodyPr>
-          <a:lstStyle/>
-          <a:p>
-            <a:r>
-              <a:rPr lang="en-US" sz="2800" dirty="0"/>
-              <a:t>Paid Tier</a:t>
-            </a:r>
-          </a:p>
-        </p:txBody>
-      </p:sp>
-      <p:sp>
-        <p:nvSpPr>
-          <p:cNvPr id="14" name="Content Placeholder 13">
-            <a:extLst>
-              <a:ext uri="{FF2B5EF4-FFF2-40B4-BE49-F238E27FC236}">
-                <a16:creationId xmlns:a16="http://schemas.microsoft.com/office/drawing/2014/main" id="{05ACCA10-3A2B-F833-4ADC-9FD5871BB41B}"/>
-              </a:ext>
-            </a:extLst>
-          </p:cNvPr>
-          <p:cNvSpPr>
-            <a:spLocks noGrp="1"/>
-          </p:cNvSpPr>
-          <p:nvPr>
-            <p:ph sz="quarter" idx="19"/>
-          </p:nvPr>
-        </p:nvSpPr>
-        <p:spPr>
-          <a:xfrm>
-            <a:off x="6723890" y="2587753"/>
-            <a:ext cx="5181907" cy="3805110"/>
-          </a:xfrm>
-        </p:spPr>
-        <p:txBody>
-          <a:bodyPr>
-            <a:normAutofit/>
-          </a:bodyPr>
-          <a:lstStyle/>
-          <a:p>
-            <a:pPr marL="285750" indent="-285750">
-              <a:buFont typeface="Arial" panose="020B0604020202020204" pitchFamily="34" charset="0"/>
-              <a:buChar char="•"/>
-            </a:pPr>
-            <a:r>
-              <a:rPr lang="en-US" sz="1800" dirty="0"/>
-              <a:t>Access to all features</a:t>
-            </a:r>
-          </a:p>
-          <a:p>
-            <a:pPr marL="285750" indent="-285750">
-              <a:buFont typeface="Arial" panose="020B0604020202020204" pitchFamily="34" charset="0"/>
-              <a:buChar char="•"/>
-            </a:pPr>
-            <a:r>
-              <a:rPr lang="en-US" sz="1800" dirty="0"/>
-              <a:t>Customizable notifications for any media items</a:t>
-            </a:r>
-          </a:p>
-          <a:p>
-            <a:pPr marL="285750" indent="-285750">
-              <a:buFont typeface="Arial" panose="020B0604020202020204" pitchFamily="34" charset="0"/>
-              <a:buChar char="•"/>
-            </a:pPr>
-            <a:r>
-              <a:rPr lang="en-US" sz="1800" dirty="0"/>
-              <a:t>Ability to sync calendar with other apps like Apple, Google, Outlook, etc.</a:t>
-            </a:r>
-          </a:p>
-          <a:p>
-            <a:pPr marL="285750" indent="-285750">
-              <a:buFont typeface="Arial" panose="020B0604020202020204" pitchFamily="34" charset="0"/>
-              <a:buChar char="•"/>
-            </a:pPr>
-            <a:r>
-              <a:rPr lang="en-US" sz="1800" dirty="0"/>
-              <a:t>Access to the “Dugout” page</a:t>
-            </a:r>
-          </a:p>
-          <a:p>
-            <a:pPr marL="285750" indent="-285750">
-              <a:buFont typeface="Arial" panose="020B0604020202020204" pitchFamily="34" charset="0"/>
-              <a:buChar char="•"/>
-            </a:pPr>
-            <a:r>
-              <a:rPr lang="en-US" sz="1800" dirty="0"/>
-              <a:t>Profile customization</a:t>
-            </a:r>
-          </a:p>
-        </p:txBody>
-      </p:sp>
-      <p:sp>
-        <p:nvSpPr>
-          <p:cNvPr id="15" name="TextBox 14">
-            <a:extLst>
-              <a:ext uri="{FF2B5EF4-FFF2-40B4-BE49-F238E27FC236}">
-                <a16:creationId xmlns:a16="http://schemas.microsoft.com/office/drawing/2014/main" id="{59A8EB60-0D3B-F948-7917-2751D9B736FD}"/>
-              </a:ext>
-            </a:extLst>
-          </p:cNvPr>
-          <p:cNvSpPr txBox="1"/>
-          <p:nvPr/>
-        </p:nvSpPr>
-        <p:spPr>
-          <a:xfrm>
-            <a:off x="4142232" y="1864984"/>
-            <a:ext cx="2487168" cy="461665"/>
-          </a:xfrm>
-          <a:prstGeom prst="rect">
-            <a:avLst/>
-          </a:prstGeom>
-          <a:noFill/>
-        </p:spPr>
-        <p:txBody>
-          <a:bodyPr wrap="square" rtlCol="0">
-            <a:spAutoFit/>
-          </a:bodyPr>
-          <a:lstStyle/>
-          <a:p>
-            <a:r>
-              <a:rPr lang="en-US" sz="2400" dirty="0"/>
-              <a:t>$0/year</a:t>
-            </a:r>
-          </a:p>
-        </p:txBody>
-      </p:sp>
-      <p:sp>
-        <p:nvSpPr>
-          <p:cNvPr id="17" name="TextBox 16">
-            <a:extLst>
-              <a:ext uri="{FF2B5EF4-FFF2-40B4-BE49-F238E27FC236}">
-                <a16:creationId xmlns:a16="http://schemas.microsoft.com/office/drawing/2014/main" id="{3B6950EF-C8AA-BF60-72E3-39E7A7C70C0A}"/>
-              </a:ext>
-            </a:extLst>
-          </p:cNvPr>
-          <p:cNvSpPr txBox="1"/>
-          <p:nvPr/>
-        </p:nvSpPr>
-        <p:spPr>
-          <a:xfrm>
-            <a:off x="10469880" y="1836348"/>
-            <a:ext cx="2487168" cy="461665"/>
-          </a:xfrm>
-          <a:prstGeom prst="rect">
-            <a:avLst/>
-          </a:prstGeom>
-          <a:noFill/>
-        </p:spPr>
-        <p:txBody>
-          <a:bodyPr wrap="square" rtlCol="0">
-            <a:spAutoFit/>
-          </a:bodyPr>
-          <a:lstStyle/>
-          <a:p>
-            <a:r>
-              <a:rPr lang="en-US" sz="2400" dirty="0"/>
-              <a:t>$10/year</a:t>
-            </a:r>
-          </a:p>
-        </p:txBody>
-      </p:sp>
+              <a:rPr lang="en-US" sz="4000" dirty="0"/>
+              <a:t>Primary Features</a:t>
+            </a:r>
+          </a:p>
+        </p:txBody>
+      </p:sp>
+      <p:graphicFrame>
+        <p:nvGraphicFramePr>
+          <p:cNvPr id="5" name="Content Placeholder 2">
+            <a:extLst>
+              <a:ext uri="{FF2B5EF4-FFF2-40B4-BE49-F238E27FC236}">
+                <a16:creationId xmlns:a16="http://schemas.microsoft.com/office/drawing/2014/main" id="{3F1F8C0C-DC36-12BC-CB0E-02376481E29A}"/>
+              </a:ext>
+            </a:extLst>
+          </p:cNvPr>
+          <p:cNvGraphicFramePr>
+            <a:graphicFrameLocks noGrp="1"/>
+          </p:cNvGraphicFramePr>
+          <p:nvPr>
+            <p:ph sz="quarter" idx="13"/>
+            <p:extLst>
+              <p:ext uri="{D42A27DB-BD31-4B8C-83A1-F6EECF244321}">
+                <p14:modId xmlns:p14="http://schemas.microsoft.com/office/powerpoint/2010/main" val="3204616516"/>
+              </p:ext>
+            </p:extLst>
+          </p:nvPr>
+        </p:nvGraphicFramePr>
+        <p:xfrm>
+          <a:off x="301752" y="2011680"/>
+          <a:ext cx="11402568" cy="4389120"/>
+        </p:xfrm>
+        <a:graphic>
+          <a:graphicData uri="http://schemas.openxmlformats.org/drawingml/2006/diagram">
+            <dgm:relIds xmlns:dgm="http://schemas.openxmlformats.org/drawingml/2006/diagram" xmlns:r="http://schemas.openxmlformats.org/officeDocument/2006/relationships" r:dm="rId2" r:lo="rId3" r:qs="rId4" r:cs="rId5"/>
+          </a:graphicData>
+        </a:graphic>
+      </p:graphicFrame>
     </p:spTree>
     <p:extLst>
       <p:ext uri="{BB962C8B-B14F-4D97-AF65-F5344CB8AC3E}">
-        <p14:creationId xmlns:p14="http://schemas.microsoft.com/office/powerpoint/2010/main" val="2513515690"/>
+        <p14:creationId xmlns:p14="http://schemas.microsoft.com/office/powerpoint/2010/main" val="1433559613"/>
       </p:ext>
     </p:extLst>
   </p:cSld>
@@ -16475,7 +17159,7 @@
           <p:cNvPr id="2" name="Title 1">
             <a:extLst>
               <a:ext uri="{FF2B5EF4-FFF2-40B4-BE49-F238E27FC236}">
-                <a16:creationId xmlns:a16="http://schemas.microsoft.com/office/drawing/2014/main" id="{352DF2B7-2ACF-AE2F-49BB-9F647CDFA66F}"/>
+                <a16:creationId xmlns:a16="http://schemas.microsoft.com/office/drawing/2014/main" id="{250FBDB4-FBB3-5E4E-871F-18ADDC9305DF}"/>
               </a:ext>
             </a:extLst>
           </p:cNvPr>
@@ -16486,470 +17170,338 @@
             <p:ph type="title"/>
           </p:nvPr>
         </p:nvSpPr>
+        <p:spPr/>
+        <p:txBody>
+          <a:bodyPr>
+            <a:normAutofit/>
+          </a:bodyPr>
+          <a:lstStyle/>
+          <a:p>
+            <a:r>
+              <a:rPr lang="en-US" sz="4400" dirty="0"/>
+              <a:t>Business Model</a:t>
+            </a:r>
+          </a:p>
+        </p:txBody>
+      </p:sp>
+      <p:sp>
+        <p:nvSpPr>
+          <p:cNvPr id="11" name="Text Placeholder 10">
+            <a:extLst>
+              <a:ext uri="{FF2B5EF4-FFF2-40B4-BE49-F238E27FC236}">
+                <a16:creationId xmlns:a16="http://schemas.microsoft.com/office/drawing/2014/main" id="{A866AA53-AF0F-D8E5-1920-897F46931FBE}"/>
+              </a:ext>
+            </a:extLst>
+          </p:cNvPr>
+          <p:cNvSpPr>
+            <a:spLocks noGrp="1"/>
+          </p:cNvSpPr>
+          <p:nvPr>
+            <p:ph type="body" idx="1"/>
+          </p:nvPr>
+        </p:nvSpPr>
+        <p:spPr/>
+        <p:txBody>
+          <a:bodyPr>
+            <a:normAutofit/>
+          </a:bodyPr>
+          <a:lstStyle/>
+          <a:p>
+            <a:r>
+              <a:rPr lang="en-US" sz="2800" dirty="0"/>
+              <a:t>Free Tier</a:t>
+            </a:r>
+          </a:p>
+        </p:txBody>
+      </p:sp>
+      <p:sp>
+        <p:nvSpPr>
+          <p:cNvPr id="13" name="Content Placeholder 12">
+            <a:extLst>
+              <a:ext uri="{FF2B5EF4-FFF2-40B4-BE49-F238E27FC236}">
+                <a16:creationId xmlns:a16="http://schemas.microsoft.com/office/drawing/2014/main" id="{EF4948EB-F8E8-F5D1-7C93-1CF2B021E895}"/>
+              </a:ext>
+            </a:extLst>
+          </p:cNvPr>
+          <p:cNvSpPr>
+            <a:spLocks noGrp="1"/>
+          </p:cNvSpPr>
+          <p:nvPr>
+            <p:ph sz="quarter" idx="18"/>
+          </p:nvPr>
+        </p:nvSpPr>
         <p:spPr>
           <a:xfrm>
-            <a:off x="429767" y="1578102"/>
-            <a:ext cx="7498080" cy="1106424"/>
-          </a:xfrm>
-        </p:spPr>
-        <p:txBody>
-          <a:bodyPr/>
+            <a:off x="301625" y="2587753"/>
+            <a:ext cx="5165725" cy="3805110"/>
+          </a:xfrm>
+        </p:spPr>
+        <p:txBody>
+          <a:bodyPr>
+            <a:normAutofit/>
+          </a:bodyPr>
           <a:lstStyle/>
           <a:p>
-            <a:r>
-              <a:rPr lang="en-US" dirty="0"/>
-              <a:t>Roadmap</a:t>
-            </a:r>
-          </a:p>
-        </p:txBody>
-      </p:sp>
-      <p:sp>
-        <p:nvSpPr>
-          <p:cNvPr id="7" name="Rectangle 6">
-            <a:extLst>
-              <a:ext uri="{FF2B5EF4-FFF2-40B4-BE49-F238E27FC236}">
-                <a16:creationId xmlns:a16="http://schemas.microsoft.com/office/drawing/2014/main" id="{B5FB133F-2387-42F7-48F8-0ED78ED45F46}"/>
-              </a:ext>
-            </a:extLst>
-          </p:cNvPr>
-          <p:cNvSpPr/>
+            <a:pPr marL="285750" indent="-285750">
+              <a:buFont typeface="Arial" panose="020B0604020202020204" pitchFamily="34" charset="0"/>
+              <a:buChar char="•"/>
+            </a:pPr>
+            <a:r>
+              <a:rPr lang="en-US" sz="1800" dirty="0"/>
+              <a:t>Access to basic tracking features</a:t>
+            </a:r>
+          </a:p>
+          <a:p>
+            <a:pPr marL="285750" indent="-285750">
+              <a:buFont typeface="Arial" panose="020B0604020202020204" pitchFamily="34" charset="0"/>
+              <a:buChar char="•"/>
+            </a:pPr>
+            <a:r>
+              <a:rPr lang="en-US" sz="1800" dirty="0"/>
+              <a:t>Full discover page access to track any media items</a:t>
+            </a:r>
+          </a:p>
+          <a:p>
+            <a:pPr marL="285750" indent="-285750">
+              <a:buFont typeface="Arial" panose="020B0604020202020204" pitchFamily="34" charset="0"/>
+              <a:buChar char="•"/>
+            </a:pPr>
+            <a:r>
+              <a:rPr lang="en-US" sz="1800" dirty="0"/>
+              <a:t>Ability to view calendar page on site</a:t>
+            </a:r>
+          </a:p>
+        </p:txBody>
+      </p:sp>
+      <p:sp>
+        <p:nvSpPr>
+          <p:cNvPr id="12" name="Text Placeholder 11">
+            <a:extLst>
+              <a:ext uri="{FF2B5EF4-FFF2-40B4-BE49-F238E27FC236}">
+                <a16:creationId xmlns:a16="http://schemas.microsoft.com/office/drawing/2014/main" id="{19473856-1FC8-4BD6-73EB-6F08A1A9D4E1}"/>
+              </a:ext>
+            </a:extLst>
+          </p:cNvPr>
+          <p:cNvSpPr>
+            <a:spLocks noGrp="1"/>
+          </p:cNvSpPr>
+          <p:nvPr>
+            <p:ph type="body" sz="quarter" idx="3"/>
+          </p:nvPr>
+        </p:nvSpPr>
+        <p:spPr/>
+        <p:txBody>
+          <a:bodyPr>
+            <a:normAutofit/>
+          </a:bodyPr>
+          <a:lstStyle/>
+          <a:p>
+            <a:r>
+              <a:rPr lang="en-US" sz="2800" dirty="0"/>
+              <a:t>Paid Tier</a:t>
+            </a:r>
+          </a:p>
+        </p:txBody>
+      </p:sp>
+      <p:sp>
+        <p:nvSpPr>
+          <p:cNvPr id="14" name="Content Placeholder 13">
+            <a:extLst>
+              <a:ext uri="{FF2B5EF4-FFF2-40B4-BE49-F238E27FC236}">
+                <a16:creationId xmlns:a16="http://schemas.microsoft.com/office/drawing/2014/main" id="{05ACCA10-3A2B-F833-4ADC-9FD5871BB41B}"/>
+              </a:ext>
+            </a:extLst>
+          </p:cNvPr>
+          <p:cNvSpPr>
+            <a:spLocks noGrp="1"/>
+          </p:cNvSpPr>
+          <p:nvPr>
+            <p:ph sz="quarter" idx="19"/>
+          </p:nvPr>
+        </p:nvSpPr>
+        <p:spPr>
+          <a:xfrm>
+            <a:off x="6723890" y="2587753"/>
+            <a:ext cx="5181907" cy="3805110"/>
+          </a:xfrm>
+        </p:spPr>
+        <p:txBody>
+          <a:bodyPr>
+            <a:normAutofit/>
+          </a:bodyPr>
+          <a:lstStyle/>
+          <a:p>
+            <a:pPr marL="285750" indent="-285750">
+              <a:buFont typeface="Arial" panose="020B0604020202020204" pitchFamily="34" charset="0"/>
+              <a:buChar char="•"/>
+            </a:pPr>
+            <a:r>
+              <a:rPr lang="en-US" sz="1800" dirty="0"/>
+              <a:t>Access to all features</a:t>
+            </a:r>
+          </a:p>
+          <a:p>
+            <a:pPr marL="285750" indent="-285750">
+              <a:buFont typeface="Arial" panose="020B0604020202020204" pitchFamily="34" charset="0"/>
+              <a:buChar char="•"/>
+            </a:pPr>
+            <a:r>
+              <a:rPr lang="en-US" sz="1800" dirty="0"/>
+              <a:t>Customizable notifications for any media items</a:t>
+            </a:r>
+          </a:p>
+          <a:p>
+            <a:pPr marL="285750" indent="-285750">
+              <a:buFont typeface="Arial" panose="020B0604020202020204" pitchFamily="34" charset="0"/>
+              <a:buChar char="•"/>
+            </a:pPr>
+            <a:r>
+              <a:rPr lang="en-US" sz="1800" dirty="0"/>
+              <a:t>Ability to sync calendar with other apps like Apple, Google, Outlook, etc.</a:t>
+            </a:r>
+          </a:p>
+          <a:p>
+            <a:pPr marL="285750" indent="-285750">
+              <a:buFont typeface="Arial" panose="020B0604020202020204" pitchFamily="34" charset="0"/>
+              <a:buChar char="•"/>
+            </a:pPr>
+            <a:r>
+              <a:rPr lang="en-US" sz="1800" dirty="0"/>
+              <a:t>Access to the “Dugout” page</a:t>
+            </a:r>
+          </a:p>
+          <a:p>
+            <a:pPr marL="285750" indent="-285750">
+              <a:buFont typeface="Arial" panose="020B0604020202020204" pitchFamily="34" charset="0"/>
+              <a:buChar char="•"/>
+            </a:pPr>
+            <a:r>
+              <a:rPr lang="en-US" sz="1800" dirty="0"/>
+              <a:t>Profile customization</a:t>
+            </a:r>
+          </a:p>
+        </p:txBody>
+      </p:sp>
+      <p:sp>
+        <p:nvSpPr>
+          <p:cNvPr id="15" name="TextBox 14">
+            <a:extLst>
+              <a:ext uri="{FF2B5EF4-FFF2-40B4-BE49-F238E27FC236}">
+                <a16:creationId xmlns:a16="http://schemas.microsoft.com/office/drawing/2014/main" id="{59A8EB60-0D3B-F948-7917-2751D9B736FD}"/>
+              </a:ext>
+            </a:extLst>
+          </p:cNvPr>
+          <p:cNvSpPr txBox="1"/>
           <p:nvPr/>
         </p:nvSpPr>
         <p:spPr>
           <a:xfrm>
-            <a:off x="5772912" y="530352"/>
-            <a:ext cx="5736336" cy="1389888"/>
+            <a:off x="4142232" y="1864984"/>
+            <a:ext cx="2487168" cy="461665"/>
           </a:xfrm>
           <a:prstGeom prst="rect">
             <a:avLst/>
           </a:prstGeom>
           <a:noFill/>
+        </p:spPr>
+        <p:txBody>
+          <a:bodyPr wrap="square" rtlCol="0">
+            <a:spAutoFit/>
+          </a:bodyPr>
+          <a:lstStyle/>
+          <a:p>
+            <a:r>
+              <a:rPr lang="en-US" sz="2400" dirty="0"/>
+              <a:t>$0/year</a:t>
+            </a:r>
+          </a:p>
+        </p:txBody>
+      </p:sp>
+      <p:sp>
+        <p:nvSpPr>
+          <p:cNvPr id="17" name="TextBox 16">
+            <a:extLst>
+              <a:ext uri="{FF2B5EF4-FFF2-40B4-BE49-F238E27FC236}">
+                <a16:creationId xmlns:a16="http://schemas.microsoft.com/office/drawing/2014/main" id="{3B6950EF-C8AA-BF60-72E3-39E7A7C70C0A}"/>
+              </a:ext>
+            </a:extLst>
+          </p:cNvPr>
+          <p:cNvSpPr txBox="1"/>
+          <p:nvPr/>
+        </p:nvSpPr>
+        <p:spPr>
+          <a:xfrm>
+            <a:off x="10469880" y="1836348"/>
+            <a:ext cx="2487168" cy="461665"/>
+          </a:xfrm>
+          <a:prstGeom prst="rect">
+            <a:avLst/>
+          </a:prstGeom>
+          <a:noFill/>
+        </p:spPr>
+        <p:txBody>
+          <a:bodyPr wrap="square" rtlCol="0">
+            <a:spAutoFit/>
+          </a:bodyPr>
+          <a:lstStyle/>
+          <a:p>
+            <a:r>
+              <a:rPr lang="en-US" sz="2400" dirty="0"/>
+              <a:t>$10/year</a:t>
+            </a:r>
+          </a:p>
+        </p:txBody>
+      </p:sp>
+      <p:cxnSp>
+        <p:nvCxnSpPr>
+          <p:cNvPr id="4" name="Straight Connector 3">
+            <a:extLst>
+              <a:ext uri="{FF2B5EF4-FFF2-40B4-BE49-F238E27FC236}">
+                <a16:creationId xmlns:a16="http://schemas.microsoft.com/office/drawing/2014/main" id="{A1B7EF9B-DDCE-F1DD-FDE2-A14F9CF20216}"/>
+              </a:ext>
+            </a:extLst>
+          </p:cNvPr>
+          <p:cNvCxnSpPr>
+            <a:cxnSpLocks/>
+          </p:cNvCxnSpPr>
+          <p:nvPr/>
+        </p:nvCxnSpPr>
+        <p:spPr>
+          <a:xfrm>
+            <a:off x="6004560" y="1581912"/>
+            <a:ext cx="0" cy="4937760"/>
+          </a:xfrm>
+          <a:prstGeom prst="line">
+            <a:avLst/>
+          </a:prstGeom>
           <a:ln>
             <a:solidFill>
-              <a:schemeClr val="tx1"/>
+              <a:schemeClr val="bg1">
+                <a:lumMod val="75000"/>
+                <a:lumOff val="25000"/>
+              </a:schemeClr>
             </a:solidFill>
           </a:ln>
         </p:spPr>
         <p:style>
-          <a:lnRef idx="2">
-            <a:schemeClr val="accent1">
-              <a:shade val="15000"/>
-            </a:schemeClr>
+          <a:lnRef idx="1">
+            <a:schemeClr val="accent1"/>
           </a:lnRef>
-          <a:fillRef idx="1">
+          <a:fillRef idx="0">
             <a:schemeClr val="accent1"/>
           </a:fillRef>
           <a:effectRef idx="0">
             <a:schemeClr val="accent1"/>
           </a:effectRef>
           <a:fontRef idx="minor">
-            <a:schemeClr val="lt1"/>
+            <a:schemeClr val="tx1"/>
           </a:fontRef>
         </p:style>
-        <p:txBody>
-          <a:bodyPr rtlCol="0" anchor="ctr"/>
-          <a:lstStyle/>
-          <a:p>
-            <a:pPr marL="342900" indent="-342900">
-              <a:buFont typeface="Arial" panose="020B0604020202020204" pitchFamily="34" charset="0"/>
-              <a:buChar char="•"/>
-            </a:pPr>
-            <a:r>
-              <a:rPr lang="en-US" sz="2000" dirty="0"/>
-              <a:t>Finalize release date pipeline</a:t>
-            </a:r>
-          </a:p>
-          <a:p>
-            <a:pPr marL="342900" indent="-342900">
-              <a:buFont typeface="Arial" panose="020B0604020202020204" pitchFamily="34" charset="0"/>
-              <a:buChar char="•"/>
-            </a:pPr>
-            <a:r>
-              <a:rPr lang="en-US" sz="2000" dirty="0"/>
-              <a:t>App Store launch</a:t>
-            </a:r>
-          </a:p>
-          <a:p>
-            <a:pPr marL="342900" indent="-342900">
-              <a:buFont typeface="Arial" panose="020B0604020202020204" pitchFamily="34" charset="0"/>
-              <a:buChar char="•"/>
-            </a:pPr>
-            <a:r>
-              <a:rPr lang="en-US" sz="2000" dirty="0"/>
-              <a:t>Initial paid tier at $5/lifetime for early users</a:t>
-            </a:r>
-          </a:p>
-        </p:txBody>
-      </p:sp>
-      <p:sp>
-        <p:nvSpPr>
-          <p:cNvPr id="13" name="Rectangle 12">
-            <a:extLst>
-              <a:ext uri="{FF2B5EF4-FFF2-40B4-BE49-F238E27FC236}">
-                <a16:creationId xmlns:a16="http://schemas.microsoft.com/office/drawing/2014/main" id="{AD0E9EED-EB3F-446D-9BA6-D9B59BFD0B63}"/>
-              </a:ext>
-            </a:extLst>
-          </p:cNvPr>
-          <p:cNvSpPr/>
-          <p:nvPr/>
-        </p:nvSpPr>
-        <p:spPr>
-          <a:xfrm>
-            <a:off x="5772912" y="2484120"/>
-            <a:ext cx="5736336" cy="1106424"/>
-          </a:xfrm>
-          <a:prstGeom prst="rect">
-            <a:avLst/>
-          </a:prstGeom>
-          <a:noFill/>
-          <a:ln>
-            <a:solidFill>
-              <a:schemeClr val="tx1"/>
-            </a:solidFill>
-          </a:ln>
-        </p:spPr>
-        <p:style>
-          <a:lnRef idx="2">
-            <a:schemeClr val="accent1">
-              <a:shade val="15000"/>
-            </a:schemeClr>
-          </a:lnRef>
-          <a:fillRef idx="1">
-            <a:schemeClr val="accent1"/>
-          </a:fillRef>
-          <a:effectRef idx="0">
-            <a:schemeClr val="accent1"/>
-          </a:effectRef>
-          <a:fontRef idx="minor">
-            <a:schemeClr val="lt1"/>
-          </a:fontRef>
-        </p:style>
-        <p:txBody>
-          <a:bodyPr rtlCol="0" anchor="ctr"/>
-          <a:lstStyle/>
-          <a:p>
-            <a:pPr marL="342900" indent="-342900">
-              <a:buFont typeface="Arial" panose="020B0604020202020204" pitchFamily="34" charset="0"/>
-              <a:buChar char="•"/>
-            </a:pPr>
-            <a:r>
-              <a:rPr lang="en-US" sz="2000" dirty="0"/>
-              <a:t>Implement personalized recommendations</a:t>
-            </a:r>
-          </a:p>
-          <a:p>
-            <a:pPr marL="342900" indent="-342900">
-              <a:buFont typeface="Arial" panose="020B0604020202020204" pitchFamily="34" charset="0"/>
-              <a:buChar char="•"/>
-            </a:pPr>
-            <a:r>
-              <a:rPr lang="en-US" sz="2000" dirty="0"/>
-              <a:t>Expand media types (books, live events, etc.)</a:t>
-            </a:r>
-          </a:p>
-          <a:p>
-            <a:pPr marL="342900" indent="-342900">
-              <a:buFont typeface="Arial" panose="020B0604020202020204" pitchFamily="34" charset="0"/>
-              <a:buChar char="•"/>
-            </a:pPr>
-            <a:r>
-              <a:rPr lang="en-US" sz="2000" dirty="0"/>
-              <a:t>Strengthen infrastructure for larger userbase</a:t>
-            </a:r>
-          </a:p>
-        </p:txBody>
-      </p:sp>
-      <p:sp>
-        <p:nvSpPr>
-          <p:cNvPr id="15" name="Rectangle 14">
-            <a:extLst>
-              <a:ext uri="{FF2B5EF4-FFF2-40B4-BE49-F238E27FC236}">
-                <a16:creationId xmlns:a16="http://schemas.microsoft.com/office/drawing/2014/main" id="{996D8C91-388D-951A-647D-6A5FADBDA29F}"/>
-              </a:ext>
-            </a:extLst>
-          </p:cNvPr>
-          <p:cNvSpPr/>
-          <p:nvPr/>
-        </p:nvSpPr>
-        <p:spPr>
-          <a:xfrm>
-            <a:off x="5772912" y="4154424"/>
-            <a:ext cx="5736336" cy="1389888"/>
-          </a:xfrm>
-          <a:prstGeom prst="rect">
-            <a:avLst/>
-          </a:prstGeom>
-          <a:noFill/>
-          <a:ln>
-            <a:solidFill>
-              <a:schemeClr val="tx1"/>
-            </a:solidFill>
-          </a:ln>
-        </p:spPr>
-        <p:style>
-          <a:lnRef idx="2">
-            <a:schemeClr val="accent1">
-              <a:shade val="15000"/>
-            </a:schemeClr>
-          </a:lnRef>
-          <a:fillRef idx="1">
-            <a:schemeClr val="accent1"/>
-          </a:fillRef>
-          <a:effectRef idx="0">
-            <a:schemeClr val="accent1"/>
-          </a:effectRef>
-          <a:fontRef idx="minor">
-            <a:schemeClr val="lt1"/>
-          </a:fontRef>
-        </p:style>
-        <p:txBody>
-          <a:bodyPr rtlCol="0" anchor="ctr"/>
-          <a:lstStyle/>
-          <a:p>
-            <a:pPr marL="342900" indent="-342900">
-              <a:buFont typeface="Arial" panose="020B0604020202020204" pitchFamily="34" charset="0"/>
-              <a:buChar char="•"/>
-            </a:pPr>
-            <a:r>
-              <a:rPr lang="en-US" sz="2000" dirty="0"/>
-              <a:t>Seek out direct data partnerships</a:t>
-            </a:r>
-          </a:p>
-          <a:p>
-            <a:pPr marL="342900" indent="-342900">
-              <a:buFont typeface="Arial" panose="020B0604020202020204" pitchFamily="34" charset="0"/>
-              <a:buChar char="•"/>
-            </a:pPr>
-            <a:r>
-              <a:rPr lang="en-US" sz="2000" dirty="0"/>
-              <a:t>Embeddable release-calendar widget</a:t>
-            </a:r>
-          </a:p>
-          <a:p>
-            <a:pPr marL="342900" indent="-342900">
-              <a:buFont typeface="Arial" panose="020B0604020202020204" pitchFamily="34" charset="0"/>
-              <a:buChar char="•"/>
-            </a:pPr>
-            <a:r>
-              <a:rPr lang="en-US" sz="2000" dirty="0"/>
-              <a:t>Explore affiliate revenue for storefront links</a:t>
-            </a:r>
-          </a:p>
-        </p:txBody>
-      </p:sp>
-      <p:sp>
-        <p:nvSpPr>
-          <p:cNvPr id="16" name="TextBox 15">
-            <a:extLst>
-              <a:ext uri="{FF2B5EF4-FFF2-40B4-BE49-F238E27FC236}">
-                <a16:creationId xmlns:a16="http://schemas.microsoft.com/office/drawing/2014/main" id="{40C505AC-0223-C127-BF84-5DF94E10BB1A}"/>
-              </a:ext>
-            </a:extLst>
-          </p:cNvPr>
-          <p:cNvSpPr txBox="1"/>
-          <p:nvPr/>
-        </p:nvSpPr>
-        <p:spPr>
-          <a:xfrm>
-            <a:off x="4050791" y="976175"/>
-            <a:ext cx="2029968" cy="461665"/>
-          </a:xfrm>
-          <a:prstGeom prst="rect">
-            <a:avLst/>
-          </a:prstGeom>
-          <a:noFill/>
-        </p:spPr>
-        <p:txBody>
-          <a:bodyPr wrap="square" rtlCol="0">
-            <a:spAutoFit/>
-          </a:bodyPr>
-          <a:lstStyle/>
-          <a:p>
-            <a:r>
-              <a:rPr lang="en-US" sz="2400" dirty="0"/>
-              <a:t>Short-term</a:t>
-            </a:r>
-          </a:p>
-        </p:txBody>
-      </p:sp>
-      <p:sp>
-        <p:nvSpPr>
-          <p:cNvPr id="18" name="TextBox 17">
-            <a:extLst>
-              <a:ext uri="{FF2B5EF4-FFF2-40B4-BE49-F238E27FC236}">
-                <a16:creationId xmlns:a16="http://schemas.microsoft.com/office/drawing/2014/main" id="{1422B8CB-8630-6AC1-CFD5-CE5360763C35}"/>
-              </a:ext>
-            </a:extLst>
-          </p:cNvPr>
-          <p:cNvSpPr txBox="1"/>
-          <p:nvPr/>
-        </p:nvSpPr>
-        <p:spPr>
-          <a:xfrm>
-            <a:off x="4066032" y="2806499"/>
-            <a:ext cx="2029968" cy="461665"/>
-          </a:xfrm>
-          <a:prstGeom prst="rect">
-            <a:avLst/>
-          </a:prstGeom>
-          <a:noFill/>
-        </p:spPr>
-        <p:txBody>
-          <a:bodyPr wrap="square" rtlCol="0">
-            <a:spAutoFit/>
-          </a:bodyPr>
-          <a:lstStyle/>
-          <a:p>
-            <a:r>
-              <a:rPr lang="en-US" sz="2400" dirty="0"/>
-              <a:t>Mid-term</a:t>
-            </a:r>
-          </a:p>
-        </p:txBody>
-      </p:sp>
-      <p:sp>
-        <p:nvSpPr>
-          <p:cNvPr id="20" name="TextBox 19">
-            <a:extLst>
-              <a:ext uri="{FF2B5EF4-FFF2-40B4-BE49-F238E27FC236}">
-                <a16:creationId xmlns:a16="http://schemas.microsoft.com/office/drawing/2014/main" id="{4BE092C5-BB83-FB52-C83B-8B06D8DCB1E0}"/>
-              </a:ext>
-            </a:extLst>
-          </p:cNvPr>
-          <p:cNvSpPr txBox="1"/>
-          <p:nvPr/>
-        </p:nvSpPr>
-        <p:spPr>
-          <a:xfrm>
-            <a:off x="4066032" y="4618535"/>
-            <a:ext cx="2029968" cy="461665"/>
-          </a:xfrm>
-          <a:prstGeom prst="rect">
-            <a:avLst/>
-          </a:prstGeom>
-          <a:noFill/>
-        </p:spPr>
-        <p:txBody>
-          <a:bodyPr wrap="square" rtlCol="0">
-            <a:spAutoFit/>
-          </a:bodyPr>
-          <a:lstStyle/>
-          <a:p>
-            <a:r>
-              <a:rPr lang="en-US" sz="2400" dirty="0"/>
-              <a:t>Long-term</a:t>
-            </a:r>
-          </a:p>
-        </p:txBody>
-      </p:sp>
-      <p:sp>
-        <p:nvSpPr>
-          <p:cNvPr id="21" name="Arrow: Down 20">
-            <a:extLst>
-              <a:ext uri="{FF2B5EF4-FFF2-40B4-BE49-F238E27FC236}">
-                <a16:creationId xmlns:a16="http://schemas.microsoft.com/office/drawing/2014/main" id="{C8D94CF0-3024-70EB-0D2D-B61400EF13E3}"/>
-              </a:ext>
-            </a:extLst>
-          </p:cNvPr>
-          <p:cNvSpPr/>
-          <p:nvPr/>
-        </p:nvSpPr>
-        <p:spPr>
-          <a:xfrm>
-            <a:off x="8471916" y="2069592"/>
-            <a:ext cx="338328" cy="265176"/>
-          </a:xfrm>
-          <a:prstGeom prst="downArrow">
-            <a:avLst/>
-          </a:prstGeom>
-          <a:noFill/>
-          <a:ln>
-            <a:solidFill>
-              <a:schemeClr val="tx1"/>
-            </a:solidFill>
-          </a:ln>
-        </p:spPr>
-        <p:style>
-          <a:lnRef idx="2">
-            <a:schemeClr val="accent1">
-              <a:shade val="15000"/>
-            </a:schemeClr>
-          </a:lnRef>
-          <a:fillRef idx="1">
-            <a:schemeClr val="accent1"/>
-          </a:fillRef>
-          <a:effectRef idx="0">
-            <a:schemeClr val="accent1"/>
-          </a:effectRef>
-          <a:fontRef idx="minor">
-            <a:schemeClr val="lt1"/>
-          </a:fontRef>
-        </p:style>
-        <p:txBody>
-          <a:bodyPr rtlCol="0" anchor="ctr"/>
-          <a:lstStyle/>
-          <a:p>
-            <a:pPr algn="ctr"/>
-            <a:endParaRPr lang="en-US"/>
-          </a:p>
-        </p:txBody>
-      </p:sp>
-      <p:sp>
-        <p:nvSpPr>
-          <p:cNvPr id="23" name="Arrow: Down 22">
-            <a:extLst>
-              <a:ext uri="{FF2B5EF4-FFF2-40B4-BE49-F238E27FC236}">
-                <a16:creationId xmlns:a16="http://schemas.microsoft.com/office/drawing/2014/main" id="{6A00D220-69CD-BD2F-6C91-EB666C98C0AE}"/>
-              </a:ext>
-            </a:extLst>
-          </p:cNvPr>
-          <p:cNvSpPr/>
-          <p:nvPr/>
-        </p:nvSpPr>
-        <p:spPr>
-          <a:xfrm>
-            <a:off x="8471916" y="3742944"/>
-            <a:ext cx="338328" cy="265176"/>
-          </a:xfrm>
-          <a:prstGeom prst="downArrow">
-            <a:avLst/>
-          </a:prstGeom>
-          <a:noFill/>
-          <a:ln>
-            <a:solidFill>
-              <a:schemeClr val="tx1"/>
-            </a:solidFill>
-          </a:ln>
-        </p:spPr>
-        <p:style>
-          <a:lnRef idx="2">
-            <a:schemeClr val="accent1">
-              <a:shade val="15000"/>
-            </a:schemeClr>
-          </a:lnRef>
-          <a:fillRef idx="1">
-            <a:schemeClr val="accent1"/>
-          </a:fillRef>
-          <a:effectRef idx="0">
-            <a:schemeClr val="accent1"/>
-          </a:effectRef>
-          <a:fontRef idx="minor">
-            <a:schemeClr val="lt1"/>
-          </a:fontRef>
-        </p:style>
-        <p:txBody>
-          <a:bodyPr rtlCol="0" anchor="ctr"/>
-          <a:lstStyle/>
-          <a:p>
-            <a:pPr algn="ctr"/>
-            <a:endParaRPr lang="en-US"/>
-          </a:p>
-        </p:txBody>
-      </p:sp>
+      </p:cxnSp>
     </p:spTree>
     <p:extLst>
       <p:ext uri="{BB962C8B-B14F-4D97-AF65-F5344CB8AC3E}">
-        <p14:creationId xmlns:p14="http://schemas.microsoft.com/office/powerpoint/2010/main" val="3472879271"/>
+        <p14:creationId xmlns:p14="http://schemas.microsoft.com/office/powerpoint/2010/main" val="2513515690"/>
       </p:ext>
     </p:extLst>
   </p:cSld>
@@ -16978,10 +17530,10 @@
       </p:grpSpPr>
       <p:sp>
         <p:nvSpPr>
-          <p:cNvPr id="2" name="Title 1">
-            <a:extLst>
-              <a:ext uri="{FF2B5EF4-FFF2-40B4-BE49-F238E27FC236}">
-                <a16:creationId xmlns:a16="http://schemas.microsoft.com/office/drawing/2014/main" id="{82B3AAF7-AA83-C46C-5B40-3C886D2C17FC}"/>
+          <p:cNvPr id="4" name="Title 3">
+            <a:extLst>
+              <a:ext uri="{FF2B5EF4-FFF2-40B4-BE49-F238E27FC236}">
+                <a16:creationId xmlns:a16="http://schemas.microsoft.com/office/drawing/2014/main" id="{167571A2-A66C-9EDF-61D1-A2B4CCD85C83}"/>
               </a:ext>
             </a:extLst>
           </p:cNvPr>
@@ -16994,126 +17546,229 @@
         </p:nvSpPr>
         <p:spPr/>
         <p:txBody>
-          <a:bodyPr/>
+          <a:bodyPr>
+            <a:normAutofit/>
+          </a:bodyPr>
           <a:lstStyle/>
           <a:p>
             <a:r>
+              <a:rPr lang="en-US" sz="4400" dirty="0"/>
+              <a:t>Marketing</a:t>
+            </a:r>
+          </a:p>
+        </p:txBody>
+      </p:sp>
+      <p:sp>
+        <p:nvSpPr>
+          <p:cNvPr id="5" name="TextBox 4">
+            <a:extLst>
+              <a:ext uri="{FF2B5EF4-FFF2-40B4-BE49-F238E27FC236}">
+                <a16:creationId xmlns:a16="http://schemas.microsoft.com/office/drawing/2014/main" id="{8F1C5603-5FB7-2C8D-657E-8A7FA43C58B9}"/>
+              </a:ext>
+            </a:extLst>
+          </p:cNvPr>
+          <p:cNvSpPr txBox="1"/>
+          <p:nvPr/>
+        </p:nvSpPr>
+        <p:spPr>
+          <a:xfrm>
+            <a:off x="1408176" y="4853649"/>
+            <a:ext cx="1938528" cy="369332"/>
+          </a:xfrm>
+          <a:prstGeom prst="rect">
+            <a:avLst/>
+          </a:prstGeom>
+          <a:noFill/>
+        </p:spPr>
+        <p:txBody>
+          <a:bodyPr wrap="square" rtlCol="0">
+            <a:spAutoFit/>
+          </a:bodyPr>
+          <a:lstStyle/>
+          <a:p>
+            <a:r>
               <a:rPr lang="en-US" dirty="0"/>
-              <a:t>Sources</a:t>
-            </a:r>
-          </a:p>
-        </p:txBody>
-      </p:sp>
-      <p:sp>
-        <p:nvSpPr>
-          <p:cNvPr id="3" name="Content Placeholder 2">
-            <a:extLst>
-              <a:ext uri="{FF2B5EF4-FFF2-40B4-BE49-F238E27FC236}">
-                <a16:creationId xmlns:a16="http://schemas.microsoft.com/office/drawing/2014/main" id="{8CB2B0BC-F208-466E-ED95-76A6A98D0312}"/>
-              </a:ext>
-            </a:extLst>
-          </p:cNvPr>
-          <p:cNvSpPr>
-            <a:spLocks noGrp="1"/>
-          </p:cNvSpPr>
-          <p:nvPr>
-            <p:ph sz="quarter" idx="13"/>
-          </p:nvPr>
-        </p:nvSpPr>
-        <p:spPr/>
-        <p:txBody>
-          <a:bodyPr/>
+              <a:t>Friends &amp; Family</a:t>
+            </a:r>
+          </a:p>
+        </p:txBody>
+      </p:sp>
+      <p:sp>
+        <p:nvSpPr>
+          <p:cNvPr id="7" name="TextBox 6">
+            <a:extLst>
+              <a:ext uri="{FF2B5EF4-FFF2-40B4-BE49-F238E27FC236}">
+                <a16:creationId xmlns:a16="http://schemas.microsoft.com/office/drawing/2014/main" id="{12FCDF1A-9E15-70D1-25B9-D8BE5F79F3FE}"/>
+              </a:ext>
+            </a:extLst>
+          </p:cNvPr>
+          <p:cNvSpPr txBox="1"/>
+          <p:nvPr/>
+        </p:nvSpPr>
+        <p:spPr>
+          <a:xfrm>
+            <a:off x="5355336" y="4853649"/>
+            <a:ext cx="1938528" cy="369332"/>
+          </a:xfrm>
+          <a:prstGeom prst="rect">
+            <a:avLst/>
+          </a:prstGeom>
+          <a:noFill/>
+        </p:spPr>
+        <p:txBody>
+          <a:bodyPr wrap="square" rtlCol="0">
+            <a:spAutoFit/>
+          </a:bodyPr>
           <a:lstStyle/>
           <a:p>
-            <a:pPr marL="285750" indent="-285750">
-              <a:buFont typeface="Arial" panose="020B0604020202020204" pitchFamily="34" charset="0"/>
-              <a:buChar char="•"/>
-            </a:pPr>
-            <a:r>
-              <a:rPr lang="en-US" dirty="0">
-                <a:hlinkClick r:id="rId2"/>
-              </a:rPr>
-              <a:t>Streaming Media Survey: Viewers Can't Find What To Watch</a:t>
-            </a:r>
-            <a:endParaRPr lang="en-US" dirty="0"/>
-          </a:p>
-          <a:p>
-            <a:pPr marL="285750" indent="-285750">
-              <a:buFont typeface="Arial" panose="020B0604020202020204" pitchFamily="34" charset="0"/>
-              <a:buChar char="•"/>
-            </a:pPr>
-            <a:r>
-              <a:rPr lang="en-US" dirty="0">
-                <a:hlinkClick r:id="rId3"/>
-              </a:rPr>
-              <a:t>Streaming Fatigue Report 2026: How Price Hikes Are Changing the Way Americans Watch TV | Reviews.org</a:t>
-            </a:r>
-            <a:endParaRPr lang="en-US" dirty="0"/>
-          </a:p>
-          <a:p>
-            <a:pPr marL="285750" indent="-285750">
-              <a:buFont typeface="Arial" panose="020B0604020202020204" pitchFamily="34" charset="0"/>
-              <a:buChar char="•"/>
-            </a:pPr>
-            <a:r>
-              <a:rPr lang="en-US" dirty="0">
-                <a:hlinkClick r:id="rId4"/>
-              </a:rPr>
-              <a:t>Lights, Camera, Action— How Many Movies Are Released Daily Around the World? - System Ent Corp</a:t>
-            </a:r>
-            <a:endParaRPr lang="en-US" dirty="0"/>
-          </a:p>
-          <a:p>
-            <a:pPr marL="285750" indent="-285750">
-              <a:buFont typeface="Arial" panose="020B0604020202020204" pitchFamily="34" charset="0"/>
-              <a:buChar char="•"/>
-            </a:pPr>
-            <a:r>
-              <a:rPr lang="en-US" dirty="0">
-                <a:hlinkClick r:id="rId5"/>
-              </a:rPr>
-              <a:t>How Many Video Games Exist in Total? – </a:t>
-            </a:r>
-            <a:r>
-              <a:rPr lang="en-US" dirty="0" err="1">
-                <a:hlinkClick r:id="rId5"/>
-              </a:rPr>
-              <a:t>WorthyGamer</a:t>
-            </a:r>
-            <a:endParaRPr lang="en-US" dirty="0"/>
-          </a:p>
-          <a:p>
-            <a:pPr marL="285750" indent="-285750">
-              <a:buFont typeface="Arial" panose="020B0604020202020204" pitchFamily="34" charset="0"/>
-              <a:buChar char="•"/>
-            </a:pPr>
-            <a:r>
-              <a:rPr lang="en-US" dirty="0">
-                <a:hlinkClick r:id="rId6"/>
-              </a:rPr>
-              <a:t>Media Entertainment Industry Statistics 2026</a:t>
-            </a:r>
-            <a:endParaRPr lang="en-US" dirty="0"/>
-          </a:p>
-          <a:p>
-            <a:pPr marL="285750" indent="-285750">
-              <a:buFont typeface="Arial" panose="020B0604020202020204" pitchFamily="34" charset="0"/>
-              <a:buChar char="•"/>
-            </a:pPr>
-            <a:r>
-              <a:rPr lang="en-US" dirty="0">
-                <a:hlinkClick r:id="rId7"/>
-              </a:rPr>
-              <a:t>How Many Streaming Services Are There? Here's a List | Streaming Better</a:t>
-            </a:r>
-            <a:endParaRPr lang="en-US" dirty="0"/>
-          </a:p>
-        </p:txBody>
-      </p:sp>
+            <a:r>
+              <a:rPr lang="en-US" dirty="0"/>
+              <a:t>Online Forums</a:t>
+            </a:r>
+          </a:p>
+        </p:txBody>
+      </p:sp>
+      <p:sp>
+        <p:nvSpPr>
+          <p:cNvPr id="9" name="TextBox 8">
+            <a:extLst>
+              <a:ext uri="{FF2B5EF4-FFF2-40B4-BE49-F238E27FC236}">
+                <a16:creationId xmlns:a16="http://schemas.microsoft.com/office/drawing/2014/main" id="{F7773AEB-F7A8-C7CE-6DA2-204B097DB486}"/>
+              </a:ext>
+            </a:extLst>
+          </p:cNvPr>
+          <p:cNvSpPr txBox="1"/>
+          <p:nvPr/>
+        </p:nvSpPr>
+        <p:spPr>
+          <a:xfrm>
+            <a:off x="9302496" y="4853649"/>
+            <a:ext cx="1938528" cy="369332"/>
+          </a:xfrm>
+          <a:prstGeom prst="rect">
+            <a:avLst/>
+          </a:prstGeom>
+          <a:noFill/>
+        </p:spPr>
+        <p:txBody>
+          <a:bodyPr wrap="square" rtlCol="0">
+            <a:spAutoFit/>
+          </a:bodyPr>
+          <a:lstStyle/>
+          <a:p>
+            <a:r>
+              <a:rPr lang="en-US" dirty="0"/>
+              <a:t>Word-of-Mouth</a:t>
+            </a:r>
+          </a:p>
+        </p:txBody>
+      </p:sp>
+      <p:pic>
+        <p:nvPicPr>
+          <p:cNvPr id="18" name="Picture 17">
+            <a:extLst>
+              <a:ext uri="{FF2B5EF4-FFF2-40B4-BE49-F238E27FC236}">
+                <a16:creationId xmlns:a16="http://schemas.microsoft.com/office/drawing/2014/main" id="{6610CC0C-76BA-7223-BD71-71650F57D154}"/>
+              </a:ext>
+            </a:extLst>
+          </p:cNvPr>
+          <p:cNvPicPr>
+            <a:picLocks noChangeAspect="1"/>
+          </p:cNvPicPr>
+          <p:nvPr/>
+        </p:nvPicPr>
+        <p:blipFill>
+          <a:blip r:embed="rId3">
+            <a:extLst>
+              <a:ext uri="{28A0092B-C50C-407E-A947-70E740481C1C}">
+                <a14:useLocalDpi xmlns:a14="http://schemas.microsoft.com/office/drawing/2010/main" val="0"/>
+              </a:ext>
+            </a:extLst>
+          </a:blip>
+          <a:stretch>
+            <a:fillRect/>
+          </a:stretch>
+        </p:blipFill>
+        <p:spPr>
+          <a:xfrm>
+            <a:off x="5114925" y="2155216"/>
+            <a:ext cx="1962150" cy="2886075"/>
+          </a:xfrm>
+          <a:prstGeom prst="rect">
+            <a:avLst/>
+          </a:prstGeom>
+        </p:spPr>
+      </p:pic>
+      <p:pic>
+        <p:nvPicPr>
+          <p:cNvPr id="19" name="Picture 18" descr="People Communicate PNGs for Free Download">
+            <a:extLst>
+              <a:ext uri="{FF2B5EF4-FFF2-40B4-BE49-F238E27FC236}">
+                <a16:creationId xmlns:a16="http://schemas.microsoft.com/office/drawing/2014/main" id="{1AAB4446-8B17-0DC6-7012-AED45FF4EC12}"/>
+              </a:ext>
+            </a:extLst>
+          </p:cNvPr>
+          <p:cNvPicPr>
+            <a:picLocks noChangeAspect="1"/>
+          </p:cNvPicPr>
+          <p:nvPr/>
+        </p:nvPicPr>
+        <p:blipFill>
+          <a:blip r:embed="rId4"/>
+          <a:stretch>
+            <a:fillRect/>
+          </a:stretch>
+        </p:blipFill>
+        <p:spPr>
+          <a:xfrm>
+            <a:off x="8439341" y="1770306"/>
+            <a:ext cx="3333750" cy="3333750"/>
+          </a:xfrm>
+          <a:prstGeom prst="rect">
+            <a:avLst/>
+          </a:prstGeom>
+        </p:spPr>
+      </p:pic>
+      <p:pic>
+        <p:nvPicPr>
+          <p:cNvPr id="21" name="Picture 20">
+            <a:extLst>
+              <a:ext uri="{FF2B5EF4-FFF2-40B4-BE49-F238E27FC236}">
+                <a16:creationId xmlns:a16="http://schemas.microsoft.com/office/drawing/2014/main" id="{B8B5E8D5-AD94-4542-07BA-50B4C0D52015}"/>
+              </a:ext>
+            </a:extLst>
+          </p:cNvPr>
+          <p:cNvPicPr>
+            <a:picLocks noChangeAspect="1"/>
+          </p:cNvPicPr>
+          <p:nvPr/>
+        </p:nvPicPr>
+        <p:blipFill>
+          <a:blip r:embed="rId5">
+            <a:extLst>
+              <a:ext uri="{28A0092B-C50C-407E-A947-70E740481C1C}">
+                <a14:useLocalDpi xmlns:a14="http://schemas.microsoft.com/office/drawing/2010/main" val="0"/>
+              </a:ext>
+            </a:extLst>
+          </a:blip>
+          <a:stretch>
+            <a:fillRect/>
+          </a:stretch>
+        </p:blipFill>
+        <p:spPr>
+          <a:xfrm>
+            <a:off x="418909" y="1847885"/>
+            <a:ext cx="3579114" cy="3579114"/>
+          </a:xfrm>
+          <a:prstGeom prst="rect">
+            <a:avLst/>
+          </a:prstGeom>
+        </p:spPr>
+      </p:pic>
     </p:spTree>
     <p:extLst>
       <p:ext uri="{BB962C8B-B14F-4D97-AF65-F5344CB8AC3E}">
-        <p14:creationId xmlns:p14="http://schemas.microsoft.com/office/powerpoint/2010/main" val="2992196600"/>
+        <p14:creationId xmlns:p14="http://schemas.microsoft.com/office/powerpoint/2010/main" val="3560780786"/>
       </p:ext>
     </p:extLst>
   </p:cSld>

</xml_diff>